<commit_message>
Standardize figure export to journal double-column (170mm) physical size, base_size=9
Root cause: base_size was fixed (12pt) but export canvas width varied across
figures (8-12in). Inserting figures into Word at a uniform column width then
scales each canvas by a different factor, so on-page font size ends up
inconsistent across figures even though the R-side base_size was the same.

Fix: base_size reduced to 9pt (journal-typical 7-10pt range) and every figure
(Fig.1-4, S1-S3) now exports at a fixed 170mm width (AoB double-column),
height scaled to preserve each figure's existing aspect ratio. PPTX exports
via eoffice::topptx() updated to the same physical dimensions (inches).
Figures should now be inserted into Word/PDF at 100% scale, not resized.
</commit_message>
<xml_diff>
--- a/figures/Figure_4.pptx
+++ b/figures/Figure_4.pptx
@@ -2250,9 +2250,9 @@
         <p:grpSpPr>
           <a:xfrm>
             <a:off x="914400" y="914400"/>
-            <a:ext cx="5486400" cy="4572000"/>
+            <a:ext cx="6120000" cy="5112000"/>
             <a:chOff x="914400" y="914400"/>
-            <a:chExt cx="5486400" cy="4572000"/>
+            <a:chExt cx="6120000" cy="5112000"/>
           </a:xfrm>
         </p:grpSpPr>
         <p:sp>
@@ -2264,7 +2264,7 @@
           <p:spPr>
             <a:xfrm>
               <a:off x="914400" y="914400"/>
-              <a:ext cx="5486400" cy="4572000"/>
+              <a:ext cx="6120000" cy="5112000"/>
             </a:xfrm>
             <a:prstGeom prst="rect">
               <a:avLst/>
@@ -2299,7 +2299,7 @@
           <p:spPr>
             <a:xfrm>
               <a:off x="914400" y="914400"/>
-              <a:ext cx="5486400" cy="4572000"/>
+              <a:ext cx="6120000" cy="5112000"/>
             </a:xfrm>
             <a:prstGeom prst="rect">
               <a:avLst/>
@@ -2324,8 +2324,8 @@
           </p:nvSpPr>
           <p:spPr>
             <a:xfrm>
-              <a:off x="2101731" y="1274400"/>
-              <a:ext cx="4119068" cy="3344394"/>
+              <a:off x="1835953" y="1274399"/>
+              <a:ext cx="5018446" cy="4055440"/>
             </a:xfrm>
             <a:prstGeom prst="rect">
               <a:avLst/>
@@ -2350,15 +2350,15 @@
           </p:nvSpPr>
           <p:spPr>
             <a:xfrm>
-              <a:off x="4203848" y="1274400"/>
-              <a:ext cx="0" cy="3344394"/>
+              <a:off x="4397058" y="1274399"/>
+              <a:ext cx="0" cy="4055440"/>
             </a:xfrm>
             <a:custGeom>
               <a:avLst/>
               <a:pathLst>
-                <a:path w="0" h="3344394">
+                <a:path w="0" h="4055440">
                   <a:moveTo>
-                    <a:pt x="0" y="3344394"/>
+                    <a:pt x="0" y="4055440"/>
                   </a:moveTo>
                   <a:lnTo>
                     <a:pt x="0" y="0"/>
@@ -2393,15 +2393,15 @@
           </p:nvSpPr>
           <p:spPr>
             <a:xfrm>
-              <a:off x="3950843" y="1384412"/>
-              <a:ext cx="0" cy="44005"/>
+              <a:off x="4088810" y="1407802"/>
+              <a:ext cx="0" cy="53361"/>
             </a:xfrm>
             <a:custGeom>
               <a:avLst/>
               <a:pathLst>
-                <a:path w="0" h="44005">
+                <a:path w="0" h="53361">
                   <a:moveTo>
-                    <a:pt x="0" y="44005"/>
+                    <a:pt x="0" y="53361"/>
                   </a:moveTo>
                   <a:lnTo>
                     <a:pt x="0" y="0"/>
@@ -2433,15 +2433,15 @@
           </p:nvSpPr>
           <p:spPr>
             <a:xfrm>
-              <a:off x="3617331" y="1406415"/>
-              <a:ext cx="333511" cy="0"/>
+              <a:off x="3682478" y="1434483"/>
+              <a:ext cx="406332" cy="0"/>
             </a:xfrm>
             <a:custGeom>
               <a:avLst/>
               <a:pathLst>
-                <a:path w="333511" h="0">
+                <a:path w="406332" h="0">
                   <a:moveTo>
-                    <a:pt x="333511" y="0"/>
+                    <a:pt x="406332" y="0"/>
                   </a:moveTo>
                   <a:lnTo>
                     <a:pt x="0" y="0"/>
@@ -2473,15 +2473,15 @@
           </p:nvSpPr>
           <p:spPr>
             <a:xfrm>
-              <a:off x="3617331" y="1384412"/>
-              <a:ext cx="0" cy="44005"/>
+              <a:off x="3682478" y="1407802"/>
+              <a:ext cx="0" cy="53361"/>
             </a:xfrm>
             <a:custGeom>
               <a:avLst/>
               <a:pathLst>
-                <a:path w="0" h="44005">
+                <a:path w="0" h="53361">
                   <a:moveTo>
-                    <a:pt x="0" y="44005"/>
+                    <a:pt x="0" y="53361"/>
                   </a:moveTo>
                   <a:lnTo>
                     <a:pt x="0" y="0"/>
@@ -2513,15 +2513,15 @@
           </p:nvSpPr>
           <p:spPr>
             <a:xfrm>
-              <a:off x="5870882" y="1604438"/>
-              <a:ext cx="0" cy="44005"/>
+              <a:off x="6428080" y="1674607"/>
+              <a:ext cx="0" cy="53361"/>
             </a:xfrm>
             <a:custGeom>
               <a:avLst/>
               <a:pathLst>
-                <a:path w="0" h="44005">
+                <a:path w="0" h="53361">
                   <a:moveTo>
-                    <a:pt x="0" y="44005"/>
+                    <a:pt x="0" y="53361"/>
                   </a:moveTo>
                   <a:lnTo>
                     <a:pt x="0" y="0"/>
@@ -2553,15 +2553,15 @@
           </p:nvSpPr>
           <p:spPr>
             <a:xfrm>
-              <a:off x="4410748" y="1626441"/>
-              <a:ext cx="1460134" cy="0"/>
+              <a:off x="4649133" y="1701288"/>
+              <a:ext cx="1778946" cy="0"/>
             </a:xfrm>
             <a:custGeom>
               <a:avLst/>
               <a:pathLst>
-                <a:path w="1460134" h="0">
+                <a:path w="1778946" h="0">
                   <a:moveTo>
-                    <a:pt x="1460134" y="0"/>
+                    <a:pt x="1778946" y="0"/>
                   </a:moveTo>
                   <a:lnTo>
                     <a:pt x="0" y="0"/>
@@ -2593,15 +2593,15 @@
           </p:nvSpPr>
           <p:spPr>
             <a:xfrm>
-              <a:off x="4410748" y="1604438"/>
-              <a:ext cx="0" cy="44005"/>
+              <a:off x="4649133" y="1674607"/>
+              <a:ext cx="0" cy="53361"/>
             </a:xfrm>
             <a:custGeom>
               <a:avLst/>
               <a:pathLst>
-                <a:path w="0" h="44005">
+                <a:path w="0" h="53361">
                   <a:moveTo>
-                    <a:pt x="0" y="44005"/>
+                    <a:pt x="0" y="53361"/>
                   </a:moveTo>
                   <a:lnTo>
                     <a:pt x="0" y="0"/>
@@ -2633,15 +2633,15 @@
           </p:nvSpPr>
           <p:spPr>
             <a:xfrm>
-              <a:off x="5985378" y="1824464"/>
-              <a:ext cx="0" cy="44005"/>
+              <a:off x="6567575" y="1941413"/>
+              <a:ext cx="0" cy="53361"/>
             </a:xfrm>
             <a:custGeom>
               <a:avLst/>
               <a:pathLst>
-                <a:path w="0" h="44005">
+                <a:path w="0" h="53361">
                   <a:moveTo>
-                    <a:pt x="0" y="44005"/>
+                    <a:pt x="0" y="53361"/>
                   </a:moveTo>
                   <a:lnTo>
                     <a:pt x="0" y="0"/>
@@ -2673,15 +2673,15 @@
           </p:nvSpPr>
           <p:spPr>
             <a:xfrm>
-              <a:off x="4567434" y="1846467"/>
-              <a:ext cx="1417943" cy="0"/>
+              <a:off x="4840030" y="1968093"/>
+              <a:ext cx="1727544" cy="0"/>
             </a:xfrm>
             <a:custGeom>
               <a:avLst/>
               <a:pathLst>
-                <a:path w="1417943" h="0">
+                <a:path w="1727544" h="0">
                   <a:moveTo>
-                    <a:pt x="1417943" y="0"/>
+                    <a:pt x="1727544" y="0"/>
                   </a:moveTo>
                   <a:lnTo>
                     <a:pt x="0" y="0"/>
@@ -2713,15 +2713,15 @@
           </p:nvSpPr>
           <p:spPr>
             <a:xfrm>
-              <a:off x="4567434" y="1824464"/>
-              <a:ext cx="0" cy="44005"/>
+              <a:off x="4840030" y="1941413"/>
+              <a:ext cx="0" cy="53361"/>
             </a:xfrm>
             <a:custGeom>
               <a:avLst/>
               <a:pathLst>
-                <a:path w="0" h="44005">
+                <a:path w="0" h="53361">
                   <a:moveTo>
-                    <a:pt x="0" y="44005"/>
+                    <a:pt x="0" y="53361"/>
                   </a:moveTo>
                   <a:lnTo>
                     <a:pt x="0" y="0"/>
@@ -2753,15 +2753,15 @@
           </p:nvSpPr>
           <p:spPr>
             <a:xfrm>
-              <a:off x="4167609" y="2044490"/>
-              <a:ext cx="0" cy="44005"/>
+              <a:off x="4352906" y="2208218"/>
+              <a:ext cx="0" cy="53361"/>
             </a:xfrm>
             <a:custGeom>
               <a:avLst/>
               <a:pathLst>
-                <a:path w="0" h="44005">
+                <a:path w="0" h="53361">
                   <a:moveTo>
-                    <a:pt x="0" y="44005"/>
+                    <a:pt x="0" y="53361"/>
                   </a:moveTo>
                   <a:lnTo>
                     <a:pt x="0" y="0"/>
@@ -2793,15 +2793,15 @@
           </p:nvSpPr>
           <p:spPr>
             <a:xfrm>
-              <a:off x="3401218" y="2066493"/>
-              <a:ext cx="766391" cy="0"/>
+              <a:off x="3419177" y="2234899"/>
+              <a:ext cx="933729" cy="0"/>
             </a:xfrm>
             <a:custGeom>
               <a:avLst/>
               <a:pathLst>
-                <a:path w="766391" h="0">
+                <a:path w="933729" h="0">
                   <a:moveTo>
-                    <a:pt x="766391" y="0"/>
+                    <a:pt x="933729" y="0"/>
                   </a:moveTo>
                   <a:lnTo>
                     <a:pt x="0" y="0"/>
@@ -2833,15 +2833,15 @@
           </p:nvSpPr>
           <p:spPr>
             <a:xfrm>
-              <a:off x="3401218" y="2044490"/>
-              <a:ext cx="0" cy="44005"/>
+              <a:off x="3419177" y="2208218"/>
+              <a:ext cx="0" cy="53361"/>
             </a:xfrm>
             <a:custGeom>
               <a:avLst/>
               <a:pathLst>
-                <a:path w="0" h="44005">
+                <a:path w="0" h="53361">
                   <a:moveTo>
-                    <a:pt x="0" y="44005"/>
+                    <a:pt x="0" y="53361"/>
                   </a:moveTo>
                   <a:lnTo>
                     <a:pt x="0" y="0"/>
@@ -2873,15 +2873,15 @@
           </p:nvSpPr>
           <p:spPr>
             <a:xfrm>
-              <a:off x="3657878" y="2264516"/>
-              <a:ext cx="0" cy="44005"/>
+              <a:off x="3731877" y="2475023"/>
+              <a:ext cx="0" cy="53361"/>
             </a:xfrm>
             <a:custGeom>
               <a:avLst/>
               <a:pathLst>
-                <a:path w="0" h="44005">
+                <a:path w="0" h="53361">
                   <a:moveTo>
-                    <a:pt x="0" y="44005"/>
+                    <a:pt x="0" y="53361"/>
                   </a:moveTo>
                   <a:lnTo>
                     <a:pt x="0" y="0"/>
@@ -2913,15 +2913,15 @@
           </p:nvSpPr>
           <p:spPr>
             <a:xfrm>
-              <a:off x="2288961" y="2286519"/>
-              <a:ext cx="1368916" cy="0"/>
+              <a:off x="2064064" y="2501704"/>
+              <a:ext cx="1667812" cy="0"/>
             </a:xfrm>
             <a:custGeom>
               <a:avLst/>
               <a:pathLst>
-                <a:path w="1368916" h="0">
+                <a:path w="1667812" h="0">
                   <a:moveTo>
-                    <a:pt x="1368916" y="0"/>
+                    <a:pt x="1667812" y="0"/>
                   </a:moveTo>
                   <a:lnTo>
                     <a:pt x="0" y="0"/>
@@ -2953,15 +2953,15 @@
           </p:nvSpPr>
           <p:spPr>
             <a:xfrm>
-              <a:off x="2288961" y="2264516"/>
-              <a:ext cx="0" cy="44005"/>
+              <a:off x="2064064" y="2475023"/>
+              <a:ext cx="0" cy="53361"/>
             </a:xfrm>
             <a:custGeom>
               <a:avLst/>
               <a:pathLst>
-                <a:path w="0" h="44005">
+                <a:path w="0" h="53361">
                   <a:moveTo>
-                    <a:pt x="0" y="44005"/>
+                    <a:pt x="0" y="53361"/>
                   </a:moveTo>
                   <a:lnTo>
                     <a:pt x="0" y="0"/>
@@ -2993,15 +2993,15 @@
           </p:nvSpPr>
           <p:spPr>
             <a:xfrm>
-              <a:off x="5423788" y="2484542"/>
-              <a:ext cx="0" cy="44005"/>
+              <a:off x="5883365" y="2741829"/>
+              <a:ext cx="0" cy="53361"/>
             </a:xfrm>
             <a:custGeom>
               <a:avLst/>
               <a:pathLst>
-                <a:path w="0" h="44005">
+                <a:path w="0" h="53361">
                   <a:moveTo>
-                    <a:pt x="0" y="44005"/>
+                    <a:pt x="0" y="53361"/>
                   </a:moveTo>
                   <a:lnTo>
                     <a:pt x="0" y="0"/>
@@ -3033,15 +3033,15 @@
           </p:nvSpPr>
           <p:spPr>
             <a:xfrm>
-              <a:off x="3745313" y="2506545"/>
-              <a:ext cx="1678474" cy="0"/>
+              <a:off x="3838404" y="2768509"/>
+              <a:ext cx="2044961" cy="0"/>
             </a:xfrm>
             <a:custGeom>
               <a:avLst/>
               <a:pathLst>
-                <a:path w="1678474" h="0">
+                <a:path w="2044961" h="0">
                   <a:moveTo>
-                    <a:pt x="1678474" y="0"/>
+                    <a:pt x="2044961" y="0"/>
                   </a:moveTo>
                   <a:lnTo>
                     <a:pt x="0" y="0"/>
@@ -3073,15 +3073,15 @@
           </p:nvSpPr>
           <p:spPr>
             <a:xfrm>
-              <a:off x="3745313" y="2484542"/>
-              <a:ext cx="0" cy="44005"/>
+              <a:off x="3838404" y="2741829"/>
+              <a:ext cx="0" cy="53361"/>
             </a:xfrm>
             <a:custGeom>
               <a:avLst/>
               <a:pathLst>
-                <a:path w="0" h="44005">
+                <a:path w="0" h="53361">
                   <a:moveTo>
-                    <a:pt x="0" y="44005"/>
+                    <a:pt x="0" y="53361"/>
                   </a:moveTo>
                   <a:lnTo>
                     <a:pt x="0" y="0"/>
@@ -3113,15 +3113,15 @@
           </p:nvSpPr>
           <p:spPr>
             <a:xfrm>
-              <a:off x="4586745" y="2704568"/>
-              <a:ext cx="0" cy="44005"/>
+              <a:off x="4863558" y="3008634"/>
+              <a:ext cx="0" cy="53361"/>
             </a:xfrm>
             <a:custGeom>
               <a:avLst/>
               <a:pathLst>
-                <a:path w="0" h="44005">
+                <a:path w="0" h="53361">
                   <a:moveTo>
-                    <a:pt x="0" y="44005"/>
+                    <a:pt x="0" y="53361"/>
                   </a:moveTo>
                   <a:lnTo>
                     <a:pt x="0" y="0"/>
@@ -3153,15 +3153,15 @@
           </p:nvSpPr>
           <p:spPr>
             <a:xfrm>
-              <a:off x="4105046" y="2726571"/>
-              <a:ext cx="481699" cy="0"/>
+              <a:off x="4276682" y="3035314"/>
+              <a:ext cx="586875" cy="0"/>
             </a:xfrm>
             <a:custGeom>
               <a:avLst/>
               <a:pathLst>
-                <a:path w="481699" h="0">
+                <a:path w="586875" h="0">
                   <a:moveTo>
-                    <a:pt x="481699" y="0"/>
+                    <a:pt x="586875" y="0"/>
                   </a:moveTo>
                   <a:lnTo>
                     <a:pt x="0" y="0"/>
@@ -3193,15 +3193,15 @@
           </p:nvSpPr>
           <p:spPr>
             <a:xfrm>
-              <a:off x="4105046" y="2704568"/>
-              <a:ext cx="0" cy="44005"/>
+              <a:off x="4276682" y="3008634"/>
+              <a:ext cx="0" cy="53361"/>
             </a:xfrm>
             <a:custGeom>
               <a:avLst/>
               <a:pathLst>
-                <a:path w="0" h="44005">
+                <a:path w="0" h="53361">
                   <a:moveTo>
-                    <a:pt x="0" y="44005"/>
+                    <a:pt x="0" y="53361"/>
                   </a:moveTo>
                   <a:lnTo>
                     <a:pt x="0" y="0"/>
@@ -3233,15 +3233,15 @@
           </p:nvSpPr>
           <p:spPr>
             <a:xfrm>
-              <a:off x="6033569" y="2924594"/>
-              <a:ext cx="0" cy="44005"/>
+              <a:off x="6626288" y="3275439"/>
+              <a:ext cx="0" cy="53361"/>
             </a:xfrm>
             <a:custGeom>
               <a:avLst/>
               <a:pathLst>
-                <a:path w="0" h="44005">
+                <a:path w="0" h="53361">
                   <a:moveTo>
-                    <a:pt x="0" y="44005"/>
+                    <a:pt x="0" y="53361"/>
                   </a:moveTo>
                   <a:lnTo>
                     <a:pt x="0" y="0"/>
@@ -3273,15 +3273,15 @@
           </p:nvSpPr>
           <p:spPr>
             <a:xfrm>
-              <a:off x="4795862" y="2946597"/>
-              <a:ext cx="1237707" cy="0"/>
+              <a:off x="5118334" y="3302120"/>
+              <a:ext cx="1507953" cy="0"/>
             </a:xfrm>
             <a:custGeom>
               <a:avLst/>
               <a:pathLst>
-                <a:path w="1237707" h="0">
+                <a:path w="1507953" h="0">
                   <a:moveTo>
-                    <a:pt x="1237707" y="0"/>
+                    <a:pt x="1507953" y="0"/>
                   </a:moveTo>
                   <a:lnTo>
                     <a:pt x="0" y="0"/>
@@ -3313,15 +3313,15 @@
           </p:nvSpPr>
           <p:spPr>
             <a:xfrm>
-              <a:off x="4795862" y="2924594"/>
-              <a:ext cx="0" cy="44005"/>
+              <a:off x="5118334" y="3275439"/>
+              <a:ext cx="0" cy="53361"/>
             </a:xfrm>
             <a:custGeom>
               <a:avLst/>
               <a:pathLst>
-                <a:path w="0" h="44005">
+                <a:path w="0" h="53361">
                   <a:moveTo>
-                    <a:pt x="0" y="44005"/>
+                    <a:pt x="0" y="53361"/>
                   </a:moveTo>
                   <a:lnTo>
                     <a:pt x="0" y="0"/>
@@ -3353,15 +3353,15 @@
           </p:nvSpPr>
           <p:spPr>
             <a:xfrm>
-              <a:off x="4375087" y="3144620"/>
-              <a:ext cx="0" cy="44005"/>
+              <a:off x="4605685" y="3542245"/>
+              <a:ext cx="0" cy="53361"/>
             </a:xfrm>
             <a:custGeom>
               <a:avLst/>
               <a:pathLst>
-                <a:path w="0" h="44005">
+                <a:path w="0" h="53361">
                   <a:moveTo>
-                    <a:pt x="0" y="44005"/>
+                    <a:pt x="0" y="53361"/>
                   </a:moveTo>
                   <a:lnTo>
                     <a:pt x="0" y="0"/>
@@ -3393,15 +3393,15 @@
           </p:nvSpPr>
           <p:spPr>
             <a:xfrm>
-              <a:off x="3603704" y="3166623"/>
-              <a:ext cx="771383" cy="0"/>
+              <a:off x="3665874" y="3568925"/>
+              <a:ext cx="939811" cy="0"/>
             </a:xfrm>
             <a:custGeom>
               <a:avLst/>
               <a:pathLst>
-                <a:path w="771383" h="0">
+                <a:path w="939811" h="0">
                   <a:moveTo>
-                    <a:pt x="771383" y="0"/>
+                    <a:pt x="939811" y="0"/>
                   </a:moveTo>
                   <a:lnTo>
                     <a:pt x="0" y="0"/>
@@ -3433,15 +3433,15 @@
           </p:nvSpPr>
           <p:spPr>
             <a:xfrm>
-              <a:off x="3603704" y="3144620"/>
-              <a:ext cx="0" cy="44005"/>
+              <a:off x="3665874" y="3542245"/>
+              <a:ext cx="0" cy="53361"/>
             </a:xfrm>
             <a:custGeom>
               <a:avLst/>
               <a:pathLst>
-                <a:path w="0" h="44005">
+                <a:path w="0" h="53361">
                   <a:moveTo>
-                    <a:pt x="0" y="44005"/>
+                    <a:pt x="0" y="53361"/>
                   </a:moveTo>
                   <a:lnTo>
                     <a:pt x="0" y="0"/>
@@ -3473,15 +3473,15 @@
           </p:nvSpPr>
           <p:spPr>
             <a:xfrm>
-              <a:off x="4103288" y="3364646"/>
-              <a:ext cx="0" cy="44005"/>
+              <a:off x="4274540" y="3809050"/>
+              <a:ext cx="0" cy="53361"/>
             </a:xfrm>
             <a:custGeom>
               <a:avLst/>
               <a:pathLst>
-                <a:path w="0" h="44005">
+                <a:path w="0" h="53361">
                   <a:moveTo>
-                    <a:pt x="0" y="44005"/>
+                    <a:pt x="0" y="53361"/>
                   </a:moveTo>
                   <a:lnTo>
                     <a:pt x="0" y="0"/>
@@ -3513,15 +3513,15 @@
           </p:nvSpPr>
           <p:spPr>
             <a:xfrm>
-              <a:off x="3296734" y="3386648"/>
-              <a:ext cx="806553" cy="0"/>
+              <a:off x="3291880" y="3835730"/>
+              <a:ext cx="982660" cy="0"/>
             </a:xfrm>
             <a:custGeom>
               <a:avLst/>
               <a:pathLst>
-                <a:path w="806553" h="0">
+                <a:path w="982660" h="0">
                   <a:moveTo>
-                    <a:pt x="806553" y="0"/>
+                    <a:pt x="982660" y="0"/>
                   </a:moveTo>
                   <a:lnTo>
                     <a:pt x="0" y="0"/>
@@ -3553,15 +3553,15 @@
           </p:nvSpPr>
           <p:spPr>
             <a:xfrm>
-              <a:off x="3296734" y="3364646"/>
-              <a:ext cx="0" cy="44005"/>
+              <a:off x="3291880" y="3809050"/>
+              <a:ext cx="0" cy="53361"/>
             </a:xfrm>
             <a:custGeom>
               <a:avLst/>
               <a:pathLst>
-                <a:path w="0" h="44005">
+                <a:path w="0" h="53361">
                   <a:moveTo>
-                    <a:pt x="0" y="44005"/>
+                    <a:pt x="0" y="53361"/>
                   </a:moveTo>
                   <a:lnTo>
                     <a:pt x="0" y="0"/>
@@ -3593,15 +3593,15 @@
           </p:nvSpPr>
           <p:spPr>
             <a:xfrm>
-              <a:off x="5339685" y="3584672"/>
-              <a:ext cx="0" cy="44005"/>
+              <a:off x="5780898" y="4075855"/>
+              <a:ext cx="0" cy="53361"/>
             </a:xfrm>
             <a:custGeom>
               <a:avLst/>
               <a:pathLst>
-                <a:path w="0" h="44005">
+                <a:path w="0" h="53361">
                   <a:moveTo>
-                    <a:pt x="0" y="44005"/>
+                    <a:pt x="0" y="53361"/>
                   </a:moveTo>
                   <a:lnTo>
                     <a:pt x="0" y="0"/>
@@ -3633,15 +3633,15 @@
           </p:nvSpPr>
           <p:spPr>
             <a:xfrm>
-              <a:off x="4578067" y="3606674"/>
-              <a:ext cx="761617" cy="0"/>
+              <a:off x="4852985" y="4102536"/>
+              <a:ext cx="927913" cy="0"/>
             </a:xfrm>
             <a:custGeom>
               <a:avLst/>
               <a:pathLst>
-                <a:path w="761617" h="0">
+                <a:path w="927913" h="0">
                   <a:moveTo>
-                    <a:pt x="761617" y="0"/>
+                    <a:pt x="927913" y="0"/>
                   </a:moveTo>
                   <a:lnTo>
                     <a:pt x="0" y="0"/>
@@ -3673,15 +3673,15 @@
           </p:nvSpPr>
           <p:spPr>
             <a:xfrm>
-              <a:off x="4578067" y="3584672"/>
-              <a:ext cx="0" cy="44005"/>
+              <a:off x="4852985" y="4075855"/>
+              <a:ext cx="0" cy="53361"/>
             </a:xfrm>
             <a:custGeom>
               <a:avLst/>
               <a:pathLst>
-                <a:path w="0" h="44005">
+                <a:path w="0" h="53361">
                   <a:moveTo>
-                    <a:pt x="0" y="44005"/>
+                    <a:pt x="0" y="53361"/>
                   </a:moveTo>
                   <a:lnTo>
                     <a:pt x="0" y="0"/>
@@ -3713,15 +3713,15 @@
           </p:nvSpPr>
           <p:spPr>
             <a:xfrm>
-              <a:off x="5151643" y="3804698"/>
-              <a:ext cx="0" cy="44005"/>
+              <a:off x="5551798" y="4342660"/>
+              <a:ext cx="0" cy="53361"/>
             </a:xfrm>
             <a:custGeom>
               <a:avLst/>
               <a:pathLst>
-                <a:path w="0" h="44005">
+                <a:path w="0" h="53361">
                   <a:moveTo>
-                    <a:pt x="0" y="44005"/>
+                    <a:pt x="0" y="53361"/>
                   </a:moveTo>
                   <a:lnTo>
                     <a:pt x="0" y="0"/>
@@ -3753,15 +3753,15 @@
           </p:nvSpPr>
           <p:spPr>
             <a:xfrm>
-              <a:off x="3156347" y="3826700"/>
-              <a:ext cx="1995296" cy="0"/>
+              <a:off x="3120840" y="4369341"/>
+              <a:ext cx="2430958" cy="0"/>
             </a:xfrm>
             <a:custGeom>
               <a:avLst/>
               <a:pathLst>
-                <a:path w="1995296" h="0">
+                <a:path w="2430958" h="0">
                   <a:moveTo>
-                    <a:pt x="1995296" y="0"/>
+                    <a:pt x="2430958" y="0"/>
                   </a:moveTo>
                   <a:lnTo>
                     <a:pt x="0" y="0"/>
@@ -3793,15 +3793,15 @@
           </p:nvSpPr>
           <p:spPr>
             <a:xfrm>
-              <a:off x="3156347" y="3804698"/>
-              <a:ext cx="0" cy="44005"/>
+              <a:off x="3120840" y="4342660"/>
+              <a:ext cx="0" cy="53361"/>
             </a:xfrm>
             <a:custGeom>
               <a:avLst/>
               <a:pathLst>
-                <a:path w="0" h="44005">
+                <a:path w="0" h="53361">
                   <a:moveTo>
-                    <a:pt x="0" y="44005"/>
+                    <a:pt x="0" y="53361"/>
                   </a:moveTo>
                   <a:lnTo>
                     <a:pt x="0" y="0"/>
@@ -3833,15 +3833,15 @@
           </p:nvSpPr>
           <p:spPr>
             <a:xfrm>
-              <a:off x="4719399" y="4024724"/>
-              <a:ext cx="0" cy="44005"/>
+              <a:off x="5025176" y="4609466"/>
+              <a:ext cx="0" cy="53361"/>
             </a:xfrm>
             <a:custGeom>
               <a:avLst/>
               <a:pathLst>
-                <a:path w="0" h="44005">
+                <a:path w="0" h="53361">
                   <a:moveTo>
-                    <a:pt x="0" y="44005"/>
+                    <a:pt x="0" y="53361"/>
                   </a:moveTo>
                   <a:lnTo>
                     <a:pt x="0" y="0"/>
@@ -3873,15 +3873,15 @@
           </p:nvSpPr>
           <p:spPr>
             <a:xfrm>
-              <a:off x="2812638" y="4046726"/>
-              <a:ext cx="1906760" cy="0"/>
+              <a:off x="2702084" y="4636146"/>
+              <a:ext cx="2323092" cy="0"/>
             </a:xfrm>
             <a:custGeom>
               <a:avLst/>
               <a:pathLst>
-                <a:path w="1906760" h="0">
+                <a:path w="2323092" h="0">
                   <a:moveTo>
-                    <a:pt x="1906760" y="0"/>
+                    <a:pt x="2323092" y="0"/>
                   </a:moveTo>
                   <a:lnTo>
                     <a:pt x="0" y="0"/>
@@ -3913,15 +3913,15 @@
           </p:nvSpPr>
           <p:spPr>
             <a:xfrm>
-              <a:off x="2812638" y="4024724"/>
-              <a:ext cx="0" cy="44005"/>
+              <a:off x="2702084" y="4609466"/>
+              <a:ext cx="0" cy="53361"/>
             </a:xfrm>
             <a:custGeom>
               <a:avLst/>
               <a:pathLst>
-                <a:path w="0" h="44005">
+                <a:path w="0" h="53361">
                   <a:moveTo>
-                    <a:pt x="0" y="44005"/>
+                    <a:pt x="0" y="53361"/>
                   </a:moveTo>
                   <a:lnTo>
                     <a:pt x="0" y="0"/>
@@ -3953,15 +3953,15 @@
           </p:nvSpPr>
           <p:spPr>
             <a:xfrm>
-              <a:off x="5027169" y="4244750"/>
-              <a:ext cx="0" cy="44005"/>
+              <a:off x="5400146" y="4876271"/>
+              <a:ext cx="0" cy="53361"/>
             </a:xfrm>
             <a:custGeom>
               <a:avLst/>
               <a:pathLst>
-                <a:path w="0" h="44005">
+                <a:path w="0" h="53361">
                   <a:moveTo>
-                    <a:pt x="0" y="44005"/>
+                    <a:pt x="0" y="53361"/>
                   </a:moveTo>
                   <a:lnTo>
                     <a:pt x="0" y="0"/>
@@ -3993,15 +3993,15 @@
           </p:nvSpPr>
           <p:spPr>
             <a:xfrm>
-              <a:off x="2966010" y="4266752"/>
-              <a:ext cx="2061158" cy="0"/>
+              <a:off x="2888944" y="4902952"/>
+              <a:ext cx="2511201" cy="0"/>
             </a:xfrm>
             <a:custGeom>
               <a:avLst/>
               <a:pathLst>
-                <a:path w="2061158" h="0">
+                <a:path w="2511201" h="0">
                   <a:moveTo>
-                    <a:pt x="2061158" y="0"/>
+                    <a:pt x="2511201" y="0"/>
                   </a:moveTo>
                   <a:lnTo>
                     <a:pt x="0" y="0"/>
@@ -4033,15 +4033,15 @@
           </p:nvSpPr>
           <p:spPr>
             <a:xfrm>
-              <a:off x="2966010" y="4244750"/>
-              <a:ext cx="0" cy="44005"/>
+              <a:off x="2888944" y="4876271"/>
+              <a:ext cx="0" cy="53361"/>
             </a:xfrm>
             <a:custGeom>
               <a:avLst/>
               <a:pathLst>
-                <a:path w="0" h="44005">
+                <a:path w="0" h="53361">
                   <a:moveTo>
-                    <a:pt x="0" y="44005"/>
+                    <a:pt x="0" y="53361"/>
                   </a:moveTo>
                   <a:lnTo>
                     <a:pt x="0" y="0"/>
@@ -4073,15 +4073,15 @@
           </p:nvSpPr>
           <p:spPr>
             <a:xfrm>
-              <a:off x="3851497" y="4464776"/>
-              <a:ext cx="0" cy="44005"/>
+              <a:off x="3967772" y="5143076"/>
+              <a:ext cx="0" cy="53361"/>
             </a:xfrm>
             <a:custGeom>
               <a:avLst/>
               <a:pathLst>
-                <a:path w="0" h="44005">
+                <a:path w="0" h="53361">
                   <a:moveTo>
-                    <a:pt x="0" y="44005"/>
+                    <a:pt x="0" y="53361"/>
                   </a:moveTo>
                   <a:lnTo>
                     <a:pt x="0" y="0"/>
@@ -4113,15 +4113,15 @@
           </p:nvSpPr>
           <p:spPr>
             <a:xfrm>
-              <a:off x="3077419" y="4486778"/>
-              <a:ext cx="774078" cy="0"/>
+              <a:off x="3024678" y="5169757"/>
+              <a:ext cx="943094" cy="0"/>
             </a:xfrm>
             <a:custGeom>
               <a:avLst/>
               <a:pathLst>
-                <a:path w="774078" h="0">
+                <a:path w="943094" h="0">
                   <a:moveTo>
-                    <a:pt x="774078" y="0"/>
+                    <a:pt x="943094" y="0"/>
                   </a:moveTo>
                   <a:lnTo>
                     <a:pt x="0" y="0"/>
@@ -4153,15 +4153,15 @@
           </p:nvSpPr>
           <p:spPr>
             <a:xfrm>
-              <a:off x="3077419" y="4464776"/>
-              <a:ext cx="0" cy="44005"/>
+              <a:off x="3024678" y="5143076"/>
+              <a:ext cx="0" cy="53361"/>
             </a:xfrm>
             <a:custGeom>
               <a:avLst/>
               <a:pathLst>
-                <a:path w="0" h="44005">
+                <a:path w="0" h="53361">
                   <a:moveTo>
-                    <a:pt x="0" y="44005"/>
+                    <a:pt x="0" y="53361"/>
                   </a:moveTo>
                   <a:lnTo>
                     <a:pt x="0" y="0"/>
@@ -4193,7 +4193,7 @@
           </p:nvSpPr>
           <p:spPr>
             <a:xfrm>
-              <a:off x="3732635" y="1354963"/>
+              <a:off x="3834192" y="1383031"/>
               <a:ext cx="102903" cy="102903"/>
             </a:xfrm>
             <a:prstGeom prst="ellipse">
@@ -4228,7 +4228,7 @@
           </p:nvSpPr>
           <p:spPr>
             <a:xfrm>
-              <a:off x="5089363" y="1574989"/>
+              <a:off x="5487155" y="1649836"/>
               <a:ext cx="102903" cy="102903"/>
             </a:xfrm>
             <a:prstGeom prst="ellipse">
@@ -4263,7 +4263,7 @@
           </p:nvSpPr>
           <p:spPr>
             <a:xfrm>
-              <a:off x="5224954" y="1795015"/>
+              <a:off x="5652350" y="1916641"/>
               <a:ext cx="102903" cy="102903"/>
             </a:xfrm>
             <a:prstGeom prst="ellipse">
@@ -4298,7 +4298,7 @@
           </p:nvSpPr>
           <p:spPr>
             <a:xfrm>
-              <a:off x="3732962" y="2015041"/>
+              <a:off x="3834589" y="2183447"/>
               <a:ext cx="102903" cy="102903"/>
             </a:xfrm>
             <a:prstGeom prst="ellipse">
@@ -4333,7 +4333,7 @@
           </p:nvSpPr>
           <p:spPr>
             <a:xfrm>
-              <a:off x="2921967" y="2235067"/>
+              <a:off x="2846519" y="2450252"/>
               <a:ext cx="102903" cy="102903"/>
             </a:xfrm>
             <a:prstGeom prst="ellipse">
@@ -4368,7 +4368,7 @@
           </p:nvSpPr>
           <p:spPr>
             <a:xfrm>
-              <a:off x="4533099" y="2455093"/>
+              <a:off x="4809432" y="2717057"/>
               <a:ext cx="102903" cy="102903"/>
             </a:xfrm>
             <a:prstGeom prst="ellipse">
@@ -4403,7 +4403,7 @@
           </p:nvSpPr>
           <p:spPr>
             <a:xfrm>
-              <a:off x="4294444" y="2675119"/>
+              <a:off x="4518668" y="2983863"/>
               <a:ext cx="102903" cy="102903"/>
             </a:xfrm>
             <a:prstGeom prst="ellipse">
@@ -4438,7 +4438,7 @@
           </p:nvSpPr>
           <p:spPr>
             <a:xfrm>
-              <a:off x="5363264" y="2895145"/>
+              <a:off x="5820859" y="3250668"/>
               <a:ext cx="102903" cy="102903"/>
             </a:xfrm>
             <a:prstGeom prst="ellipse">
@@ -4473,7 +4473,7 @@
           </p:nvSpPr>
           <p:spPr>
             <a:xfrm>
-              <a:off x="3937943" y="3115171"/>
+              <a:off x="4084328" y="3517473"/>
               <a:ext cx="102903" cy="102903"/>
             </a:xfrm>
             <a:prstGeom prst="ellipse">
@@ -4508,7 +4508,7 @@
           </p:nvSpPr>
           <p:spPr>
             <a:xfrm>
-              <a:off x="3648559" y="3335197"/>
+              <a:off x="3731758" y="3784278"/>
               <a:ext cx="102903" cy="102903"/>
             </a:xfrm>
             <a:prstGeom prst="ellipse">
@@ -4543,7 +4543,7 @@
           </p:nvSpPr>
           <p:spPr>
             <a:xfrm>
-              <a:off x="4907424" y="3555223"/>
+              <a:off x="5265490" y="4051084"/>
               <a:ext cx="102903" cy="102903"/>
             </a:xfrm>
             <a:prstGeom prst="ellipse">
@@ -4578,7 +4578,7 @@
           </p:nvSpPr>
           <p:spPr>
             <a:xfrm>
-              <a:off x="4102543" y="3775248"/>
+              <a:off x="4284867" y="4317889"/>
               <a:ext cx="102903" cy="102903"/>
             </a:xfrm>
             <a:prstGeom prst="ellipse">
@@ -4613,7 +4613,7 @@
           </p:nvSpPr>
           <p:spPr>
             <a:xfrm>
-              <a:off x="3714566" y="3995274"/>
+              <a:off x="3812178" y="4584694"/>
               <a:ext cx="102903" cy="102903"/>
             </a:xfrm>
             <a:prstGeom prst="ellipse">
@@ -4648,7 +4648,7 @@
           </p:nvSpPr>
           <p:spPr>
             <a:xfrm>
-              <a:off x="3945138" y="4215300"/>
+              <a:off x="4093093" y="4851500"/>
               <a:ext cx="102903" cy="102903"/>
             </a:xfrm>
             <a:prstGeom prst="ellipse">
@@ -4683,7 +4683,7 @@
           </p:nvSpPr>
           <p:spPr>
             <a:xfrm>
-              <a:off x="3413006" y="4435326"/>
+              <a:off x="3444773" y="5118305"/>
               <a:ext cx="102903" cy="102903"/>
             </a:xfrm>
             <a:prstGeom prst="ellipse">
@@ -4718,8 +4718,8 @@
           </p:nvSpPr>
           <p:spPr>
             <a:xfrm>
-              <a:off x="2101731" y="1274400"/>
-              <a:ext cx="4119068" cy="3344394"/>
+              <a:off x="1835953" y="1274399"/>
+              <a:ext cx="5018446" cy="4055440"/>
             </a:xfrm>
             <a:prstGeom prst="rect">
               <a:avLst/>
@@ -4739,15 +4739,15 @@
           </p:nvSpPr>
           <p:spPr>
             <a:xfrm>
-              <a:off x="2101731" y="1274400"/>
-              <a:ext cx="0" cy="3344394"/>
+              <a:off x="1835953" y="1274399"/>
+              <a:ext cx="0" cy="4055440"/>
             </a:xfrm>
             <a:custGeom>
               <a:avLst/>
               <a:pathLst>
-                <a:path w="0" h="3344394">
+                <a:path w="0" h="4055440">
                   <a:moveTo>
-                    <a:pt x="0" y="3344394"/>
+                    <a:pt x="0" y="4055440"/>
                   </a:moveTo>
                   <a:lnTo>
                     <a:pt x="0" y="0"/>
@@ -4755,7 +4755,7 @@
                 </a:path>
               </a:pathLst>
             </a:custGeom>
-            <a:ln w="14782" cap="flat">
+            <a:ln w="11086" cap="flat">
               <a:solidFill>
                 <a:srgbClr val="000000">
                   <a:alpha val="100000"/>
@@ -4779,8 +4779,8 @@
           </p:nvSpPr>
           <p:spPr>
             <a:xfrm>
-              <a:off x="1303441" y="4436669"/>
-              <a:ext cx="729965" cy="100218"/>
+              <a:off x="1253901" y="5133318"/>
+              <a:ext cx="530809" cy="72877"/>
             </a:xfrm>
             <a:prstGeom prst="rect">
               <a:avLst/>
@@ -4793,7 +4793,7 @@
             <a:p>
               <a:pPr algn="l" marL="0" marR="0" indent="0">
                 <a:lnSpc>
-                  <a:spcPts val="1100"/>
+                  <a:spcPts val="800"/>
                 </a:lnSpc>
                 <a:spcBef>
                   <a:spcPts val="0"/>
@@ -4803,7 +4803,7 @@
                 </a:spcAft>
               </a:pPr>
               <a:r>
-                <a:rPr sz="1100">
+                <a:rPr sz="800">
                   <a:solidFill>
                     <a:srgbClr val="000000">
                       <a:alpha val="100000"/>
@@ -4825,8 +4825,8 @@
           </p:nvSpPr>
           <p:spPr>
             <a:xfrm>
-              <a:off x="1303441" y="4216643"/>
-              <a:ext cx="729965" cy="100218"/>
+              <a:off x="1253901" y="4866513"/>
+              <a:ext cx="530809" cy="72877"/>
             </a:xfrm>
             <a:prstGeom prst="rect">
               <a:avLst/>
@@ -4839,7 +4839,7 @@
             <a:p>
               <a:pPr algn="l" marL="0" marR="0" indent="0">
                 <a:lnSpc>
-                  <a:spcPts val="1100"/>
+                  <a:spcPts val="800"/>
                 </a:lnSpc>
                 <a:spcBef>
                   <a:spcPts val="0"/>
@@ -4849,7 +4849,7 @@
                 </a:spcAft>
               </a:pPr>
               <a:r>
-                <a:rPr sz="1100">
+                <a:rPr sz="800">
                   <a:solidFill>
                     <a:srgbClr val="000000">
                       <a:alpha val="100000"/>
@@ -4871,8 +4871,8 @@
           </p:nvSpPr>
           <p:spPr>
             <a:xfrm>
-              <a:off x="1746194" y="3996617"/>
-              <a:ext cx="287213" cy="100218"/>
+              <a:off x="1575862" y="4599707"/>
+              <a:ext cx="208848" cy="72877"/>
             </a:xfrm>
             <a:prstGeom prst="rect">
               <a:avLst/>
@@ -4885,7 +4885,7 @@
             <a:p>
               <a:pPr algn="l" marL="0" marR="0" indent="0">
                 <a:lnSpc>
-                  <a:spcPts val="1100"/>
+                  <a:spcPts val="800"/>
                 </a:lnSpc>
                 <a:spcBef>
                   <a:spcPts val="0"/>
@@ -4895,7 +4895,7 @@
                 </a:spcAft>
               </a:pPr>
               <a:r>
-                <a:rPr sz="1100">
+                <a:rPr sz="800">
                   <a:solidFill>
                     <a:srgbClr val="000000">
                       <a:alpha val="100000"/>
@@ -4917,8 +4917,8 @@
           </p:nvSpPr>
           <p:spPr>
             <a:xfrm>
-              <a:off x="1746377" y="3776591"/>
-              <a:ext cx="287030" cy="100218"/>
+              <a:off x="1575953" y="4332902"/>
+              <a:ext cx="208757" cy="72877"/>
             </a:xfrm>
             <a:prstGeom prst="rect">
               <a:avLst/>
@@ -4931,7 +4931,7 @@
             <a:p>
               <a:pPr algn="l" marL="0" marR="0" indent="0">
                 <a:lnSpc>
-                  <a:spcPts val="1100"/>
+                  <a:spcPts val="800"/>
                 </a:lnSpc>
                 <a:spcBef>
                   <a:spcPts val="0"/>
@@ -4941,7 +4941,7 @@
                 </a:spcAft>
               </a:pPr>
               <a:r>
-                <a:rPr sz="1100">
+                <a:rPr sz="800">
                   <a:solidFill>
                     <a:srgbClr val="000000">
                       <a:alpha val="100000"/>
@@ -4963,8 +4963,8 @@
           </p:nvSpPr>
           <p:spPr>
             <a:xfrm>
-              <a:off x="1831690" y="3556565"/>
-              <a:ext cx="201716" cy="100218"/>
+              <a:off x="1638041" y="4066097"/>
+              <a:ext cx="146669" cy="72877"/>
             </a:xfrm>
             <a:prstGeom prst="rect">
               <a:avLst/>
@@ -4977,7 +4977,7 @@
             <a:p>
               <a:pPr algn="l" marL="0" marR="0" indent="0">
                 <a:lnSpc>
-                  <a:spcPts val="1100"/>
+                  <a:spcPts val="800"/>
                 </a:lnSpc>
                 <a:spcBef>
                   <a:spcPts val="0"/>
@@ -4987,7 +4987,7 @@
                 </a:spcAft>
               </a:pPr>
               <a:r>
-                <a:rPr sz="1100">
+                <a:rPr sz="800">
                   <a:solidFill>
                     <a:srgbClr val="000000">
                       <a:alpha val="100000"/>
@@ -5009,8 +5009,8 @@
           </p:nvSpPr>
           <p:spPr>
             <a:xfrm>
-              <a:off x="1761647" y="3336539"/>
-              <a:ext cx="271759" cy="100218"/>
+              <a:off x="1587109" y="3799292"/>
+              <a:ext cx="197601" cy="72877"/>
             </a:xfrm>
             <a:prstGeom prst="rect">
               <a:avLst/>
@@ -5023,7 +5023,7 @@
             <a:p>
               <a:pPr algn="l" marL="0" marR="0" indent="0">
                 <a:lnSpc>
-                  <a:spcPts val="1100"/>
+                  <a:spcPts val="800"/>
                 </a:lnSpc>
                 <a:spcBef>
                   <a:spcPts val="0"/>
@@ -5033,7 +5033,7 @@
                 </a:spcAft>
               </a:pPr>
               <a:r>
-                <a:rPr sz="1100">
+                <a:rPr sz="800">
                   <a:solidFill>
                     <a:srgbClr val="000000">
                       <a:alpha val="100000"/>
@@ -5055,8 +5055,8 @@
           </p:nvSpPr>
           <p:spPr>
             <a:xfrm>
-              <a:off x="1287714" y="3116513"/>
-              <a:ext cx="745693" cy="100218"/>
+              <a:off x="1242471" y="3532486"/>
+              <a:ext cx="542239" cy="72877"/>
             </a:xfrm>
             <a:prstGeom prst="rect">
               <a:avLst/>
@@ -5069,7 +5069,7 @@
             <a:p>
               <a:pPr algn="l" marL="0" marR="0" indent="0">
                 <a:lnSpc>
-                  <a:spcPts val="1100"/>
+                  <a:spcPts val="800"/>
                 </a:lnSpc>
                 <a:spcBef>
                   <a:spcPts val="0"/>
@@ -5079,7 +5079,7 @@
                 </a:spcAft>
               </a:pPr>
               <a:r>
-                <a:rPr sz="1100">
+                <a:rPr sz="800">
                   <a:solidFill>
                     <a:srgbClr val="000000">
                       <a:alpha val="100000"/>
@@ -5101,8 +5101,8 @@
           </p:nvSpPr>
           <p:spPr>
             <a:xfrm>
-              <a:off x="1287714" y="2896488"/>
-              <a:ext cx="745693" cy="100218"/>
+              <a:off x="1242471" y="3265681"/>
+              <a:ext cx="542239" cy="72877"/>
             </a:xfrm>
             <a:prstGeom prst="rect">
               <a:avLst/>
@@ -5115,7 +5115,7 @@
             <a:p>
               <a:pPr algn="l" marL="0" marR="0" indent="0">
                 <a:lnSpc>
-                  <a:spcPts val="1100"/>
+                  <a:spcPts val="800"/>
                 </a:lnSpc>
                 <a:spcBef>
                   <a:spcPts val="0"/>
@@ -5125,7 +5125,7 @@
                 </a:spcAft>
               </a:pPr>
               <a:r>
-                <a:rPr sz="1100">
+                <a:rPr sz="800">
                   <a:solidFill>
                     <a:srgbClr val="000000">
                       <a:alpha val="100000"/>
@@ -5147,8 +5147,8 @@
           </p:nvSpPr>
           <p:spPr>
             <a:xfrm>
-              <a:off x="1629608" y="2676462"/>
-              <a:ext cx="403799" cy="100218"/>
+              <a:off x="1491005" y="2998876"/>
+              <a:ext cx="293705" cy="72877"/>
             </a:xfrm>
             <a:prstGeom prst="rect">
               <a:avLst/>
@@ -5161,7 +5161,7 @@
             <a:p>
               <a:pPr algn="l" marL="0" marR="0" indent="0">
                 <a:lnSpc>
-                  <a:spcPts val="1100"/>
+                  <a:spcPts val="800"/>
                 </a:lnSpc>
                 <a:spcBef>
                   <a:spcPts val="0"/>
@@ -5171,7 +5171,7 @@
                 </a:spcAft>
               </a:pPr>
               <a:r>
-                <a:rPr sz="1100">
+                <a:rPr sz="800">
                   <a:solidFill>
                     <a:srgbClr val="000000">
                       <a:alpha val="100000"/>
@@ -5193,8 +5193,8 @@
           </p:nvSpPr>
           <p:spPr>
             <a:xfrm>
-              <a:off x="1823826" y="2456436"/>
-              <a:ext cx="209580" cy="100218"/>
+              <a:off x="1632280" y="2732070"/>
+              <a:ext cx="152430" cy="72877"/>
             </a:xfrm>
             <a:prstGeom prst="rect">
               <a:avLst/>
@@ -5207,7 +5207,7 @@
             <a:p>
               <a:pPr algn="l" marL="0" marR="0" indent="0">
                 <a:lnSpc>
-                  <a:spcPts val="1100"/>
+                  <a:spcPts val="800"/>
                 </a:lnSpc>
                 <a:spcBef>
                   <a:spcPts val="0"/>
@@ -5217,7 +5217,7 @@
                 </a:spcAft>
               </a:pPr>
               <a:r>
-                <a:rPr sz="1100">
+                <a:rPr sz="800">
                   <a:solidFill>
                     <a:srgbClr val="000000">
                       <a:alpha val="100000"/>
@@ -5239,8 +5239,8 @@
           </p:nvSpPr>
           <p:spPr>
             <a:xfrm>
-              <a:off x="1746194" y="2236410"/>
-              <a:ext cx="287213" cy="100218"/>
+              <a:off x="1575862" y="2465265"/>
+              <a:ext cx="208848" cy="72877"/>
             </a:xfrm>
             <a:prstGeom prst="rect">
               <a:avLst/>
@@ -5253,7 +5253,7 @@
             <a:p>
               <a:pPr algn="l" marL="0" marR="0" indent="0">
                 <a:lnSpc>
-                  <a:spcPts val="1100"/>
+                  <a:spcPts val="800"/>
                 </a:lnSpc>
                 <a:spcBef>
                   <a:spcPts val="0"/>
@@ -5263,7 +5263,7 @@
                 </a:spcAft>
               </a:pPr>
               <a:r>
-                <a:rPr sz="1100">
+                <a:rPr sz="800">
                   <a:solidFill>
                     <a:srgbClr val="000000">
                       <a:alpha val="100000"/>
@@ -5285,8 +5285,8 @@
           </p:nvSpPr>
           <p:spPr>
             <a:xfrm>
-              <a:off x="1637563" y="2016384"/>
-              <a:ext cx="395843" cy="100218"/>
+              <a:off x="1496857" y="2198460"/>
+              <a:ext cx="287853" cy="72877"/>
             </a:xfrm>
             <a:prstGeom prst="rect">
               <a:avLst/>
@@ -5299,7 +5299,7 @@
             <a:p>
               <a:pPr algn="l" marL="0" marR="0" indent="0">
                 <a:lnSpc>
-                  <a:spcPts val="1100"/>
+                  <a:spcPts val="800"/>
                 </a:lnSpc>
                 <a:spcBef>
                   <a:spcPts val="0"/>
@@ -5309,7 +5309,7 @@
                 </a:spcAft>
               </a:pPr>
               <a:r>
-                <a:rPr sz="1100">
+                <a:rPr sz="800">
                   <a:solidFill>
                     <a:srgbClr val="000000">
                       <a:alpha val="100000"/>
@@ -5331,8 +5331,8 @@
           </p:nvSpPr>
           <p:spPr>
             <a:xfrm>
-              <a:off x="1769328" y="1796358"/>
-              <a:ext cx="264078" cy="100218"/>
+              <a:off x="1592686" y="1931654"/>
+              <a:ext cx="192024" cy="72877"/>
             </a:xfrm>
             <a:prstGeom prst="rect">
               <a:avLst/>
@@ -5345,7 +5345,7 @@
             <a:p>
               <a:pPr algn="l" marL="0" marR="0" indent="0">
                 <a:lnSpc>
-                  <a:spcPts val="1100"/>
+                  <a:spcPts val="800"/>
                 </a:lnSpc>
                 <a:spcBef>
                   <a:spcPts val="0"/>
@@ -5355,7 +5355,7 @@
                 </a:spcAft>
               </a:pPr>
               <a:r>
-                <a:rPr sz="1100">
+                <a:rPr sz="800">
                   <a:solidFill>
                     <a:srgbClr val="000000">
                       <a:alpha val="100000"/>
@@ -5377,8 +5377,8 @@
           </p:nvSpPr>
           <p:spPr>
             <a:xfrm>
-              <a:off x="1746102" y="1576332"/>
-              <a:ext cx="287304" cy="100218"/>
+              <a:off x="1575770" y="1664849"/>
+              <a:ext cx="208940" cy="72877"/>
             </a:xfrm>
             <a:prstGeom prst="rect">
               <a:avLst/>
@@ -5391,7 +5391,7 @@
             <a:p>
               <a:pPr algn="l" marL="0" marR="0" indent="0">
                 <a:lnSpc>
-                  <a:spcPts val="1100"/>
+                  <a:spcPts val="800"/>
                 </a:lnSpc>
                 <a:spcBef>
                   <a:spcPts val="0"/>
@@ -5401,7 +5401,7 @@
                 </a:spcAft>
               </a:pPr>
               <a:r>
-                <a:rPr sz="1100">
+                <a:rPr sz="800">
                   <a:solidFill>
                     <a:srgbClr val="000000">
                       <a:alpha val="100000"/>
@@ -5423,8 +5423,8 @@
           </p:nvSpPr>
           <p:spPr>
             <a:xfrm>
-              <a:off x="1761739" y="1356306"/>
-              <a:ext cx="271668" cy="100218"/>
+              <a:off x="1587109" y="1398044"/>
+              <a:ext cx="197601" cy="72877"/>
             </a:xfrm>
             <a:prstGeom prst="rect">
               <a:avLst/>
@@ -5437,7 +5437,7 @@
             <a:p>
               <a:pPr algn="l" marL="0" marR="0" indent="0">
                 <a:lnSpc>
-                  <a:spcPts val="1100"/>
+                  <a:spcPts val="800"/>
                 </a:lnSpc>
                 <a:spcBef>
                   <a:spcPts val="0"/>
@@ -5447,7 +5447,7 @@
                 </a:spcAft>
               </a:pPr>
               <a:r>
-                <a:rPr sz="1100">
+                <a:rPr sz="800">
                   <a:solidFill>
                     <a:srgbClr val="000000">
                       <a:alpha val="100000"/>
@@ -5469,23 +5469,23 @@
           </p:nvSpPr>
           <p:spPr>
             <a:xfrm>
-              <a:off x="2063773" y="4486778"/>
-              <a:ext cx="37957" cy="0"/>
+              <a:off x="1807485" y="5169757"/>
+              <a:ext cx="28468" cy="0"/>
             </a:xfrm>
             <a:custGeom>
               <a:avLst/>
               <a:pathLst>
-                <a:path w="37957" h="0">
+                <a:path w="28468" h="0">
                   <a:moveTo>
                     <a:pt x="0" y="0"/>
                   </a:moveTo>
                   <a:lnTo>
-                    <a:pt x="37957" y="0"/>
+                    <a:pt x="28468" y="0"/>
                   </a:lnTo>
                 </a:path>
               </a:pathLst>
             </a:custGeom>
-            <a:ln w="14782" cap="flat">
+            <a:ln w="11086" cap="flat">
               <a:solidFill>
                 <a:srgbClr val="333333">
                   <a:alpha val="100000"/>
@@ -5509,23 +5509,23 @@
           </p:nvSpPr>
           <p:spPr>
             <a:xfrm>
-              <a:off x="2063773" y="4266752"/>
-              <a:ext cx="37957" cy="0"/>
+              <a:off x="1807485" y="4902952"/>
+              <a:ext cx="28468" cy="0"/>
             </a:xfrm>
             <a:custGeom>
               <a:avLst/>
               <a:pathLst>
-                <a:path w="37957" h="0">
+                <a:path w="28468" h="0">
                   <a:moveTo>
                     <a:pt x="0" y="0"/>
                   </a:moveTo>
                   <a:lnTo>
-                    <a:pt x="37957" y="0"/>
+                    <a:pt x="28468" y="0"/>
                   </a:lnTo>
                 </a:path>
               </a:pathLst>
             </a:custGeom>
-            <a:ln w="14782" cap="flat">
+            <a:ln w="11086" cap="flat">
               <a:solidFill>
                 <a:srgbClr val="333333">
                   <a:alpha val="100000"/>
@@ -5549,23 +5549,23 @@
           </p:nvSpPr>
           <p:spPr>
             <a:xfrm>
-              <a:off x="2063773" y="4046726"/>
-              <a:ext cx="37957" cy="0"/>
+              <a:off x="1807485" y="4636146"/>
+              <a:ext cx="28468" cy="0"/>
             </a:xfrm>
             <a:custGeom>
               <a:avLst/>
               <a:pathLst>
-                <a:path w="37957" h="0">
+                <a:path w="28468" h="0">
                   <a:moveTo>
                     <a:pt x="0" y="0"/>
                   </a:moveTo>
                   <a:lnTo>
-                    <a:pt x="37957" y="0"/>
+                    <a:pt x="28468" y="0"/>
                   </a:lnTo>
                 </a:path>
               </a:pathLst>
             </a:custGeom>
-            <a:ln w="14782" cap="flat">
+            <a:ln w="11086" cap="flat">
               <a:solidFill>
                 <a:srgbClr val="333333">
                   <a:alpha val="100000"/>
@@ -5589,23 +5589,23 @@
           </p:nvSpPr>
           <p:spPr>
             <a:xfrm>
-              <a:off x="2063773" y="3826700"/>
-              <a:ext cx="37957" cy="0"/>
+              <a:off x="1807485" y="4369341"/>
+              <a:ext cx="28468" cy="0"/>
             </a:xfrm>
             <a:custGeom>
               <a:avLst/>
               <a:pathLst>
-                <a:path w="37957" h="0">
+                <a:path w="28468" h="0">
                   <a:moveTo>
                     <a:pt x="0" y="0"/>
                   </a:moveTo>
                   <a:lnTo>
-                    <a:pt x="37957" y="0"/>
+                    <a:pt x="28468" y="0"/>
                   </a:lnTo>
                 </a:path>
               </a:pathLst>
             </a:custGeom>
-            <a:ln w="14782" cap="flat">
+            <a:ln w="11086" cap="flat">
               <a:solidFill>
                 <a:srgbClr val="333333">
                   <a:alpha val="100000"/>
@@ -5629,23 +5629,23 @@
           </p:nvSpPr>
           <p:spPr>
             <a:xfrm>
-              <a:off x="2063773" y="3606674"/>
-              <a:ext cx="37957" cy="0"/>
+              <a:off x="1807485" y="4102536"/>
+              <a:ext cx="28468" cy="0"/>
             </a:xfrm>
             <a:custGeom>
               <a:avLst/>
               <a:pathLst>
-                <a:path w="37957" h="0">
+                <a:path w="28468" h="0">
                   <a:moveTo>
                     <a:pt x="0" y="0"/>
                   </a:moveTo>
                   <a:lnTo>
-                    <a:pt x="37957" y="0"/>
+                    <a:pt x="28468" y="0"/>
                   </a:lnTo>
                 </a:path>
               </a:pathLst>
             </a:custGeom>
-            <a:ln w="14782" cap="flat">
+            <a:ln w="11086" cap="flat">
               <a:solidFill>
                 <a:srgbClr val="333333">
                   <a:alpha val="100000"/>
@@ -5669,23 +5669,23 @@
           </p:nvSpPr>
           <p:spPr>
             <a:xfrm>
-              <a:off x="2063773" y="3386648"/>
-              <a:ext cx="37957" cy="0"/>
+              <a:off x="1807485" y="3835730"/>
+              <a:ext cx="28468" cy="0"/>
             </a:xfrm>
             <a:custGeom>
               <a:avLst/>
               <a:pathLst>
-                <a:path w="37957" h="0">
+                <a:path w="28468" h="0">
                   <a:moveTo>
                     <a:pt x="0" y="0"/>
                   </a:moveTo>
                   <a:lnTo>
-                    <a:pt x="37957" y="0"/>
+                    <a:pt x="28468" y="0"/>
                   </a:lnTo>
                 </a:path>
               </a:pathLst>
             </a:custGeom>
-            <a:ln w="14782" cap="flat">
+            <a:ln w="11086" cap="flat">
               <a:solidFill>
                 <a:srgbClr val="333333">
                   <a:alpha val="100000"/>
@@ -5709,23 +5709,23 @@
           </p:nvSpPr>
           <p:spPr>
             <a:xfrm>
-              <a:off x="2063773" y="3166623"/>
-              <a:ext cx="37957" cy="0"/>
+              <a:off x="1807485" y="3568925"/>
+              <a:ext cx="28468" cy="0"/>
             </a:xfrm>
             <a:custGeom>
               <a:avLst/>
               <a:pathLst>
-                <a:path w="37957" h="0">
+                <a:path w="28468" h="0">
                   <a:moveTo>
                     <a:pt x="0" y="0"/>
                   </a:moveTo>
                   <a:lnTo>
-                    <a:pt x="37957" y="0"/>
+                    <a:pt x="28468" y="0"/>
                   </a:lnTo>
                 </a:path>
               </a:pathLst>
             </a:custGeom>
-            <a:ln w="14782" cap="flat">
+            <a:ln w="11086" cap="flat">
               <a:solidFill>
                 <a:srgbClr val="333333">
                   <a:alpha val="100000"/>
@@ -5749,23 +5749,23 @@
           </p:nvSpPr>
           <p:spPr>
             <a:xfrm>
-              <a:off x="2063773" y="2946597"/>
-              <a:ext cx="37957" cy="0"/>
+              <a:off x="1807485" y="3302120"/>
+              <a:ext cx="28468" cy="0"/>
             </a:xfrm>
             <a:custGeom>
               <a:avLst/>
               <a:pathLst>
-                <a:path w="37957" h="0">
+                <a:path w="28468" h="0">
                   <a:moveTo>
                     <a:pt x="0" y="0"/>
                   </a:moveTo>
                   <a:lnTo>
-                    <a:pt x="37957" y="0"/>
+                    <a:pt x="28468" y="0"/>
                   </a:lnTo>
                 </a:path>
               </a:pathLst>
             </a:custGeom>
-            <a:ln w="14782" cap="flat">
+            <a:ln w="11086" cap="flat">
               <a:solidFill>
                 <a:srgbClr val="333333">
                   <a:alpha val="100000"/>
@@ -5789,23 +5789,23 @@
           </p:nvSpPr>
           <p:spPr>
             <a:xfrm>
-              <a:off x="2063773" y="2726571"/>
-              <a:ext cx="37957" cy="0"/>
+              <a:off x="1807485" y="3035314"/>
+              <a:ext cx="28468" cy="0"/>
             </a:xfrm>
             <a:custGeom>
               <a:avLst/>
               <a:pathLst>
-                <a:path w="37957" h="0">
+                <a:path w="28468" h="0">
                   <a:moveTo>
                     <a:pt x="0" y="0"/>
                   </a:moveTo>
                   <a:lnTo>
-                    <a:pt x="37957" y="0"/>
+                    <a:pt x="28468" y="0"/>
                   </a:lnTo>
                 </a:path>
               </a:pathLst>
             </a:custGeom>
-            <a:ln w="14782" cap="flat">
+            <a:ln w="11086" cap="flat">
               <a:solidFill>
                 <a:srgbClr val="333333">
                   <a:alpha val="100000"/>
@@ -5829,23 +5829,23 @@
           </p:nvSpPr>
           <p:spPr>
             <a:xfrm>
-              <a:off x="2063773" y="2506545"/>
-              <a:ext cx="37957" cy="0"/>
+              <a:off x="1807485" y="2768509"/>
+              <a:ext cx="28468" cy="0"/>
             </a:xfrm>
             <a:custGeom>
               <a:avLst/>
               <a:pathLst>
-                <a:path w="37957" h="0">
+                <a:path w="28468" h="0">
                   <a:moveTo>
                     <a:pt x="0" y="0"/>
                   </a:moveTo>
                   <a:lnTo>
-                    <a:pt x="37957" y="0"/>
+                    <a:pt x="28468" y="0"/>
                   </a:lnTo>
                 </a:path>
               </a:pathLst>
             </a:custGeom>
-            <a:ln w="14782" cap="flat">
+            <a:ln w="11086" cap="flat">
               <a:solidFill>
                 <a:srgbClr val="333333">
                   <a:alpha val="100000"/>
@@ -5869,23 +5869,23 @@
           </p:nvSpPr>
           <p:spPr>
             <a:xfrm>
-              <a:off x="2063773" y="2286519"/>
-              <a:ext cx="37957" cy="0"/>
+              <a:off x="1807485" y="2501704"/>
+              <a:ext cx="28468" cy="0"/>
             </a:xfrm>
             <a:custGeom>
               <a:avLst/>
               <a:pathLst>
-                <a:path w="37957" h="0">
+                <a:path w="28468" h="0">
                   <a:moveTo>
                     <a:pt x="0" y="0"/>
                   </a:moveTo>
                   <a:lnTo>
-                    <a:pt x="37957" y="0"/>
+                    <a:pt x="28468" y="0"/>
                   </a:lnTo>
                 </a:path>
               </a:pathLst>
             </a:custGeom>
-            <a:ln w="14782" cap="flat">
+            <a:ln w="11086" cap="flat">
               <a:solidFill>
                 <a:srgbClr val="333333">
                   <a:alpha val="100000"/>
@@ -5909,23 +5909,23 @@
           </p:nvSpPr>
           <p:spPr>
             <a:xfrm>
-              <a:off x="2063773" y="2066493"/>
-              <a:ext cx="37957" cy="0"/>
+              <a:off x="1807485" y="2234899"/>
+              <a:ext cx="28468" cy="0"/>
             </a:xfrm>
             <a:custGeom>
               <a:avLst/>
               <a:pathLst>
-                <a:path w="37957" h="0">
+                <a:path w="28468" h="0">
                   <a:moveTo>
                     <a:pt x="0" y="0"/>
                   </a:moveTo>
                   <a:lnTo>
-                    <a:pt x="37957" y="0"/>
+                    <a:pt x="28468" y="0"/>
                   </a:lnTo>
                 </a:path>
               </a:pathLst>
             </a:custGeom>
-            <a:ln w="14782" cap="flat">
+            <a:ln w="11086" cap="flat">
               <a:solidFill>
                 <a:srgbClr val="333333">
                   <a:alpha val="100000"/>
@@ -5949,23 +5949,23 @@
           </p:nvSpPr>
           <p:spPr>
             <a:xfrm>
-              <a:off x="2063773" y="1846467"/>
-              <a:ext cx="37957" cy="0"/>
+              <a:off x="1807485" y="1968093"/>
+              <a:ext cx="28468" cy="0"/>
             </a:xfrm>
             <a:custGeom>
               <a:avLst/>
               <a:pathLst>
-                <a:path w="37957" h="0">
+                <a:path w="28468" h="0">
                   <a:moveTo>
                     <a:pt x="0" y="0"/>
                   </a:moveTo>
                   <a:lnTo>
-                    <a:pt x="37957" y="0"/>
+                    <a:pt x="28468" y="0"/>
                   </a:lnTo>
                 </a:path>
               </a:pathLst>
             </a:custGeom>
-            <a:ln w="14782" cap="flat">
+            <a:ln w="11086" cap="flat">
               <a:solidFill>
                 <a:srgbClr val="333333">
                   <a:alpha val="100000"/>
@@ -5989,23 +5989,23 @@
           </p:nvSpPr>
           <p:spPr>
             <a:xfrm>
-              <a:off x="2063773" y="1626441"/>
-              <a:ext cx="37957" cy="0"/>
+              <a:off x="1807485" y="1701288"/>
+              <a:ext cx="28468" cy="0"/>
             </a:xfrm>
             <a:custGeom>
               <a:avLst/>
               <a:pathLst>
-                <a:path w="37957" h="0">
+                <a:path w="28468" h="0">
                   <a:moveTo>
                     <a:pt x="0" y="0"/>
                   </a:moveTo>
                   <a:lnTo>
-                    <a:pt x="37957" y="0"/>
+                    <a:pt x="28468" y="0"/>
                   </a:lnTo>
                 </a:path>
               </a:pathLst>
             </a:custGeom>
-            <a:ln w="14782" cap="flat">
+            <a:ln w="11086" cap="flat">
               <a:solidFill>
                 <a:srgbClr val="333333">
                   <a:alpha val="100000"/>
@@ -6029,23 +6029,23 @@
           </p:nvSpPr>
           <p:spPr>
             <a:xfrm>
-              <a:off x="2063773" y="1406415"/>
-              <a:ext cx="37957" cy="0"/>
+              <a:off x="1807485" y="1434483"/>
+              <a:ext cx="28468" cy="0"/>
             </a:xfrm>
             <a:custGeom>
               <a:avLst/>
               <a:pathLst>
-                <a:path w="37957" h="0">
+                <a:path w="28468" h="0">
                   <a:moveTo>
                     <a:pt x="0" y="0"/>
                   </a:moveTo>
                   <a:lnTo>
-                    <a:pt x="37957" y="0"/>
+                    <a:pt x="28468" y="0"/>
                   </a:lnTo>
                 </a:path>
               </a:pathLst>
             </a:custGeom>
-            <a:ln w="14782" cap="flat">
+            <a:ln w="11086" cap="flat">
               <a:solidFill>
                 <a:srgbClr val="333333">
                   <a:alpha val="100000"/>
@@ -6069,23 +6069,23 @@
           </p:nvSpPr>
           <p:spPr>
             <a:xfrm>
-              <a:off x="2101731" y="4618794"/>
-              <a:ext cx="4119068" cy="0"/>
+              <a:off x="1835953" y="5329840"/>
+              <a:ext cx="5018446" cy="0"/>
             </a:xfrm>
             <a:custGeom>
               <a:avLst/>
               <a:pathLst>
-                <a:path w="4119068" h="0">
+                <a:path w="5018446" h="0">
                   <a:moveTo>
                     <a:pt x="0" y="0"/>
                   </a:moveTo>
                   <a:lnTo>
-                    <a:pt x="4119068" y="0"/>
+                    <a:pt x="5018446" y="0"/>
                   </a:lnTo>
                 </a:path>
               </a:pathLst>
             </a:custGeom>
-            <a:ln w="14782" cap="flat">
+            <a:ln w="11086" cap="flat">
               <a:solidFill>
                 <a:srgbClr val="000000">
                   <a:alpha val="100000"/>
@@ -6109,15 +6109,15 @@
           </p:nvSpPr>
           <p:spPr>
             <a:xfrm>
-              <a:off x="2328754" y="4618794"/>
-              <a:ext cx="0" cy="37957"/>
+              <a:off x="2112545" y="5329840"/>
+              <a:ext cx="0" cy="28468"/>
             </a:xfrm>
             <a:custGeom>
               <a:avLst/>
               <a:pathLst>
-                <a:path w="0" h="37957">
+                <a:path w="0" h="28468">
                   <a:moveTo>
-                    <a:pt x="0" y="37957"/>
+                    <a:pt x="0" y="28468"/>
                   </a:moveTo>
                   <a:lnTo>
                     <a:pt x="0" y="0"/>
@@ -6125,7 +6125,7 @@
                 </a:path>
               </a:pathLst>
             </a:custGeom>
-            <a:ln w="14782" cap="flat">
+            <a:ln w="11086" cap="flat">
               <a:solidFill>
                 <a:srgbClr val="333333">
                   <a:alpha val="100000"/>
@@ -6149,15 +6149,15 @@
           </p:nvSpPr>
           <p:spPr>
             <a:xfrm>
-              <a:off x="3266301" y="4618794"/>
-              <a:ext cx="0" cy="37957"/>
+              <a:off x="3254802" y="5329840"/>
+              <a:ext cx="0" cy="28468"/>
             </a:xfrm>
             <a:custGeom>
               <a:avLst/>
               <a:pathLst>
-                <a:path w="0" h="37957">
+                <a:path w="0" h="28468">
                   <a:moveTo>
-                    <a:pt x="0" y="37957"/>
+                    <a:pt x="0" y="28468"/>
                   </a:moveTo>
                   <a:lnTo>
                     <a:pt x="0" y="0"/>
@@ -6165,7 +6165,7 @@
                 </a:path>
               </a:pathLst>
             </a:custGeom>
-            <a:ln w="14782" cap="flat">
+            <a:ln w="11086" cap="flat">
               <a:solidFill>
                 <a:srgbClr val="333333">
                   <a:alpha val="100000"/>
@@ -6189,15 +6189,15 @@
           </p:nvSpPr>
           <p:spPr>
             <a:xfrm>
-              <a:off x="4203848" y="4618794"/>
-              <a:ext cx="0" cy="37957"/>
+              <a:off x="4397058" y="5329840"/>
+              <a:ext cx="0" cy="28468"/>
             </a:xfrm>
             <a:custGeom>
               <a:avLst/>
               <a:pathLst>
-                <a:path w="0" h="37957">
+                <a:path w="0" h="28468">
                   <a:moveTo>
-                    <a:pt x="0" y="37957"/>
+                    <a:pt x="0" y="28468"/>
                   </a:moveTo>
                   <a:lnTo>
                     <a:pt x="0" y="0"/>
@@ -6205,7 +6205,7 @@
                 </a:path>
               </a:pathLst>
             </a:custGeom>
-            <a:ln w="14782" cap="flat">
+            <a:ln w="11086" cap="flat">
               <a:solidFill>
                 <a:srgbClr val="333333">
                   <a:alpha val="100000"/>
@@ -6229,15 +6229,15 @@
           </p:nvSpPr>
           <p:spPr>
             <a:xfrm>
-              <a:off x="5141396" y="4618794"/>
-              <a:ext cx="0" cy="37957"/>
+              <a:off x="5539314" y="5329840"/>
+              <a:ext cx="0" cy="28468"/>
             </a:xfrm>
             <a:custGeom>
               <a:avLst/>
               <a:pathLst>
-                <a:path w="0" h="37957">
+                <a:path w="0" h="28468">
                   <a:moveTo>
-                    <a:pt x="0" y="37957"/>
+                    <a:pt x="0" y="28468"/>
                   </a:moveTo>
                   <a:lnTo>
                     <a:pt x="0" y="0"/>
@@ -6245,7 +6245,7 @@
                 </a:path>
               </a:pathLst>
             </a:custGeom>
-            <a:ln w="14782" cap="flat">
+            <a:ln w="11086" cap="flat">
               <a:solidFill>
                 <a:srgbClr val="333333">
                   <a:alpha val="100000"/>
@@ -6269,15 +6269,15 @@
           </p:nvSpPr>
           <p:spPr>
             <a:xfrm>
-              <a:off x="6078943" y="4618794"/>
-              <a:ext cx="0" cy="37957"/>
+              <a:off x="6681570" y="5329840"/>
+              <a:ext cx="0" cy="28468"/>
             </a:xfrm>
             <a:custGeom>
               <a:avLst/>
               <a:pathLst>
-                <a:path w="0" h="37957">
+                <a:path w="0" h="28468">
                   <a:moveTo>
-                    <a:pt x="0" y="37957"/>
+                    <a:pt x="0" y="28468"/>
                   </a:moveTo>
                   <a:lnTo>
                     <a:pt x="0" y="0"/>
@@ -6285,7 +6285,7 @@
                 </a:path>
               </a:pathLst>
             </a:custGeom>
-            <a:ln w="14782" cap="flat">
+            <a:ln w="11086" cap="flat">
               <a:solidFill>
                 <a:srgbClr val="333333">
                   <a:alpha val="100000"/>
@@ -6309,8 +6309,8 @@
           </p:nvSpPr>
           <p:spPr>
             <a:xfrm>
-              <a:off x="2169511" y="4687118"/>
-              <a:ext cx="318485" cy="100218"/>
+              <a:off x="1996737" y="5381083"/>
+              <a:ext cx="231617" cy="72877"/>
             </a:xfrm>
             <a:prstGeom prst="rect">
               <a:avLst/>
@@ -6323,7 +6323,7 @@
             <a:p>
               <a:pPr algn="l" marL="0" marR="0" indent="0">
                 <a:lnSpc>
-                  <a:spcPts val="1100"/>
+                  <a:spcPts val="800"/>
                 </a:lnSpc>
                 <a:spcBef>
                   <a:spcPts val="0"/>
@@ -6333,7 +6333,7 @@
                 </a:spcAft>
               </a:pPr>
               <a:r>
-                <a:rPr sz="1100">
+                <a:rPr sz="800">
                   <a:solidFill>
                     <a:srgbClr val="000000">
                       <a:alpha val="100000"/>
@@ -6355,8 +6355,8 @@
           </p:nvSpPr>
           <p:spPr>
             <a:xfrm>
-              <a:off x="3107058" y="4687118"/>
-              <a:ext cx="318485" cy="100218"/>
+              <a:off x="3138993" y="5381083"/>
+              <a:ext cx="231617" cy="72877"/>
             </a:xfrm>
             <a:prstGeom prst="rect">
               <a:avLst/>
@@ -6369,7 +6369,7 @@
             <a:p>
               <a:pPr algn="l" marL="0" marR="0" indent="0">
                 <a:lnSpc>
-                  <a:spcPts val="1100"/>
+                  <a:spcPts val="800"/>
                 </a:lnSpc>
                 <a:spcBef>
                   <a:spcPts val="0"/>
@@ -6379,7 +6379,7 @@
                 </a:spcAft>
               </a:pPr>
               <a:r>
-                <a:rPr sz="1100">
+                <a:rPr sz="800">
                   <a:solidFill>
                     <a:srgbClr val="000000">
                       <a:alpha val="100000"/>
@@ -6401,8 +6401,8 @@
           </p:nvSpPr>
           <p:spPr>
             <a:xfrm>
-              <a:off x="4067877" y="4687118"/>
-              <a:ext cx="271942" cy="100218"/>
+              <a:off x="4298165" y="5381083"/>
+              <a:ext cx="197784" cy="72877"/>
             </a:xfrm>
             <a:prstGeom prst="rect">
               <a:avLst/>
@@ -6415,7 +6415,7 @@
             <a:p>
               <a:pPr algn="l" marL="0" marR="0" indent="0">
                 <a:lnSpc>
-                  <a:spcPts val="1100"/>
+                  <a:spcPts val="800"/>
                 </a:lnSpc>
                 <a:spcBef>
                   <a:spcPts val="0"/>
@@ -6425,7 +6425,7 @@
                 </a:spcAft>
               </a:pPr>
               <a:r>
-                <a:rPr sz="1100">
+                <a:rPr sz="800">
                   <a:solidFill>
                     <a:srgbClr val="000000">
                       <a:alpha val="100000"/>
@@ -6447,8 +6447,8 @@
           </p:nvSpPr>
           <p:spPr>
             <a:xfrm>
-              <a:off x="5005425" y="4687118"/>
-              <a:ext cx="271942" cy="100218"/>
+              <a:off x="5440421" y="5381083"/>
+              <a:ext cx="197784" cy="72877"/>
             </a:xfrm>
             <a:prstGeom prst="rect">
               <a:avLst/>
@@ -6461,7 +6461,7 @@
             <a:p>
               <a:pPr algn="l" marL="0" marR="0" indent="0">
                 <a:lnSpc>
-                  <a:spcPts val="1100"/>
+                  <a:spcPts val="800"/>
                 </a:lnSpc>
                 <a:spcBef>
                   <a:spcPts val="0"/>
@@ -6471,7 +6471,7 @@
                 </a:spcAft>
               </a:pPr>
               <a:r>
-                <a:rPr sz="1100">
+                <a:rPr sz="800">
                   <a:solidFill>
                     <a:srgbClr val="000000">
                       <a:alpha val="100000"/>
@@ -6493,8 +6493,8 @@
           </p:nvSpPr>
           <p:spPr>
             <a:xfrm>
-              <a:off x="5942972" y="4687118"/>
-              <a:ext cx="271942" cy="100218"/>
+              <a:off x="6582677" y="5381083"/>
+              <a:ext cx="197784" cy="72877"/>
             </a:xfrm>
             <a:prstGeom prst="rect">
               <a:avLst/>
@@ -6507,7 +6507,7 @@
             <a:p>
               <a:pPr algn="l" marL="0" marR="0" indent="0">
                 <a:lnSpc>
-                  <a:spcPts val="1100"/>
+                  <a:spcPts val="800"/>
                 </a:lnSpc>
                 <a:spcBef>
                   <a:spcPts val="0"/>
@@ -6517,7 +6517,7 @@
                 </a:spcAft>
               </a:pPr>
               <a:r>
-                <a:rPr sz="1100">
+                <a:rPr sz="800">
                   <a:solidFill>
                     <a:srgbClr val="000000">
                       <a:alpha val="100000"/>
@@ -6539,8 +6539,8 @@
           </p:nvSpPr>
           <p:spPr>
             <a:xfrm>
-              <a:off x="2785047" y="4899982"/>
-              <a:ext cx="2752435" cy="118872"/>
+              <a:off x="3286164" y="5538719"/>
+              <a:ext cx="2118024" cy="91440"/>
             </a:xfrm>
             <a:prstGeom prst="rect">
               <a:avLst/>
@@ -6553,7 +6553,7 @@
             <a:p>
               <a:pPr algn="l" marL="0" marR="0" indent="0">
                 <a:lnSpc>
-                  <a:spcPts val="1300"/>
+                  <a:spcPts val="1000"/>
                 </a:lnSpc>
                 <a:spcBef>
                   <a:spcPts val="0"/>
@@ -6563,7 +6563,7 @@
                 </a:spcAft>
               </a:pPr>
               <a:r>
-                <a:rPr sz="1300" b="1">
+                <a:rPr sz="1000" b="1">
                   <a:solidFill>
                     <a:srgbClr val="000000">
                       <a:alpha val="100000"/>
@@ -6585,8 +6585,8 @@
           </p:nvSpPr>
           <p:spPr>
             <a:xfrm rot="-5400000">
-              <a:off x="938449" y="2887161"/>
-              <a:ext cx="357804" cy="118872"/>
+              <a:off x="974293" y="3256400"/>
+              <a:ext cx="275325" cy="91440"/>
             </a:xfrm>
             <a:prstGeom prst="rect">
               <a:avLst/>
@@ -6599,7 +6599,7 @@
             <a:p>
               <a:pPr algn="l" marL="0" marR="0" indent="0">
                 <a:lnSpc>
-                  <a:spcPts val="1300"/>
+                  <a:spcPts val="1000"/>
                 </a:lnSpc>
                 <a:spcBef>
                   <a:spcPts val="0"/>
@@ -6609,7 +6609,7 @@
                 </a:spcAft>
               </a:pPr>
               <a:r>
-                <a:rPr sz="1300" b="1">
+                <a:rPr sz="1000" b="1">
                   <a:solidFill>
                     <a:srgbClr val="000000">
                       <a:alpha val="100000"/>
@@ -6631,8 +6631,8 @@
           </p:nvSpPr>
           <p:spPr>
             <a:xfrm>
-              <a:off x="2721813" y="5163387"/>
-              <a:ext cx="2878904" cy="143012"/>
+              <a:off x="3239399" y="5738400"/>
+              <a:ext cx="2211555" cy="107999"/>
             </a:xfrm>
             <a:prstGeom prst="rect">
               <a:avLst/>
@@ -6657,8 +6657,8 @@
           </p:nvSpPr>
           <p:spPr>
             <a:xfrm>
-              <a:off x="2721813" y="5180212"/>
-              <a:ext cx="923178" cy="109362"/>
+              <a:off x="3239399" y="5751389"/>
+              <a:ext cx="692200" cy="82021"/>
             </a:xfrm>
             <a:prstGeom prst="rect">
               <a:avLst/>
@@ -6671,7 +6671,7 @@
             <a:p>
               <a:pPr algn="l" marL="0" marR="0" indent="0">
                 <a:lnSpc>
-                  <a:spcPts val="1200"/>
+                  <a:spcPts val="900"/>
                 </a:lnSpc>
                 <a:spcBef>
                   <a:spcPts val="0"/>
@@ -6681,7 +6681,7 @@
                 </a:spcAft>
               </a:pPr>
               <a:r>
-                <a:rPr sz="1200">
+                <a:rPr sz="900">
                   <a:solidFill>
                     <a:srgbClr val="000000">
                       <a:alpha val="100000"/>
@@ -6703,8 +6703,8 @@
           </p:nvSpPr>
           <p:spPr>
             <a:xfrm>
-              <a:off x="3720906" y="5177698"/>
-              <a:ext cx="107999" cy="114391"/>
+              <a:off x="3988536" y="5738400"/>
+              <a:ext cx="107999" cy="107999"/>
             </a:xfrm>
             <a:prstGeom prst="rect">
               <a:avLst/>
@@ -6729,7 +6729,103 @@
           </p:nvSpPr>
           <p:spPr>
             <a:xfrm>
-              <a:off x="3731706" y="5234893"/>
+              <a:off x="3999336" y="5792400"/>
+              <a:ext cx="86400" cy="0"/>
+            </a:xfrm>
+            <a:custGeom>
+              <a:avLst/>
+              <a:pathLst>
+                <a:path w="86400" h="0">
+                  <a:moveTo>
+                    <a:pt x="0" y="0"/>
+                  </a:moveTo>
+                  <a:lnTo>
+                    <a:pt x="86400" y="0"/>
+                  </a:lnTo>
+                </a:path>
+              </a:pathLst>
+            </a:custGeom>
+            <a:ln w="21681" cap="flat">
+              <a:solidFill>
+                <a:srgbClr val="2F7F6F">
+                  <a:alpha val="100000"/>
+                </a:srgbClr>
+              </a:solidFill>
+              <a:prstDash val="solid"/>
+              <a:round/>
+            </a:ln>
+          </p:spPr>
+          <p:txBody>
+            <a:bodyPr/>
+            <a:lstStyle/>
+            <a:p/>
+          </p:txBody>
+        </p:sp>
+        <p:sp>
+          <p:nvSpPr>
+            <p:cNvPr id="117" name="pt116"/>
+            <p:cNvSpPr/>
+            <p:nvPr/>
+          </p:nvSpPr>
+          <p:spPr>
+            <a:xfrm>
+              <a:off x="3991084" y="5740948"/>
+              <a:ext cx="102903" cy="102903"/>
+            </a:xfrm>
+            <a:prstGeom prst="ellipse">
+              <a:avLst/>
+            </a:prstGeom>
+            <a:ln w="21600" cap="rnd">
+              <a:solidFill>
+                <a:srgbClr val="2F7F6F">
+                  <a:alpha val="100000"/>
+                </a:srgbClr>
+              </a:solidFill>
+              <a:prstDash val="solid"/>
+              <a:round/>
+            </a:ln>
+          </p:spPr>
+          <p:txBody>
+            <a:bodyPr/>
+            <a:lstStyle/>
+            <a:p/>
+          </p:txBody>
+        </p:sp>
+        <p:sp>
+          <p:nvSpPr>
+            <p:cNvPr id="118" name="rc117"/>
+            <p:cNvSpPr/>
+            <p:nvPr/>
+          </p:nvSpPr>
+          <p:spPr>
+            <a:xfrm>
+              <a:off x="4753288" y="5738400"/>
+              <a:ext cx="107999" cy="107999"/>
+            </a:xfrm>
+            <a:prstGeom prst="rect">
+              <a:avLst/>
+            </a:prstGeom>
+            <a:solidFill>
+              <a:srgbClr val="FFFFFF">
+                <a:alpha val="100000"/>
+              </a:srgbClr>
+            </a:solidFill>
+          </p:spPr>
+          <p:txBody>
+            <a:bodyPr/>
+            <a:lstStyle/>
+            <a:p/>
+          </p:txBody>
+        </p:sp>
+        <p:sp>
+          <p:nvSpPr>
+            <p:cNvPr id="119" name="pl118"/>
+            <p:cNvSpPr/>
+            <p:nvPr/>
+          </p:nvSpPr>
+          <p:spPr>
+            <a:xfrm>
+              <a:off x="4764088" y="5792400"/>
               <a:ext cx="86399" cy="0"/>
             </a:xfrm>
             <a:custGeom>
@@ -6747,29 +6843,29 @@
             </a:custGeom>
             <a:ln w="21681" cap="flat">
               <a:solidFill>
-                <a:srgbClr val="2F7F6F">
-                  <a:alpha val="100000"/>
-                </a:srgbClr>
-              </a:solidFill>
-              <a:prstDash val="solid"/>
-              <a:round/>
-            </a:ln>
-          </p:spPr>
-          <p:txBody>
-            <a:bodyPr/>
-            <a:lstStyle/>
-            <a:p/>
-          </p:txBody>
-        </p:sp>
-        <p:sp>
-          <p:nvSpPr>
-            <p:cNvPr id="117" name="pt116"/>
-            <p:cNvSpPr/>
-            <p:nvPr/>
-          </p:nvSpPr>
-          <p:spPr>
-            <a:xfrm>
-              <a:off x="3723454" y="5183442"/>
+                <a:srgbClr val="9C6B2F">
+                  <a:alpha val="100000"/>
+                </a:srgbClr>
+              </a:solidFill>
+              <a:prstDash val="solid"/>
+              <a:round/>
+            </a:ln>
+          </p:spPr>
+          <p:txBody>
+            <a:bodyPr/>
+            <a:lstStyle/>
+            <a:p/>
+          </p:txBody>
+        </p:sp>
+        <p:sp>
+          <p:nvSpPr>
+            <p:cNvPr id="120" name="pt119"/>
+            <p:cNvSpPr/>
+            <p:nvPr/>
+          </p:nvSpPr>
+          <p:spPr>
+            <a:xfrm>
+              <a:off x="4755836" y="5740948"/>
               <a:ext cx="102903" cy="102903"/>
             </a:xfrm>
             <a:prstGeom prst="ellipse">
@@ -6777,72 +6873,6 @@
             </a:prstGeom>
             <a:ln w="21600" cap="rnd">
               <a:solidFill>
-                <a:srgbClr val="2F7F6F">
-                  <a:alpha val="100000"/>
-                </a:srgbClr>
-              </a:solidFill>
-              <a:prstDash val="solid"/>
-              <a:round/>
-            </a:ln>
-          </p:spPr>
-          <p:txBody>
-            <a:bodyPr/>
-            <a:lstStyle/>
-            <a:p/>
-          </p:txBody>
-        </p:sp>
-        <p:sp>
-          <p:nvSpPr>
-            <p:cNvPr id="118" name="rc117"/>
-            <p:cNvSpPr/>
-            <p:nvPr/>
-          </p:nvSpPr>
-          <p:spPr>
-            <a:xfrm>
-              <a:off x="4705582" y="5177698"/>
-              <a:ext cx="107999" cy="114391"/>
-            </a:xfrm>
-            <a:prstGeom prst="rect">
-              <a:avLst/>
-            </a:prstGeom>
-            <a:solidFill>
-              <a:srgbClr val="FFFFFF">
-                <a:alpha val="100000"/>
-              </a:srgbClr>
-            </a:solidFill>
-          </p:spPr>
-          <p:txBody>
-            <a:bodyPr/>
-            <a:lstStyle/>
-            <a:p/>
-          </p:txBody>
-        </p:sp>
-        <p:sp>
-          <p:nvSpPr>
-            <p:cNvPr id="119" name="pl118"/>
-            <p:cNvSpPr/>
-            <p:nvPr/>
-          </p:nvSpPr>
-          <p:spPr>
-            <a:xfrm>
-              <a:off x="4716382" y="5234893"/>
-              <a:ext cx="86399" cy="0"/>
-            </a:xfrm>
-            <a:custGeom>
-              <a:avLst/>
-              <a:pathLst>
-                <a:path w="86399" h="0">
-                  <a:moveTo>
-                    <a:pt x="0" y="0"/>
-                  </a:moveTo>
-                  <a:lnTo>
-                    <a:pt x="86399" y="0"/>
-                  </a:lnTo>
-                </a:path>
-              </a:pathLst>
-            </a:custGeom>
-            <a:ln w="21681" cap="flat">
-              <a:solidFill>
                 <a:srgbClr val="9C6B2F">
                   <a:alpha val="100000"/>
                 </a:srgbClr>
@@ -6859,44 +6889,14 @@
         </p:sp>
         <p:sp>
           <p:nvSpPr>
-            <p:cNvPr id="120" name="pt119"/>
-            <p:cNvSpPr/>
-            <p:nvPr/>
-          </p:nvSpPr>
-          <p:spPr>
-            <a:xfrm>
-              <a:off x="4708130" y="5183442"/>
-              <a:ext cx="102903" cy="102903"/>
-            </a:xfrm>
-            <a:prstGeom prst="ellipse">
-              <a:avLst/>
-            </a:prstGeom>
-            <a:ln w="21600" cap="rnd">
-              <a:solidFill>
-                <a:srgbClr val="9C6B2F">
-                  <a:alpha val="100000"/>
-                </a:srgbClr>
-              </a:solidFill>
-              <a:prstDash val="solid"/>
-              <a:round/>
-            </a:ln>
-          </p:spPr>
-          <p:txBody>
-            <a:bodyPr/>
-            <a:lstStyle/>
-            <a:p/>
-          </p:txBody>
-        </p:sp>
-        <p:sp>
-          <p:nvSpPr>
             <p:cNvPr id="121" name="tx120"/>
             <p:cNvSpPr/>
             <p:nvPr/>
           </p:nvSpPr>
           <p:spPr>
             <a:xfrm>
-              <a:off x="3904822" y="5191185"/>
-              <a:ext cx="724844" cy="87416"/>
+              <a:off x="4153472" y="5759618"/>
+              <a:ext cx="542879" cy="65562"/>
             </a:xfrm>
             <a:prstGeom prst="rect">
               <a:avLst/>
@@ -6909,7 +6909,7 @@
             <a:p>
               <a:pPr algn="l" marL="0" marR="0" indent="0">
                 <a:lnSpc>
-                  <a:spcPts val="960"/>
+                  <a:spcPts val="720"/>
                 </a:lnSpc>
                 <a:spcBef>
                   <a:spcPts val="0"/>
@@ -6919,7 +6919,7 @@
                 </a:spcAft>
               </a:pPr>
               <a:r>
-                <a:rPr sz="960">
+                <a:rPr sz="720">
                   <a:solidFill>
                     <a:srgbClr val="000000">
                       <a:alpha val="100000"/>
@@ -6941,8 +6941,8 @@
           </p:nvSpPr>
           <p:spPr>
             <a:xfrm>
-              <a:off x="4889497" y="5191185"/>
-              <a:ext cx="711220" cy="87416"/>
+              <a:off x="4918225" y="5759618"/>
+              <a:ext cx="532729" cy="65562"/>
             </a:xfrm>
             <a:prstGeom prst="rect">
               <a:avLst/>
@@ -6955,7 +6955,7 @@
             <a:p>
               <a:pPr algn="l" marL="0" marR="0" indent="0">
                 <a:lnSpc>
-                  <a:spcPts val="960"/>
+                  <a:spcPts val="720"/>
                 </a:lnSpc>
                 <a:spcBef>
                   <a:spcPts val="0"/>
@@ -6965,7 +6965,7 @@
                 </a:spcAft>
               </a:pPr>
               <a:r>
-                <a:rPr sz="960">
+                <a:rPr sz="720">
                   <a:solidFill>
                     <a:srgbClr val="000000">
                       <a:alpha val="100000"/>

</xml_diff>

<commit_message>
Resize Fig.4 to 90x100mm (single-panel), down from 170x142mm double-column
</commit_message>
<xml_diff>
--- a/figures/Figure_4.pptx
+++ b/figures/Figure_4.pptx
@@ -2250,9 +2250,9 @@
         <p:grpSpPr>
           <a:xfrm>
             <a:off x="914400" y="914400"/>
-            <a:ext cx="6120000" cy="5112000"/>
+            <a:ext cx="3240000" cy="3600000"/>
             <a:chOff x="914400" y="914400"/>
-            <a:chExt cx="6120000" cy="5112000"/>
+            <a:chExt cx="3240000" cy="3600000"/>
           </a:xfrm>
         </p:grpSpPr>
         <p:sp>
@@ -2264,7 +2264,7 @@
           <p:spPr>
             <a:xfrm>
               <a:off x="914400" y="914400"/>
-              <a:ext cx="6120000" cy="5112000"/>
+              <a:ext cx="3240000" cy="3600000"/>
             </a:xfrm>
             <a:prstGeom prst="rect">
               <a:avLst/>
@@ -2299,7 +2299,7 @@
           <p:spPr>
             <a:xfrm>
               <a:off x="914400" y="914400"/>
-              <a:ext cx="6120000" cy="5112000"/>
+              <a:ext cx="3240000" cy="3600000"/>
             </a:xfrm>
             <a:prstGeom prst="rect">
               <a:avLst/>
@@ -2325,7 +2325,7 @@
           <p:spPr>
             <a:xfrm>
               <a:off x="1835679" y="1274399"/>
-              <a:ext cx="5018720" cy="4055714"/>
+              <a:ext cx="2138720" cy="2543714"/>
             </a:xfrm>
             <a:prstGeom prst="rect">
               <a:avLst/>
@@ -2350,15 +2350,15 @@
           </p:nvSpPr>
           <p:spPr>
             <a:xfrm>
-              <a:off x="4396923" y="1274399"/>
-              <a:ext cx="0" cy="4055714"/>
+              <a:off x="2927150" y="1274399"/>
+              <a:ext cx="0" cy="2543714"/>
             </a:xfrm>
             <a:custGeom>
               <a:avLst/>
               <a:pathLst>
-                <a:path w="0" h="4055714">
+                <a:path w="0" h="2543714">
                   <a:moveTo>
-                    <a:pt x="0" y="4055714"/>
+                    <a:pt x="0" y="2543714"/>
                   </a:moveTo>
                   <a:lnTo>
                     <a:pt x="0" y="0"/>
@@ -2393,15 +2393,15 @@
           </p:nvSpPr>
           <p:spPr>
             <a:xfrm>
-              <a:off x="4088658" y="1407811"/>
-              <a:ext cx="0" cy="53364"/>
+              <a:off x="2795783" y="1358074"/>
+              <a:ext cx="0" cy="33469"/>
             </a:xfrm>
             <a:custGeom>
               <a:avLst/>
               <a:pathLst>
-                <a:path w="0" h="53364">
+                <a:path w="0" h="33469">
                   <a:moveTo>
-                    <a:pt x="0" y="53364"/>
+                    <a:pt x="0" y="33469"/>
                   </a:moveTo>
                   <a:lnTo>
                     <a:pt x="0" y="0"/>
@@ -2433,15 +2433,15 @@
           </p:nvSpPr>
           <p:spPr>
             <a:xfrm>
-              <a:off x="3682304" y="1434494"/>
-              <a:ext cx="406354" cy="0"/>
+              <a:off x="2622616" y="1374809"/>
+              <a:ext cx="173167" cy="0"/>
             </a:xfrm>
             <a:custGeom>
               <a:avLst/>
               <a:pathLst>
-                <a:path w="406354" h="0">
+                <a:path w="173167" h="0">
                   <a:moveTo>
-                    <a:pt x="406354" y="0"/>
+                    <a:pt x="173167" y="0"/>
                   </a:moveTo>
                   <a:lnTo>
                     <a:pt x="0" y="0"/>
@@ -2473,15 +2473,15 @@
           </p:nvSpPr>
           <p:spPr>
             <a:xfrm>
-              <a:off x="3682304" y="1407811"/>
-              <a:ext cx="0" cy="53364"/>
+              <a:off x="2622616" y="1358074"/>
+              <a:ext cx="0" cy="33469"/>
             </a:xfrm>
             <a:custGeom>
               <a:avLst/>
               <a:pathLst>
-                <a:path w="0" h="53364">
+                <a:path w="0" h="33469">
                   <a:moveTo>
-                    <a:pt x="0" y="53364"/>
+                    <a:pt x="0" y="33469"/>
                   </a:moveTo>
                   <a:lnTo>
                     <a:pt x="0" y="0"/>
@@ -2513,15 +2513,15 @@
           </p:nvSpPr>
           <p:spPr>
             <a:xfrm>
-              <a:off x="6428057" y="1674635"/>
-              <a:ext cx="0" cy="53364"/>
+              <a:off x="3792714" y="1525424"/>
+              <a:ext cx="0" cy="33469"/>
             </a:xfrm>
             <a:custGeom>
               <a:avLst/>
               <a:pathLst>
-                <a:path w="0" h="53364">
+                <a:path w="0" h="33469">
                   <a:moveTo>
-                    <a:pt x="0" y="53364"/>
+                    <a:pt x="0" y="33469"/>
                   </a:moveTo>
                   <a:lnTo>
                     <a:pt x="0" y="0"/>
@@ -2553,15 +2553,15 @@
           </p:nvSpPr>
           <p:spPr>
             <a:xfrm>
-              <a:off x="4649012" y="1701317"/>
-              <a:ext cx="1779044" cy="0"/>
+              <a:off x="3034577" y="1542159"/>
+              <a:ext cx="758137" cy="0"/>
             </a:xfrm>
             <a:custGeom>
               <a:avLst/>
               <a:pathLst>
-                <a:path w="1779044" h="0">
+                <a:path w="758137" h="0">
                   <a:moveTo>
-                    <a:pt x="1779044" y="0"/>
+                    <a:pt x="758137" y="0"/>
                   </a:moveTo>
                   <a:lnTo>
                     <a:pt x="0" y="0"/>
@@ -2593,15 +2593,15 @@
           </p:nvSpPr>
           <p:spPr>
             <a:xfrm>
-              <a:off x="4649012" y="1674635"/>
-              <a:ext cx="0" cy="53364"/>
+              <a:off x="3034577" y="1525424"/>
+              <a:ext cx="0" cy="33469"/>
             </a:xfrm>
             <a:custGeom>
               <a:avLst/>
               <a:pathLst>
-                <a:path w="0" h="53364">
+                <a:path w="0" h="33469">
                   <a:moveTo>
-                    <a:pt x="0" y="53364"/>
+                    <a:pt x="0" y="33469"/>
                   </a:moveTo>
                   <a:lnTo>
                     <a:pt x="0" y="0"/>
@@ -2633,15 +2633,15 @@
           </p:nvSpPr>
           <p:spPr>
             <a:xfrm>
-              <a:off x="6567559" y="1941458"/>
-              <a:ext cx="0" cy="53364"/>
+              <a:off x="3852163" y="1692774"/>
+              <a:ext cx="0" cy="33469"/>
             </a:xfrm>
             <a:custGeom>
               <a:avLst/>
               <a:pathLst>
-                <a:path w="0" h="53364">
+                <a:path w="0" h="33469">
                   <a:moveTo>
-                    <a:pt x="0" y="53364"/>
+                    <a:pt x="0" y="33469"/>
                   </a:moveTo>
                   <a:lnTo>
                     <a:pt x="0" y="0"/>
@@ -2673,15 +2673,15 @@
           </p:nvSpPr>
           <p:spPr>
             <a:xfrm>
-              <a:off x="4839920" y="1968140"/>
-              <a:ext cx="1727639" cy="0"/>
+              <a:off x="3115932" y="1709509"/>
+              <a:ext cx="736230" cy="0"/>
             </a:xfrm>
             <a:custGeom>
               <a:avLst/>
               <a:pathLst>
-                <a:path w="1727639" h="0">
+                <a:path w="736230" h="0">
                   <a:moveTo>
-                    <a:pt x="1727639" y="0"/>
+                    <a:pt x="736230" y="0"/>
                   </a:moveTo>
                   <a:lnTo>
                     <a:pt x="0" y="0"/>
@@ -2713,15 +2713,15 @@
           </p:nvSpPr>
           <p:spPr>
             <a:xfrm>
-              <a:off x="4839920" y="1941458"/>
-              <a:ext cx="0" cy="53364"/>
+              <a:off x="3115932" y="1692774"/>
+              <a:ext cx="0" cy="33469"/>
             </a:xfrm>
             <a:custGeom>
               <a:avLst/>
               <a:pathLst>
-                <a:path w="0" h="53364">
+                <a:path w="0" h="33469">
                   <a:moveTo>
-                    <a:pt x="0" y="53364"/>
+                    <a:pt x="0" y="33469"/>
                   </a:moveTo>
                   <a:lnTo>
                     <a:pt x="0" y="0"/>
@@ -2753,15 +2753,15 @@
           </p:nvSpPr>
           <p:spPr>
             <a:xfrm>
-              <a:off x="4352769" y="2208281"/>
-              <a:ext cx="0" cy="53364"/>
+              <a:off x="2908333" y="1860123"/>
+              <a:ext cx="0" cy="33469"/>
             </a:xfrm>
             <a:custGeom>
               <a:avLst/>
               <a:pathLst>
-                <a:path w="0" h="53364">
+                <a:path w="0" h="33469">
                   <a:moveTo>
-                    <a:pt x="0" y="53364"/>
+                    <a:pt x="0" y="33469"/>
                   </a:moveTo>
                   <a:lnTo>
                     <a:pt x="0" y="0"/>
@@ -2793,15 +2793,15 @@
           </p:nvSpPr>
           <p:spPr>
             <a:xfrm>
-              <a:off x="3418989" y="2234964"/>
-              <a:ext cx="933780" cy="0"/>
+              <a:off x="2510404" y="1876858"/>
+              <a:ext cx="397929" cy="0"/>
             </a:xfrm>
             <a:custGeom>
               <a:avLst/>
               <a:pathLst>
-                <a:path w="933780" h="0">
+                <a:path w="397929" h="0">
                   <a:moveTo>
-                    <a:pt x="933780" y="0"/>
+                    <a:pt x="397929" y="0"/>
                   </a:moveTo>
                   <a:lnTo>
                     <a:pt x="0" y="0"/>
@@ -2833,15 +2833,15 @@
           </p:nvSpPr>
           <p:spPr>
             <a:xfrm>
-              <a:off x="3418989" y="2208281"/>
-              <a:ext cx="0" cy="53364"/>
+              <a:off x="2510404" y="1860123"/>
+              <a:ext cx="0" cy="33469"/>
             </a:xfrm>
             <a:custGeom>
               <a:avLst/>
               <a:pathLst>
-                <a:path w="0" h="53364">
+                <a:path w="0" h="33469">
                   <a:moveTo>
-                    <a:pt x="0" y="53364"/>
+                    <a:pt x="0" y="33469"/>
                   </a:moveTo>
                   <a:lnTo>
                     <a:pt x="0" y="0"/>
@@ -2873,15 +2873,15 @@
           </p:nvSpPr>
           <p:spPr>
             <a:xfrm>
-              <a:off x="3731706" y="2475105"/>
-              <a:ext cx="0" cy="53364"/>
+              <a:off x="2643668" y="2027473"/>
+              <a:ext cx="0" cy="33469"/>
             </a:xfrm>
             <a:custGeom>
               <a:avLst/>
               <a:pathLst>
-                <a:path w="0" h="53364">
+                <a:path w="0" h="33469">
                   <a:moveTo>
-                    <a:pt x="0" y="53364"/>
+                    <a:pt x="0" y="33469"/>
                   </a:moveTo>
                   <a:lnTo>
                     <a:pt x="0" y="0"/>
@@ -2913,15 +2913,15 @@
           </p:nvSpPr>
           <p:spPr>
             <a:xfrm>
-              <a:off x="2063803" y="2501787"/>
-              <a:ext cx="1667903" cy="0"/>
+              <a:off x="1932894" y="2044208"/>
+              <a:ext cx="710774" cy="0"/>
             </a:xfrm>
             <a:custGeom>
               <a:avLst/>
               <a:pathLst>
-                <a:path w="1667903" h="0">
+                <a:path w="710774" h="0">
                   <a:moveTo>
-                    <a:pt x="1667903" y="0"/>
+                    <a:pt x="710774" y="0"/>
                   </a:moveTo>
                   <a:lnTo>
                     <a:pt x="0" y="0"/>
@@ -2953,15 +2953,15 @@
           </p:nvSpPr>
           <p:spPr>
             <a:xfrm>
-              <a:off x="2063803" y="2475105"/>
-              <a:ext cx="0" cy="53364"/>
+              <a:off x="1932894" y="2027473"/>
+              <a:ext cx="0" cy="33469"/>
             </a:xfrm>
             <a:custGeom>
               <a:avLst/>
               <a:pathLst>
-                <a:path w="0" h="53364">
+                <a:path w="0" h="33469">
                   <a:moveTo>
-                    <a:pt x="0" y="53364"/>
+                    <a:pt x="0" y="33469"/>
                   </a:moveTo>
                   <a:lnTo>
                     <a:pt x="0" y="0"/>
@@ -2993,15 +2993,15 @@
           </p:nvSpPr>
           <p:spPr>
             <a:xfrm>
-              <a:off x="5883312" y="2741928"/>
-              <a:ext cx="0" cy="53364"/>
+              <a:off x="3560572" y="2194823"/>
+              <a:ext cx="0" cy="33469"/>
             </a:xfrm>
             <a:custGeom>
               <a:avLst/>
               <a:pathLst>
-                <a:path w="0" h="53364">
+                <a:path w="0" h="33469">
                   <a:moveTo>
-                    <a:pt x="0" y="53364"/>
+                    <a:pt x="0" y="33469"/>
                   </a:moveTo>
                   <a:lnTo>
                     <a:pt x="0" y="0"/>
@@ -3033,15 +3033,15 @@
           </p:nvSpPr>
           <p:spPr>
             <a:xfrm>
-              <a:off x="3838239" y="2768610"/>
-              <a:ext cx="2045073" cy="0"/>
+              <a:off x="2689067" y="2211558"/>
+              <a:ext cx="871504" cy="0"/>
             </a:xfrm>
             <a:custGeom>
               <a:avLst/>
               <a:pathLst>
-                <a:path w="2045073" h="0">
+                <a:path w="871504" h="0">
                   <a:moveTo>
-                    <a:pt x="2045073" y="0"/>
+                    <a:pt x="871504" y="0"/>
                   </a:moveTo>
                   <a:lnTo>
                     <a:pt x="0" y="0"/>
@@ -3073,15 +3073,15 @@
           </p:nvSpPr>
           <p:spPr>
             <a:xfrm>
-              <a:off x="3838239" y="2741928"/>
-              <a:ext cx="0" cy="53364"/>
+              <a:off x="2689067" y="2194823"/>
+              <a:ext cx="0" cy="33469"/>
             </a:xfrm>
             <a:custGeom>
               <a:avLst/>
               <a:pathLst>
-                <a:path w="0" h="53364">
+                <a:path w="0" h="33469">
                   <a:moveTo>
-                    <a:pt x="0" y="53364"/>
+                    <a:pt x="0" y="33469"/>
                   </a:moveTo>
                   <a:lnTo>
                     <a:pt x="0" y="0"/>
@@ -3113,15 +3113,15 @@
           </p:nvSpPr>
           <p:spPr>
             <a:xfrm>
-              <a:off x="4863449" y="3008751"/>
-              <a:ext cx="0" cy="53364"/>
+              <a:off x="3125959" y="2362172"/>
+              <a:ext cx="0" cy="33469"/>
             </a:xfrm>
             <a:custGeom>
               <a:avLst/>
               <a:pathLst>
-                <a:path w="0" h="53364">
+                <a:path w="0" h="33469">
                   <a:moveTo>
-                    <a:pt x="0" y="53364"/>
+                    <a:pt x="0" y="33469"/>
                   </a:moveTo>
                   <a:lnTo>
                     <a:pt x="0" y="0"/>
@@ -3153,15 +3153,15 @@
           </p:nvSpPr>
           <p:spPr>
             <a:xfrm>
-              <a:off x="4276541" y="3035434"/>
-              <a:ext cx="586908" cy="0"/>
+              <a:off x="2875849" y="2378907"/>
+              <a:ext cx="250110" cy="0"/>
             </a:xfrm>
             <a:custGeom>
               <a:avLst/>
               <a:pathLst>
-                <a:path w="586908" h="0">
+                <a:path w="250110" h="0">
                   <a:moveTo>
-                    <a:pt x="586908" y="0"/>
+                    <a:pt x="250110" y="0"/>
                   </a:moveTo>
                   <a:lnTo>
                     <a:pt x="0" y="0"/>
@@ -3193,15 +3193,15 @@
           </p:nvSpPr>
           <p:spPr>
             <a:xfrm>
-              <a:off x="4276541" y="3008751"/>
-              <a:ext cx="0" cy="53364"/>
+              <a:off x="2875849" y="2362172"/>
+              <a:ext cx="0" cy="33469"/>
             </a:xfrm>
             <a:custGeom>
               <a:avLst/>
               <a:pathLst>
-                <a:path w="0" h="53364">
+                <a:path w="0" h="33469">
                   <a:moveTo>
-                    <a:pt x="0" y="53364"/>
+                    <a:pt x="0" y="33469"/>
                   </a:moveTo>
                   <a:lnTo>
                     <a:pt x="0" y="0"/>
@@ -3233,15 +3233,15 @@
           </p:nvSpPr>
           <p:spPr>
             <a:xfrm>
-              <a:off x="6626276" y="3275575"/>
-              <a:ext cx="0" cy="53364"/>
+              <a:off x="3877185" y="2529522"/>
+              <a:ext cx="0" cy="33469"/>
             </a:xfrm>
             <a:custGeom>
               <a:avLst/>
               <a:pathLst>
-                <a:path w="0" h="53364">
+                <a:path w="0" h="33469">
                   <a:moveTo>
-                    <a:pt x="0" y="53364"/>
+                    <a:pt x="0" y="33469"/>
                   </a:moveTo>
                   <a:lnTo>
                     <a:pt x="0" y="0"/>
@@ -3273,15 +3273,15 @@
           </p:nvSpPr>
           <p:spPr>
             <a:xfrm>
-              <a:off x="5118239" y="3302257"/>
-              <a:ext cx="1508036" cy="0"/>
+              <a:off x="3234537" y="2546257"/>
+              <a:ext cx="642647" cy="0"/>
             </a:xfrm>
             <a:custGeom>
               <a:avLst/>
               <a:pathLst>
-                <a:path w="1508036" h="0">
+                <a:path w="642647" h="0">
                   <a:moveTo>
-                    <a:pt x="1508036" y="0"/>
+                    <a:pt x="642647" y="0"/>
                   </a:moveTo>
                   <a:lnTo>
                     <a:pt x="0" y="0"/>
@@ -3313,15 +3313,15 @@
           </p:nvSpPr>
           <p:spPr>
             <a:xfrm>
-              <a:off x="5118239" y="3275575"/>
-              <a:ext cx="0" cy="53364"/>
+              <a:off x="3234537" y="2529522"/>
+              <a:ext cx="0" cy="33469"/>
             </a:xfrm>
             <a:custGeom>
               <a:avLst/>
               <a:pathLst>
-                <a:path w="0" h="53364">
+                <a:path w="0" h="33469">
                   <a:moveTo>
-                    <a:pt x="0" y="53364"/>
+                    <a:pt x="0" y="33469"/>
                   </a:moveTo>
                   <a:lnTo>
                     <a:pt x="0" y="0"/>
@@ -3353,15 +3353,15 @@
           </p:nvSpPr>
           <p:spPr>
             <a:xfrm>
-              <a:off x="4605562" y="3542398"/>
-              <a:ext cx="0" cy="53364"/>
+              <a:off x="3016061" y="2696872"/>
+              <a:ext cx="0" cy="33469"/>
             </a:xfrm>
             <a:custGeom>
               <a:avLst/>
               <a:pathLst>
-                <a:path w="0" h="53364">
+                <a:path w="0" h="33469">
                   <a:moveTo>
-                    <a:pt x="0" y="53364"/>
+                    <a:pt x="0" y="33469"/>
                   </a:moveTo>
                   <a:lnTo>
                     <a:pt x="0" y="0"/>
@@ -3393,15 +3393,15 @@
           </p:nvSpPr>
           <p:spPr>
             <a:xfrm>
-              <a:off x="3665700" y="3569080"/>
-              <a:ext cx="939862" cy="0"/>
+              <a:off x="2615540" y="2713607"/>
+              <a:ext cx="400521" cy="0"/>
             </a:xfrm>
             <a:custGeom>
               <a:avLst/>
               <a:pathLst>
-                <a:path w="939862" h="0">
+                <a:path w="400521" h="0">
                   <a:moveTo>
-                    <a:pt x="939862" y="0"/>
+                    <a:pt x="400521" y="0"/>
                   </a:moveTo>
                   <a:lnTo>
                     <a:pt x="0" y="0"/>
@@ -3433,15 +3433,15 @@
           </p:nvSpPr>
           <p:spPr>
             <a:xfrm>
-              <a:off x="3665700" y="3542398"/>
-              <a:ext cx="0" cy="53364"/>
+              <a:off x="2615540" y="2696872"/>
+              <a:ext cx="0" cy="33469"/>
             </a:xfrm>
             <a:custGeom>
               <a:avLst/>
               <a:pathLst>
-                <a:path w="0" h="53364">
+                <a:path w="0" h="33469">
                   <a:moveTo>
-                    <a:pt x="0" y="53364"/>
+                    <a:pt x="0" y="33469"/>
                   </a:moveTo>
                   <a:lnTo>
                     <a:pt x="0" y="0"/>
@@ -3473,15 +3473,15 @@
           </p:nvSpPr>
           <p:spPr>
             <a:xfrm>
-              <a:off x="4274399" y="3809221"/>
-              <a:ext cx="0" cy="53364"/>
+              <a:off x="2874936" y="2864221"/>
+              <a:ext cx="0" cy="33469"/>
             </a:xfrm>
             <a:custGeom>
               <a:avLst/>
               <a:pathLst>
-                <a:path w="0" h="53364">
+                <a:path w="0" h="33469">
                   <a:moveTo>
-                    <a:pt x="0" y="53364"/>
+                    <a:pt x="0" y="33469"/>
                   </a:moveTo>
                   <a:lnTo>
                     <a:pt x="0" y="0"/>
@@ -3513,15 +3513,15 @@
           </p:nvSpPr>
           <p:spPr>
             <a:xfrm>
-              <a:off x="3291685" y="3835904"/>
-              <a:ext cx="982713" cy="0"/>
+              <a:off x="2456154" y="2880956"/>
+              <a:ext cx="418782" cy="0"/>
             </a:xfrm>
             <a:custGeom>
               <a:avLst/>
               <a:pathLst>
-                <a:path w="982713" h="0">
+                <a:path w="418782" h="0">
                   <a:moveTo>
-                    <a:pt x="982713" y="0"/>
+                    <a:pt x="418782" y="0"/>
                   </a:moveTo>
                   <a:lnTo>
                     <a:pt x="0" y="0"/>
@@ -3553,15 +3553,15 @@
           </p:nvSpPr>
           <p:spPr>
             <a:xfrm>
-              <a:off x="3291685" y="3809221"/>
-              <a:ext cx="0" cy="53364"/>
+              <a:off x="2456154" y="2864221"/>
+              <a:ext cx="0" cy="33469"/>
             </a:xfrm>
             <a:custGeom>
               <a:avLst/>
               <a:pathLst>
-                <a:path w="0" h="53364">
+                <a:path w="0" h="33469">
                   <a:moveTo>
-                    <a:pt x="0" y="53364"/>
+                    <a:pt x="0" y="33469"/>
                   </a:moveTo>
                   <a:lnTo>
                     <a:pt x="0" y="0"/>
@@ -3593,15 +3593,15 @@
           </p:nvSpPr>
           <p:spPr>
             <a:xfrm>
-              <a:off x="5780839" y="4076045"/>
-              <a:ext cx="0" cy="53364"/>
+              <a:off x="3516903" y="3031571"/>
+              <a:ext cx="0" cy="33469"/>
             </a:xfrm>
             <a:custGeom>
               <a:avLst/>
               <a:pathLst>
-                <a:path w="0" h="53364">
+                <a:path w="0" h="33469">
                   <a:moveTo>
-                    <a:pt x="0" y="53364"/>
+                    <a:pt x="0" y="33469"/>
                   </a:moveTo>
                   <a:lnTo>
                     <a:pt x="0" y="0"/>
@@ -3633,15 +3633,15 @@
           </p:nvSpPr>
           <p:spPr>
             <a:xfrm>
-              <a:off x="4852875" y="4102727"/>
-              <a:ext cx="927963" cy="0"/>
+              <a:off x="3121453" y="3048306"/>
+              <a:ext cx="395450" cy="0"/>
             </a:xfrm>
             <a:custGeom>
               <a:avLst/>
               <a:pathLst>
-                <a:path w="927963" h="0">
+                <a:path w="395450" h="0">
                   <a:moveTo>
-                    <a:pt x="927963" y="0"/>
+                    <a:pt x="395450" y="0"/>
                   </a:moveTo>
                   <a:lnTo>
                     <a:pt x="0" y="0"/>
@@ -3673,15 +3673,15 @@
           </p:nvSpPr>
           <p:spPr>
             <a:xfrm>
-              <a:off x="4852875" y="4076045"/>
-              <a:ext cx="0" cy="53364"/>
+              <a:off x="3121453" y="3031571"/>
+              <a:ext cx="0" cy="33469"/>
             </a:xfrm>
             <a:custGeom>
               <a:avLst/>
               <a:pathLst>
-                <a:path w="0" h="53364">
+                <a:path w="0" h="33469">
                   <a:moveTo>
-                    <a:pt x="0" y="53364"/>
+                    <a:pt x="0" y="33469"/>
                   </a:moveTo>
                   <a:lnTo>
                     <a:pt x="0" y="0"/>
@@ -3713,15 +3713,15 @@
           </p:nvSpPr>
           <p:spPr>
             <a:xfrm>
-              <a:off x="5551727" y="4342868"/>
-              <a:ext cx="0" cy="53364"/>
+              <a:off x="3419268" y="3198921"/>
+              <a:ext cx="0" cy="33469"/>
             </a:xfrm>
             <a:custGeom>
               <a:avLst/>
               <a:pathLst>
-                <a:path w="0" h="53364">
+                <a:path w="0" h="33469">
                   <a:moveTo>
-                    <a:pt x="0" y="53364"/>
+                    <a:pt x="0" y="33469"/>
                   </a:moveTo>
                   <a:lnTo>
                     <a:pt x="0" y="0"/>
@@ -3753,15 +3753,15 @@
           </p:nvSpPr>
           <p:spPr>
             <a:xfrm>
-              <a:off x="3120636" y="4369550"/>
-              <a:ext cx="2431091" cy="0"/>
+              <a:off x="2383261" y="3215656"/>
+              <a:ext cx="1036006" cy="0"/>
             </a:xfrm>
             <a:custGeom>
               <a:avLst/>
               <a:pathLst>
-                <a:path w="2431091" h="0">
+                <a:path w="1036006" h="0">
                   <a:moveTo>
-                    <a:pt x="2431091" y="0"/>
+                    <a:pt x="1036006" y="0"/>
                   </a:moveTo>
                   <a:lnTo>
                     <a:pt x="0" y="0"/>
@@ -3793,15 +3793,15 @@
           </p:nvSpPr>
           <p:spPr>
             <a:xfrm>
-              <a:off x="3120636" y="4342868"/>
-              <a:ext cx="0" cy="53364"/>
+              <a:off x="2383261" y="3198921"/>
+              <a:ext cx="0" cy="33469"/>
             </a:xfrm>
             <a:custGeom>
               <a:avLst/>
               <a:pathLst>
-                <a:path w="0" h="53364">
+                <a:path w="0" h="33469">
                   <a:moveTo>
-                    <a:pt x="0" y="53364"/>
+                    <a:pt x="0" y="33469"/>
                   </a:moveTo>
                   <a:lnTo>
                     <a:pt x="0" y="0"/>
@@ -3833,15 +3833,15 @@
           </p:nvSpPr>
           <p:spPr>
             <a:xfrm>
-              <a:off x="5025076" y="4609691"/>
-              <a:ext cx="0" cy="53364"/>
+              <a:off x="3194836" y="3366270"/>
+              <a:ext cx="0" cy="33469"/>
             </a:xfrm>
             <a:custGeom>
               <a:avLst/>
               <a:pathLst>
-                <a:path w="0" h="53364">
+                <a:path w="0" h="33469">
                   <a:moveTo>
-                    <a:pt x="0" y="53364"/>
+                    <a:pt x="0" y="33469"/>
                   </a:moveTo>
                   <a:lnTo>
                     <a:pt x="0" y="0"/>
@@ -3873,15 +3873,15 @@
           </p:nvSpPr>
           <p:spPr>
             <a:xfrm>
-              <a:off x="2701857" y="4636374"/>
-              <a:ext cx="2323219" cy="0"/>
+              <a:off x="2204799" y="3383005"/>
+              <a:ext cx="990036" cy="0"/>
             </a:xfrm>
             <a:custGeom>
               <a:avLst/>
               <a:pathLst>
-                <a:path w="2323219" h="0">
+                <a:path w="990036" h="0">
                   <a:moveTo>
-                    <a:pt x="2323219" y="0"/>
+                    <a:pt x="990036" y="0"/>
                   </a:moveTo>
                   <a:lnTo>
                     <a:pt x="0" y="0"/>
@@ -3913,15 +3913,15 @@
           </p:nvSpPr>
           <p:spPr>
             <a:xfrm>
-              <a:off x="2701857" y="4609691"/>
-              <a:ext cx="0" cy="53364"/>
+              <a:off x="2204799" y="3366270"/>
+              <a:ext cx="0" cy="33469"/>
             </a:xfrm>
             <a:custGeom>
               <a:avLst/>
               <a:pathLst>
-                <a:path w="0" h="53364">
+                <a:path w="0" h="33469">
                   <a:moveTo>
-                    <a:pt x="0" y="53364"/>
+                    <a:pt x="0" y="33469"/>
                   </a:moveTo>
                   <a:lnTo>
                     <a:pt x="0" y="0"/>
@@ -3953,15 +3953,15 @@
           </p:nvSpPr>
           <p:spPr>
             <a:xfrm>
-              <a:off x="5400066" y="4876515"/>
-              <a:ext cx="0" cy="53364"/>
+              <a:off x="3354637" y="3533620"/>
+              <a:ext cx="0" cy="33469"/>
             </a:xfrm>
             <a:custGeom>
               <a:avLst/>
               <a:pathLst>
-                <a:path w="0" h="53364">
+                <a:path w="0" h="33469">
                   <a:moveTo>
-                    <a:pt x="0" y="53364"/>
+                    <a:pt x="0" y="33469"/>
                   </a:moveTo>
                   <a:lnTo>
                     <a:pt x="0" y="0"/>
@@ -3993,15 +3993,15 @@
           </p:nvSpPr>
           <p:spPr>
             <a:xfrm>
-              <a:off x="2888727" y="4903197"/>
-              <a:ext cx="2511339" cy="0"/>
+              <a:off x="2284434" y="3550355"/>
+              <a:ext cx="1070203" cy="0"/>
             </a:xfrm>
             <a:custGeom>
               <a:avLst/>
               <a:pathLst>
-                <a:path w="2511339" h="0">
+                <a:path w="1070203" h="0">
                   <a:moveTo>
-                    <a:pt x="2511339" y="0"/>
+                    <a:pt x="1070203" y="0"/>
                   </a:moveTo>
                   <a:lnTo>
                     <a:pt x="0" y="0"/>
@@ -4033,15 +4033,15 @@
           </p:nvSpPr>
           <p:spPr>
             <a:xfrm>
-              <a:off x="2888727" y="4876515"/>
-              <a:ext cx="0" cy="53364"/>
+              <a:off x="2284434" y="3533620"/>
+              <a:ext cx="0" cy="33469"/>
             </a:xfrm>
             <a:custGeom>
               <a:avLst/>
               <a:pathLst>
-                <a:path w="0" h="53364">
+                <a:path w="0" h="33469">
                   <a:moveTo>
-                    <a:pt x="0" y="53364"/>
+                    <a:pt x="0" y="33469"/>
                   </a:moveTo>
                   <a:lnTo>
                     <a:pt x="0" y="0"/>
@@ -4073,15 +4073,15 @@
           </p:nvSpPr>
           <p:spPr>
             <a:xfrm>
-              <a:off x="3967614" y="5143338"/>
-              <a:ext cx="0" cy="53364"/>
+              <a:off x="2744200" y="3700970"/>
+              <a:ext cx="0" cy="33469"/>
             </a:xfrm>
             <a:custGeom>
               <a:avLst/>
               <a:pathLst>
-                <a:path w="0" h="53364">
+                <a:path w="0" h="33469">
                   <a:moveTo>
-                    <a:pt x="0" y="53364"/>
+                    <a:pt x="0" y="33469"/>
                   </a:moveTo>
                   <a:lnTo>
                     <a:pt x="0" y="0"/>
@@ -4113,15 +4113,15 @@
           </p:nvSpPr>
           <p:spPr>
             <a:xfrm>
-              <a:off x="3024469" y="5170020"/>
-              <a:ext cx="943145" cy="0"/>
+              <a:off x="2342280" y="3717705"/>
+              <a:ext cx="401920" cy="0"/>
             </a:xfrm>
             <a:custGeom>
               <a:avLst/>
               <a:pathLst>
-                <a:path w="943145" h="0">
+                <a:path w="401920" h="0">
                   <a:moveTo>
-                    <a:pt x="943145" y="0"/>
+                    <a:pt x="401920" y="0"/>
                   </a:moveTo>
                   <a:lnTo>
                     <a:pt x="0" y="0"/>
@@ -4153,15 +4153,15 @@
           </p:nvSpPr>
           <p:spPr>
             <a:xfrm>
-              <a:off x="3024469" y="5143338"/>
-              <a:ext cx="0" cy="53364"/>
+              <a:off x="2342280" y="3700970"/>
+              <a:ext cx="0" cy="33469"/>
             </a:xfrm>
             <a:custGeom>
               <a:avLst/>
               <a:pathLst>
-                <a:path w="0" h="53364">
+                <a:path w="0" h="33469">
                   <a:moveTo>
-                    <a:pt x="0" y="53364"/>
+                    <a:pt x="0" y="33469"/>
                   </a:moveTo>
                   <a:lnTo>
                     <a:pt x="0" y="0"/>
@@ -4193,7 +4193,7 @@
           </p:nvSpPr>
           <p:spPr>
             <a:xfrm>
-              <a:off x="3834030" y="1383042"/>
+              <a:off x="2657747" y="1323357"/>
               <a:ext cx="102903" cy="102903"/>
             </a:xfrm>
             <a:prstGeom prst="ellipse">
@@ -4228,7 +4228,7 @@
           </p:nvSpPr>
           <p:spPr>
             <a:xfrm>
-              <a:off x="5487083" y="1649865"/>
+              <a:off x="3362194" y="1490707"/>
               <a:ext cx="102903" cy="102903"/>
             </a:xfrm>
             <a:prstGeom prst="ellipse">
@@ -4263,7 +4263,7 @@
           </p:nvSpPr>
           <p:spPr>
             <a:xfrm>
-              <a:off x="5652287" y="1916688"/>
+              <a:off x="3432595" y="1658057"/>
               <a:ext cx="102903" cy="102903"/>
             </a:xfrm>
             <a:prstGeom prst="ellipse">
@@ -4298,7 +4298,7 @@
           </p:nvSpPr>
           <p:spPr>
             <a:xfrm>
-              <a:off x="3834427" y="2183512"/>
+              <a:off x="2657917" y="1825406"/>
               <a:ext cx="102903" cy="102903"/>
             </a:xfrm>
             <a:prstGeom prst="ellipse">
@@ -4333,7 +4333,7 @@
           </p:nvSpPr>
           <p:spPr>
             <a:xfrm>
-              <a:off x="2846302" y="2450335"/>
+              <a:off x="2236829" y="1992756"/>
               <a:ext cx="102903" cy="102903"/>
             </a:xfrm>
             <a:prstGeom prst="ellipse">
@@ -4368,7 +4368,7 @@
           </p:nvSpPr>
           <p:spPr>
             <a:xfrm>
-              <a:off x="4809323" y="2717158"/>
+              <a:off x="3073368" y="2160106"/>
               <a:ext cx="102903" cy="102903"/>
             </a:xfrm>
             <a:prstGeom prst="ellipse">
@@ -4403,7 +4403,7 @@
           </p:nvSpPr>
           <p:spPr>
             <a:xfrm>
-              <a:off x="4518543" y="2983982"/>
+              <a:off x="2949452" y="2327455"/>
               <a:ext cx="102903" cy="102903"/>
             </a:xfrm>
             <a:prstGeom prst="ellipse">
@@ -4438,7 +4438,7 @@
           </p:nvSpPr>
           <p:spPr>
             <a:xfrm>
-              <a:off x="5820806" y="3250805"/>
+              <a:off x="3504409" y="2494805"/>
               <a:ext cx="102903" cy="102903"/>
             </a:xfrm>
             <a:prstGeom prst="ellipse">
@@ -4473,7 +4473,7 @@
           </p:nvSpPr>
           <p:spPr>
             <a:xfrm>
-              <a:off x="4084179" y="3517628"/>
+              <a:off x="2764348" y="2662155"/>
               <a:ext cx="102903" cy="102903"/>
             </a:xfrm>
             <a:prstGeom prst="ellipse">
@@ -4508,7 +4508,7 @@
           </p:nvSpPr>
           <p:spPr>
             <a:xfrm>
-              <a:off x="3731590" y="3784452"/>
+              <a:off x="2614093" y="2829504"/>
               <a:ext cx="102903" cy="102903"/>
             </a:xfrm>
             <a:prstGeom prst="ellipse">
@@ -4543,7 +4543,7 @@
           </p:nvSpPr>
           <p:spPr>
             <a:xfrm>
-              <a:off x="5265405" y="4051275"/>
+              <a:off x="3267726" y="2996854"/>
               <a:ext cx="102903" cy="102903"/>
             </a:xfrm>
             <a:prstGeom prst="ellipse">
@@ -4578,7 +4578,7 @@
           </p:nvSpPr>
           <p:spPr>
             <a:xfrm>
-              <a:off x="4284730" y="4318098"/>
+              <a:off x="2849813" y="3164204"/>
               <a:ext cx="102903" cy="102903"/>
             </a:xfrm>
             <a:prstGeom prst="ellipse">
@@ -4613,7 +4613,7 @@
           </p:nvSpPr>
           <p:spPr>
             <a:xfrm>
-              <a:off x="3812014" y="4584922"/>
+              <a:off x="2648366" y="3331553"/>
               <a:ext cx="102903" cy="102903"/>
             </a:xfrm>
             <a:prstGeom prst="ellipse">
@@ -4648,7 +4648,7 @@
           </p:nvSpPr>
           <p:spPr>
             <a:xfrm>
-              <a:off x="4092945" y="4851745"/>
+              <a:off x="2768084" y="3498903"/>
               <a:ext cx="102903" cy="102903"/>
             </a:xfrm>
             <a:prstGeom prst="ellipse">
@@ -4683,7 +4683,7 @@
           </p:nvSpPr>
           <p:spPr>
             <a:xfrm>
-              <a:off x="3444590" y="5118568"/>
+              <a:off x="2491788" y="3666253"/>
               <a:ext cx="102903" cy="102903"/>
             </a:xfrm>
             <a:prstGeom prst="ellipse">
@@ -4719,7 +4719,7 @@
           <p:spPr>
             <a:xfrm>
               <a:off x="1835679" y="1274399"/>
-              <a:ext cx="5018720" cy="4055714"/>
+              <a:ext cx="2138720" cy="2543714"/>
             </a:xfrm>
             <a:prstGeom prst="rect">
               <a:avLst/>
@@ -4740,14 +4740,14 @@
           <p:spPr>
             <a:xfrm>
               <a:off x="1835679" y="1274399"/>
-              <a:ext cx="0" cy="4055714"/>
+              <a:ext cx="0" cy="2543714"/>
             </a:xfrm>
             <a:custGeom>
               <a:avLst/>
               <a:pathLst>
-                <a:path w="0" h="4055714">
+                <a:path w="0" h="2543714">
                   <a:moveTo>
-                    <a:pt x="0" y="4055714"/>
+                    <a:pt x="0" y="2543714"/>
                   </a:moveTo>
                   <a:lnTo>
                     <a:pt x="0" y="0"/>
@@ -4779,7 +4779,7 @@
           </p:nvSpPr>
           <p:spPr>
             <a:xfrm>
-              <a:off x="1253627" y="5133581"/>
+              <a:off x="1253627" y="3681266"/>
               <a:ext cx="530809" cy="72877"/>
             </a:xfrm>
             <a:prstGeom prst="rect">
@@ -4825,7 +4825,7 @@
           </p:nvSpPr>
           <p:spPr>
             <a:xfrm>
-              <a:off x="1253627" y="4866758"/>
+              <a:off x="1253627" y="3513916"/>
               <a:ext cx="530809" cy="72877"/>
             </a:xfrm>
             <a:prstGeom prst="rect">
@@ -4871,7 +4871,7 @@
           </p:nvSpPr>
           <p:spPr>
             <a:xfrm>
-              <a:off x="1575587" y="4599935"/>
+              <a:off x="1575587" y="3346566"/>
               <a:ext cx="208848" cy="72877"/>
             </a:xfrm>
             <a:prstGeom prst="rect">
@@ -4917,7 +4917,7 @@
           </p:nvSpPr>
           <p:spPr>
             <a:xfrm>
-              <a:off x="1575679" y="4333111"/>
+              <a:off x="1575679" y="3179217"/>
               <a:ext cx="208757" cy="72877"/>
             </a:xfrm>
             <a:prstGeom prst="rect">
@@ -4963,7 +4963,7 @@
           </p:nvSpPr>
           <p:spPr>
             <a:xfrm>
-              <a:off x="1637766" y="4066288"/>
+              <a:off x="1637766" y="3011867"/>
               <a:ext cx="146669" cy="72877"/>
             </a:xfrm>
             <a:prstGeom prst="rect">
@@ -5009,7 +5009,7 @@
           </p:nvSpPr>
           <p:spPr>
             <a:xfrm>
-              <a:off x="1586834" y="3799465"/>
+              <a:off x="1586834" y="2844517"/>
               <a:ext cx="197601" cy="72877"/>
             </a:xfrm>
             <a:prstGeom prst="rect">
@@ -5055,7 +5055,7 @@
           </p:nvSpPr>
           <p:spPr>
             <a:xfrm>
-              <a:off x="1242197" y="3532641"/>
+              <a:off x="1242197" y="2677168"/>
               <a:ext cx="542239" cy="72877"/>
             </a:xfrm>
             <a:prstGeom prst="rect">
@@ -5101,7 +5101,7 @@
           </p:nvSpPr>
           <p:spPr>
             <a:xfrm>
-              <a:off x="1242197" y="3265818"/>
+              <a:off x="1242197" y="2509818"/>
               <a:ext cx="542239" cy="72877"/>
             </a:xfrm>
             <a:prstGeom prst="rect">
@@ -5147,7 +5147,7 @@
           </p:nvSpPr>
           <p:spPr>
             <a:xfrm>
-              <a:off x="1490731" y="2998995"/>
+              <a:off x="1490731" y="2342468"/>
               <a:ext cx="293705" cy="72877"/>
             </a:xfrm>
             <a:prstGeom prst="rect">
@@ -5193,7 +5193,7 @@
           </p:nvSpPr>
           <p:spPr>
             <a:xfrm>
-              <a:off x="1632006" y="2732171"/>
+              <a:off x="1632006" y="2175119"/>
               <a:ext cx="152430" cy="72877"/>
             </a:xfrm>
             <a:prstGeom prst="rect">
@@ -5239,7 +5239,7 @@
           </p:nvSpPr>
           <p:spPr>
             <a:xfrm>
-              <a:off x="1575587" y="2465348"/>
+              <a:off x="1575587" y="2007769"/>
               <a:ext cx="208848" cy="72877"/>
             </a:xfrm>
             <a:prstGeom prst="rect">
@@ -5285,7 +5285,7 @@
           </p:nvSpPr>
           <p:spPr>
             <a:xfrm>
-              <a:off x="1496583" y="2198525"/>
+              <a:off x="1496583" y="1840419"/>
               <a:ext cx="287853" cy="72877"/>
             </a:xfrm>
             <a:prstGeom prst="rect">
@@ -5331,7 +5331,7 @@
           </p:nvSpPr>
           <p:spPr>
             <a:xfrm>
-              <a:off x="1592412" y="1931701"/>
+              <a:off x="1592412" y="1673070"/>
               <a:ext cx="192024" cy="72877"/>
             </a:xfrm>
             <a:prstGeom prst="rect">
@@ -5377,7 +5377,7 @@
           </p:nvSpPr>
           <p:spPr>
             <a:xfrm>
-              <a:off x="1575496" y="1664878"/>
+              <a:off x="1575496" y="1505720"/>
               <a:ext cx="208940" cy="72877"/>
             </a:xfrm>
             <a:prstGeom prst="rect">
@@ -5423,7 +5423,7 @@
           </p:nvSpPr>
           <p:spPr>
             <a:xfrm>
-              <a:off x="1586834" y="1398055"/>
+              <a:off x="1586834" y="1338370"/>
               <a:ext cx="197601" cy="72877"/>
             </a:xfrm>
             <a:prstGeom prst="rect">
@@ -5469,7 +5469,7 @@
           </p:nvSpPr>
           <p:spPr>
             <a:xfrm>
-              <a:off x="1807211" y="5170020"/>
+              <a:off x="1807211" y="3717705"/>
               <a:ext cx="28468" cy="0"/>
             </a:xfrm>
             <a:custGeom>
@@ -5509,7 +5509,7 @@
           </p:nvSpPr>
           <p:spPr>
             <a:xfrm>
-              <a:off x="1807211" y="4903197"/>
+              <a:off x="1807211" y="3550355"/>
               <a:ext cx="28468" cy="0"/>
             </a:xfrm>
             <a:custGeom>
@@ -5549,7 +5549,7 @@
           </p:nvSpPr>
           <p:spPr>
             <a:xfrm>
-              <a:off x="1807211" y="4636374"/>
+              <a:off x="1807211" y="3383005"/>
               <a:ext cx="28468" cy="0"/>
             </a:xfrm>
             <a:custGeom>
@@ -5589,7 +5589,7 @@
           </p:nvSpPr>
           <p:spPr>
             <a:xfrm>
-              <a:off x="1807211" y="4369550"/>
+              <a:off x="1807211" y="3215656"/>
               <a:ext cx="28468" cy="0"/>
             </a:xfrm>
             <a:custGeom>
@@ -5629,7 +5629,7 @@
           </p:nvSpPr>
           <p:spPr>
             <a:xfrm>
-              <a:off x="1807211" y="4102727"/>
+              <a:off x="1807211" y="3048306"/>
               <a:ext cx="28468" cy="0"/>
             </a:xfrm>
             <a:custGeom>
@@ -5669,7 +5669,7 @@
           </p:nvSpPr>
           <p:spPr>
             <a:xfrm>
-              <a:off x="1807211" y="3835904"/>
+              <a:off x="1807211" y="2880956"/>
               <a:ext cx="28468" cy="0"/>
             </a:xfrm>
             <a:custGeom>
@@ -5709,7 +5709,7 @@
           </p:nvSpPr>
           <p:spPr>
             <a:xfrm>
-              <a:off x="1807211" y="3569080"/>
+              <a:off x="1807211" y="2713607"/>
               <a:ext cx="28468" cy="0"/>
             </a:xfrm>
             <a:custGeom>
@@ -5749,7 +5749,7 @@
           </p:nvSpPr>
           <p:spPr>
             <a:xfrm>
-              <a:off x="1807211" y="3302257"/>
+              <a:off x="1807211" y="2546257"/>
               <a:ext cx="28468" cy="0"/>
             </a:xfrm>
             <a:custGeom>
@@ -5789,7 +5789,7 @@
           </p:nvSpPr>
           <p:spPr>
             <a:xfrm>
-              <a:off x="1807211" y="3035434"/>
+              <a:off x="1807211" y="2378907"/>
               <a:ext cx="28468" cy="0"/>
             </a:xfrm>
             <a:custGeom>
@@ -5829,7 +5829,7 @@
           </p:nvSpPr>
           <p:spPr>
             <a:xfrm>
-              <a:off x="1807211" y="2768610"/>
+              <a:off x="1807211" y="2211558"/>
               <a:ext cx="28468" cy="0"/>
             </a:xfrm>
             <a:custGeom>
@@ -5869,7 +5869,7 @@
           </p:nvSpPr>
           <p:spPr>
             <a:xfrm>
-              <a:off x="1807211" y="2501787"/>
+              <a:off x="1807211" y="2044208"/>
               <a:ext cx="28468" cy="0"/>
             </a:xfrm>
             <a:custGeom>
@@ -5909,7 +5909,7 @@
           </p:nvSpPr>
           <p:spPr>
             <a:xfrm>
-              <a:off x="1807211" y="2234964"/>
+              <a:off x="1807211" y="1876858"/>
               <a:ext cx="28468" cy="0"/>
             </a:xfrm>
             <a:custGeom>
@@ -5949,7 +5949,7 @@
           </p:nvSpPr>
           <p:spPr>
             <a:xfrm>
-              <a:off x="1807211" y="1968140"/>
+              <a:off x="1807211" y="1709509"/>
               <a:ext cx="28468" cy="0"/>
             </a:xfrm>
             <a:custGeom>
@@ -5989,7 +5989,7 @@
           </p:nvSpPr>
           <p:spPr>
             <a:xfrm>
-              <a:off x="1807211" y="1701317"/>
+              <a:off x="1807211" y="1542159"/>
               <a:ext cx="28468" cy="0"/>
             </a:xfrm>
             <a:custGeom>
@@ -6029,7 +6029,7 @@
           </p:nvSpPr>
           <p:spPr>
             <a:xfrm>
-              <a:off x="1807211" y="1434494"/>
+              <a:off x="1807211" y="1374809"/>
               <a:ext cx="28468" cy="0"/>
             </a:xfrm>
             <a:custGeom>
@@ -6069,18 +6069,18 @@
           </p:nvSpPr>
           <p:spPr>
             <a:xfrm>
-              <a:off x="1835679" y="5330114"/>
-              <a:ext cx="5018720" cy="0"/>
+              <a:off x="1835679" y="3818114"/>
+              <a:ext cx="2138720" cy="0"/>
             </a:xfrm>
             <a:custGeom>
               <a:avLst/>
               <a:pathLst>
-                <a:path w="5018720" h="0">
+                <a:path w="2138720" h="0">
                   <a:moveTo>
                     <a:pt x="0" y="0"/>
                   </a:moveTo>
                   <a:lnTo>
-                    <a:pt x="5018720" y="0"/>
+                    <a:pt x="2138720" y="0"/>
                   </a:lnTo>
                 </a:path>
               </a:pathLst>
@@ -6109,7 +6109,7 @@
           </p:nvSpPr>
           <p:spPr>
             <a:xfrm>
-              <a:off x="2112286" y="5330114"/>
+              <a:off x="1953555" y="3818114"/>
               <a:ext cx="0" cy="28468"/>
             </a:xfrm>
             <a:custGeom>
@@ -6149,7 +6149,7 @@
           </p:nvSpPr>
           <p:spPr>
             <a:xfrm>
-              <a:off x="3254605" y="5330114"/>
+              <a:off x="2440352" y="3818114"/>
               <a:ext cx="0" cy="28468"/>
             </a:xfrm>
             <a:custGeom>
@@ -6189,7 +6189,7 @@
           </p:nvSpPr>
           <p:spPr>
             <a:xfrm>
-              <a:off x="4396923" y="5330114"/>
+              <a:off x="2927150" y="3818114"/>
               <a:ext cx="0" cy="28468"/>
             </a:xfrm>
             <a:custGeom>
@@ -6229,7 +6229,7 @@
           </p:nvSpPr>
           <p:spPr>
             <a:xfrm>
-              <a:off x="5539242" y="5330114"/>
+              <a:off x="3413947" y="3818114"/>
               <a:ext cx="0" cy="28468"/>
             </a:xfrm>
             <a:custGeom>
@@ -6269,7 +6269,7 @@
           </p:nvSpPr>
           <p:spPr>
             <a:xfrm>
-              <a:off x="6681560" y="5330114"/>
+              <a:off x="3900744" y="3818114"/>
               <a:ext cx="0" cy="28468"/>
             </a:xfrm>
             <a:custGeom>
@@ -6309,7 +6309,7 @@
           </p:nvSpPr>
           <p:spPr>
             <a:xfrm>
-              <a:off x="1996477" y="5381357"/>
+              <a:off x="1837746" y="3869357"/>
               <a:ext cx="231617" cy="72877"/>
             </a:xfrm>
             <a:prstGeom prst="rect">
@@ -6355,7 +6355,7 @@
           </p:nvSpPr>
           <p:spPr>
             <a:xfrm>
-              <a:off x="3138796" y="5381357"/>
+              <a:off x="2324543" y="3869357"/>
               <a:ext cx="231617" cy="72877"/>
             </a:xfrm>
             <a:prstGeom prst="rect">
@@ -6401,7 +6401,7 @@
           </p:nvSpPr>
           <p:spPr>
             <a:xfrm>
-              <a:off x="4298031" y="5381357"/>
+              <a:off x="2828257" y="3869357"/>
               <a:ext cx="197784" cy="72877"/>
             </a:xfrm>
             <a:prstGeom prst="rect">
@@ -6447,7 +6447,7 @@
           </p:nvSpPr>
           <p:spPr>
             <a:xfrm>
-              <a:off x="5440349" y="5381357"/>
+              <a:off x="3315055" y="3869357"/>
               <a:ext cx="197784" cy="72877"/>
             </a:xfrm>
             <a:prstGeom prst="rect">
@@ -6493,7 +6493,7 @@
           </p:nvSpPr>
           <p:spPr>
             <a:xfrm>
-              <a:off x="6582668" y="5381357"/>
+              <a:off x="3801852" y="3869357"/>
               <a:ext cx="197784" cy="72877"/>
             </a:xfrm>
             <a:prstGeom prst="rect">
@@ -6539,7 +6539,7 @@
           </p:nvSpPr>
           <p:spPr>
             <a:xfrm>
-              <a:off x="3367683" y="5538994"/>
+              <a:off x="1927683" y="4026994"/>
               <a:ext cx="1954712" cy="91165"/>
             </a:xfrm>
             <a:prstGeom prst="rect">
@@ -6585,7 +6585,7 @@
           </p:nvSpPr>
           <p:spPr>
             <a:xfrm rot="-5400000">
-              <a:off x="984809" y="3256674"/>
+              <a:off x="984809" y="2500674"/>
               <a:ext cx="254020" cy="91165"/>
             </a:xfrm>
             <a:prstGeom prst="rect">
@@ -6631,7 +6631,7 @@
           </p:nvSpPr>
           <p:spPr>
             <a:xfrm>
-              <a:off x="3239262" y="5738400"/>
+              <a:off x="1799262" y="4226400"/>
               <a:ext cx="2211555" cy="107999"/>
             </a:xfrm>
             <a:prstGeom prst="rect">
@@ -6657,7 +6657,7 @@
           </p:nvSpPr>
           <p:spPr>
             <a:xfrm>
-              <a:off x="3239262" y="5751389"/>
+              <a:off x="1799262" y="4239389"/>
               <a:ext cx="692200" cy="82021"/>
             </a:xfrm>
             <a:prstGeom prst="rect">
@@ -6703,7 +6703,7 @@
           </p:nvSpPr>
           <p:spPr>
             <a:xfrm>
-              <a:off x="3988399" y="5738400"/>
+              <a:off x="2548399" y="4226400"/>
               <a:ext cx="107999" cy="107999"/>
             </a:xfrm>
             <a:prstGeom prst="rect">
@@ -6729,7 +6729,103 @@
           </p:nvSpPr>
           <p:spPr>
             <a:xfrm>
-              <a:off x="3999199" y="5792400"/>
+              <a:off x="2559199" y="4280400"/>
+              <a:ext cx="86400" cy="0"/>
+            </a:xfrm>
+            <a:custGeom>
+              <a:avLst/>
+              <a:pathLst>
+                <a:path w="86400" h="0">
+                  <a:moveTo>
+                    <a:pt x="0" y="0"/>
+                  </a:moveTo>
+                  <a:lnTo>
+                    <a:pt x="86400" y="0"/>
+                  </a:lnTo>
+                </a:path>
+              </a:pathLst>
+            </a:custGeom>
+            <a:ln w="21681" cap="flat">
+              <a:solidFill>
+                <a:srgbClr val="2F7F6F">
+                  <a:alpha val="100000"/>
+                </a:srgbClr>
+              </a:solidFill>
+              <a:prstDash val="solid"/>
+              <a:round/>
+            </a:ln>
+          </p:spPr>
+          <p:txBody>
+            <a:bodyPr/>
+            <a:lstStyle/>
+            <a:p/>
+          </p:txBody>
+        </p:sp>
+        <p:sp>
+          <p:nvSpPr>
+            <p:cNvPr id="117" name="pt116"/>
+            <p:cNvSpPr/>
+            <p:nvPr/>
+          </p:nvSpPr>
+          <p:spPr>
+            <a:xfrm>
+              <a:off x="2550947" y="4228948"/>
+              <a:ext cx="102903" cy="102903"/>
+            </a:xfrm>
+            <a:prstGeom prst="ellipse">
+              <a:avLst/>
+            </a:prstGeom>
+            <a:ln w="21600" cap="rnd">
+              <a:solidFill>
+                <a:srgbClr val="2F7F6F">
+                  <a:alpha val="100000"/>
+                </a:srgbClr>
+              </a:solidFill>
+              <a:prstDash val="solid"/>
+              <a:round/>
+            </a:ln>
+          </p:spPr>
+          <p:txBody>
+            <a:bodyPr/>
+            <a:lstStyle/>
+            <a:p/>
+          </p:txBody>
+        </p:sp>
+        <p:sp>
+          <p:nvSpPr>
+            <p:cNvPr id="118" name="rc117"/>
+            <p:cNvSpPr/>
+            <p:nvPr/>
+          </p:nvSpPr>
+          <p:spPr>
+            <a:xfrm>
+              <a:off x="3313151" y="4226400"/>
+              <a:ext cx="107999" cy="107999"/>
+            </a:xfrm>
+            <a:prstGeom prst="rect">
+              <a:avLst/>
+            </a:prstGeom>
+            <a:solidFill>
+              <a:srgbClr val="FFFFFF">
+                <a:alpha val="100000"/>
+              </a:srgbClr>
+            </a:solidFill>
+          </p:spPr>
+          <p:txBody>
+            <a:bodyPr/>
+            <a:lstStyle/>
+            <a:p/>
+          </p:txBody>
+        </p:sp>
+        <p:sp>
+          <p:nvSpPr>
+            <p:cNvPr id="119" name="pl118"/>
+            <p:cNvSpPr/>
+            <p:nvPr/>
+          </p:nvSpPr>
+          <p:spPr>
+            <a:xfrm>
+              <a:off x="3323951" y="4280400"/>
               <a:ext cx="86399" cy="0"/>
             </a:xfrm>
             <a:custGeom>
@@ -6747,29 +6843,29 @@
             </a:custGeom>
             <a:ln w="21681" cap="flat">
               <a:solidFill>
-                <a:srgbClr val="2F7F6F">
-                  <a:alpha val="100000"/>
-                </a:srgbClr>
-              </a:solidFill>
-              <a:prstDash val="solid"/>
-              <a:round/>
-            </a:ln>
-          </p:spPr>
-          <p:txBody>
-            <a:bodyPr/>
-            <a:lstStyle/>
-            <a:p/>
-          </p:txBody>
-        </p:sp>
-        <p:sp>
-          <p:nvSpPr>
-            <p:cNvPr id="117" name="pt116"/>
-            <p:cNvSpPr/>
-            <p:nvPr/>
-          </p:nvSpPr>
-          <p:spPr>
-            <a:xfrm>
-              <a:off x="3990947" y="5740948"/>
+                <a:srgbClr val="9C6B2F">
+                  <a:alpha val="100000"/>
+                </a:srgbClr>
+              </a:solidFill>
+              <a:prstDash val="solid"/>
+              <a:round/>
+            </a:ln>
+          </p:spPr>
+          <p:txBody>
+            <a:bodyPr/>
+            <a:lstStyle/>
+            <a:p/>
+          </p:txBody>
+        </p:sp>
+        <p:sp>
+          <p:nvSpPr>
+            <p:cNvPr id="120" name="pt119"/>
+            <p:cNvSpPr/>
+            <p:nvPr/>
+          </p:nvSpPr>
+          <p:spPr>
+            <a:xfrm>
+              <a:off x="3315699" y="4228948"/>
               <a:ext cx="102903" cy="102903"/>
             </a:xfrm>
             <a:prstGeom prst="ellipse">
@@ -6777,72 +6873,6 @@
             </a:prstGeom>
             <a:ln w="21600" cap="rnd">
               <a:solidFill>
-                <a:srgbClr val="2F7F6F">
-                  <a:alpha val="100000"/>
-                </a:srgbClr>
-              </a:solidFill>
-              <a:prstDash val="solid"/>
-              <a:round/>
-            </a:ln>
-          </p:spPr>
-          <p:txBody>
-            <a:bodyPr/>
-            <a:lstStyle/>
-            <a:p/>
-          </p:txBody>
-        </p:sp>
-        <p:sp>
-          <p:nvSpPr>
-            <p:cNvPr id="118" name="rc117"/>
-            <p:cNvSpPr/>
-            <p:nvPr/>
-          </p:nvSpPr>
-          <p:spPr>
-            <a:xfrm>
-              <a:off x="4753151" y="5738400"/>
-              <a:ext cx="107999" cy="107999"/>
-            </a:xfrm>
-            <a:prstGeom prst="rect">
-              <a:avLst/>
-            </a:prstGeom>
-            <a:solidFill>
-              <a:srgbClr val="FFFFFF">
-                <a:alpha val="100000"/>
-              </a:srgbClr>
-            </a:solidFill>
-          </p:spPr>
-          <p:txBody>
-            <a:bodyPr/>
-            <a:lstStyle/>
-            <a:p/>
-          </p:txBody>
-        </p:sp>
-        <p:sp>
-          <p:nvSpPr>
-            <p:cNvPr id="119" name="pl118"/>
-            <p:cNvSpPr/>
-            <p:nvPr/>
-          </p:nvSpPr>
-          <p:spPr>
-            <a:xfrm>
-              <a:off x="4763951" y="5792400"/>
-              <a:ext cx="86399" cy="0"/>
-            </a:xfrm>
-            <a:custGeom>
-              <a:avLst/>
-              <a:pathLst>
-                <a:path w="86399" h="0">
-                  <a:moveTo>
-                    <a:pt x="0" y="0"/>
-                  </a:moveTo>
-                  <a:lnTo>
-                    <a:pt x="86399" y="0"/>
-                  </a:lnTo>
-                </a:path>
-              </a:pathLst>
-            </a:custGeom>
-            <a:ln w="21681" cap="flat">
-              <a:solidFill>
                 <a:srgbClr val="9C6B2F">
                   <a:alpha val="100000"/>
                 </a:srgbClr>
@@ -6859,43 +6889,13 @@
         </p:sp>
         <p:sp>
           <p:nvSpPr>
-            <p:cNvPr id="120" name="pt119"/>
-            <p:cNvSpPr/>
-            <p:nvPr/>
-          </p:nvSpPr>
-          <p:spPr>
-            <a:xfrm>
-              <a:off x="4755699" y="5740948"/>
-              <a:ext cx="102903" cy="102903"/>
-            </a:xfrm>
-            <a:prstGeom prst="ellipse">
-              <a:avLst/>
-            </a:prstGeom>
-            <a:ln w="21600" cap="rnd">
-              <a:solidFill>
-                <a:srgbClr val="9C6B2F">
-                  <a:alpha val="100000"/>
-                </a:srgbClr>
-              </a:solidFill>
-              <a:prstDash val="solid"/>
-              <a:round/>
-            </a:ln>
-          </p:spPr>
-          <p:txBody>
-            <a:bodyPr/>
-            <a:lstStyle/>
-            <a:p/>
-          </p:txBody>
-        </p:sp>
-        <p:sp>
-          <p:nvSpPr>
             <p:cNvPr id="121" name="tx120"/>
             <p:cNvSpPr/>
             <p:nvPr/>
           </p:nvSpPr>
           <p:spPr>
             <a:xfrm>
-              <a:off x="4153335" y="5759618"/>
+              <a:off x="2713335" y="4247618"/>
               <a:ext cx="542879" cy="65562"/>
             </a:xfrm>
             <a:prstGeom prst="rect">
@@ -6941,7 +6941,7 @@
           </p:nvSpPr>
           <p:spPr>
             <a:xfrm>
-              <a:off x="4918088" y="5759618"/>
+              <a:off x="3478088" y="4247618"/>
               <a:ext cx="532729" cy="65562"/>
             </a:xfrm>
             <a:prstGeom prst="rect">

</xml_diff>

<commit_message>
Italicize Slope/p in stat annotations, unify to 3 decimals; fix Fig.3 b/c text position
Slope and p labels across Fig.1/2/3 now use plotmath (parse=TRUE) so "Slope"
and "p" render in italics while surrounding text/numbers stay upright,
matching standard journal convention. All P-values now format to exactly
3 decimal places (sprintf instead of round(), which silently dropped
trailing zeros). Also unified margin (2/4/2/4pt) across all multi-panel
figures (Fig.2, S1, S2, S3 were still on the old 10pt default) and Fig.4's
own margin (previously inherited theme_Publication's 10mm default).

Fig.3 panel b/c annotation text repositioned to fixed y=20/18.5 and
y=1.2/1.1 respectively (near the top of each panel's actual scale) instead
of being computed from the data range.
</commit_message>
<xml_diff>
--- a/figures/Figure_4.pptx
+++ b/figures/Figure_4.pptx
@@ -2324,8 +2324,8 @@
           </p:nvSpPr>
           <p:spPr>
             <a:xfrm>
-              <a:off x="1835679" y="1274399"/>
-              <a:ext cx="2138720" cy="2543714"/>
+              <a:off x="1706289" y="939705"/>
+              <a:ext cx="2397500" cy="3033104"/>
             </a:xfrm>
             <a:prstGeom prst="rect">
               <a:avLst/>
@@ -2350,15 +2350,15 @@
           </p:nvSpPr>
           <p:spPr>
             <a:xfrm>
-              <a:off x="2927150" y="1274399"/>
-              <a:ext cx="0" cy="2543714"/>
+              <a:off x="2929825" y="939705"/>
+              <a:ext cx="0" cy="3033104"/>
             </a:xfrm>
             <a:custGeom>
               <a:avLst/>
               <a:pathLst>
-                <a:path w="0" h="2543714">
+                <a:path w="0" h="3033104">
                   <a:moveTo>
-                    <a:pt x="0" y="2543714"/>
+                    <a:pt x="0" y="3033104"/>
                   </a:moveTo>
                   <a:lnTo>
                     <a:pt x="0" y="0"/>
@@ -2393,15 +2393,15 @@
           </p:nvSpPr>
           <p:spPr>
             <a:xfrm>
-              <a:off x="2795783" y="1358074"/>
-              <a:ext cx="0" cy="33469"/>
+              <a:off x="2782563" y="1039478"/>
+              <a:ext cx="0" cy="39909"/>
             </a:xfrm>
             <a:custGeom>
               <a:avLst/>
               <a:pathLst>
-                <a:path w="0" h="33469">
+                <a:path w="0" h="39909">
                   <a:moveTo>
-                    <a:pt x="0" y="33469"/>
+                    <a:pt x="0" y="39909"/>
                   </a:moveTo>
                   <a:lnTo>
                     <a:pt x="0" y="0"/>
@@ -2433,15 +2433,15 @@
           </p:nvSpPr>
           <p:spPr>
             <a:xfrm>
-              <a:off x="2622616" y="1374809"/>
-              <a:ext cx="173167" cy="0"/>
+              <a:off x="2588443" y="1059432"/>
+              <a:ext cx="194120" cy="0"/>
             </a:xfrm>
             <a:custGeom>
               <a:avLst/>
               <a:pathLst>
-                <a:path w="173167" h="0">
+                <a:path w="194120" h="0">
                   <a:moveTo>
-                    <a:pt x="173167" y="0"/>
+                    <a:pt x="194120" y="0"/>
                   </a:moveTo>
                   <a:lnTo>
                     <a:pt x="0" y="0"/>
@@ -2473,15 +2473,15 @@
           </p:nvSpPr>
           <p:spPr>
             <a:xfrm>
-              <a:off x="2622616" y="1358074"/>
-              <a:ext cx="0" cy="33469"/>
+              <a:off x="2588443" y="1039478"/>
+              <a:ext cx="0" cy="39909"/>
             </a:xfrm>
             <a:custGeom>
               <a:avLst/>
               <a:pathLst>
-                <a:path w="0" h="33469">
+                <a:path w="0" h="39909">
                   <a:moveTo>
-                    <a:pt x="0" y="33469"/>
+                    <a:pt x="0" y="39909"/>
                   </a:moveTo>
                   <a:lnTo>
                     <a:pt x="0" y="0"/>
@@ -2513,15 +2513,15 @@
           </p:nvSpPr>
           <p:spPr>
             <a:xfrm>
-              <a:off x="3792714" y="1525424"/>
-              <a:ext cx="0" cy="33469"/>
+              <a:off x="3900120" y="1239024"/>
+              <a:ext cx="0" cy="39909"/>
             </a:xfrm>
             <a:custGeom>
               <a:avLst/>
               <a:pathLst>
-                <a:path w="0" h="33469">
+                <a:path w="0" h="39909">
                   <a:moveTo>
-                    <a:pt x="0" y="33469"/>
+                    <a:pt x="0" y="39909"/>
                   </a:moveTo>
                   <a:lnTo>
                     <a:pt x="0" y="0"/>
@@ -2553,15 +2553,15 @@
           </p:nvSpPr>
           <p:spPr>
             <a:xfrm>
-              <a:off x="3034577" y="1542159"/>
-              <a:ext cx="758137" cy="0"/>
+              <a:off x="3050251" y="1258979"/>
+              <a:ext cx="849869" cy="0"/>
             </a:xfrm>
             <a:custGeom>
               <a:avLst/>
               <a:pathLst>
-                <a:path w="758137" h="0">
+                <a:path w="849869" h="0">
                   <a:moveTo>
-                    <a:pt x="758137" y="0"/>
+                    <a:pt x="849869" y="0"/>
                   </a:moveTo>
                   <a:lnTo>
                     <a:pt x="0" y="0"/>
@@ -2593,15 +2593,15 @@
           </p:nvSpPr>
           <p:spPr>
             <a:xfrm>
-              <a:off x="3034577" y="1525424"/>
-              <a:ext cx="0" cy="33469"/>
+              <a:off x="3050251" y="1239024"/>
+              <a:ext cx="0" cy="39909"/>
             </a:xfrm>
             <a:custGeom>
               <a:avLst/>
               <a:pathLst>
-                <a:path w="0" h="33469">
+                <a:path w="0" h="39909">
                   <a:moveTo>
-                    <a:pt x="0" y="33469"/>
+                    <a:pt x="0" y="39909"/>
                   </a:moveTo>
                   <a:lnTo>
                     <a:pt x="0" y="0"/>
@@ -2633,15 +2633,15 @@
           </p:nvSpPr>
           <p:spPr>
             <a:xfrm>
-              <a:off x="3852163" y="1692774"/>
-              <a:ext cx="0" cy="33469"/>
+              <a:off x="3966762" y="1438570"/>
+              <a:ext cx="0" cy="39909"/>
             </a:xfrm>
             <a:custGeom>
               <a:avLst/>
               <a:pathLst>
-                <a:path w="0" h="33469">
+                <a:path w="0" h="39909">
                   <a:moveTo>
-                    <a:pt x="0" y="33469"/>
+                    <a:pt x="0" y="39909"/>
                   </a:moveTo>
                   <a:lnTo>
                     <a:pt x="0" y="0"/>
@@ -2673,15 +2673,15 @@
           </p:nvSpPr>
           <p:spPr>
             <a:xfrm>
-              <a:off x="3115932" y="1709509"/>
-              <a:ext cx="736230" cy="0"/>
+              <a:off x="3141449" y="1458525"/>
+              <a:ext cx="825312" cy="0"/>
             </a:xfrm>
             <a:custGeom>
               <a:avLst/>
               <a:pathLst>
-                <a:path w="736230" h="0">
+                <a:path w="825312" h="0">
                   <a:moveTo>
-                    <a:pt x="736230" y="0"/>
+                    <a:pt x="825312" y="0"/>
                   </a:moveTo>
                   <a:lnTo>
                     <a:pt x="0" y="0"/>
@@ -2713,15 +2713,15 @@
           </p:nvSpPr>
           <p:spPr>
             <a:xfrm>
-              <a:off x="3115932" y="1692774"/>
-              <a:ext cx="0" cy="33469"/>
+              <a:off x="3141449" y="1438570"/>
+              <a:ext cx="0" cy="39909"/>
             </a:xfrm>
             <a:custGeom>
               <a:avLst/>
               <a:pathLst>
-                <a:path w="0" h="33469">
+                <a:path w="0" h="39909">
                   <a:moveTo>
-                    <a:pt x="0" y="33469"/>
+                    <a:pt x="0" y="39909"/>
                   </a:moveTo>
                   <a:lnTo>
                     <a:pt x="0" y="0"/>
@@ -2753,15 +2753,15 @@
           </p:nvSpPr>
           <p:spPr>
             <a:xfrm>
-              <a:off x="2908333" y="1860123"/>
-              <a:ext cx="0" cy="33469"/>
+              <a:off x="2908732" y="1638117"/>
+              <a:ext cx="0" cy="39909"/>
             </a:xfrm>
             <a:custGeom>
               <a:avLst/>
               <a:pathLst>
-                <a:path w="0" h="33469">
+                <a:path w="0" h="39909">
                   <a:moveTo>
-                    <a:pt x="0" y="33469"/>
+                    <a:pt x="0" y="39909"/>
                   </a:moveTo>
                   <a:lnTo>
                     <a:pt x="0" y="0"/>
@@ -2793,15 +2793,15 @@
           </p:nvSpPr>
           <p:spPr>
             <a:xfrm>
-              <a:off x="2510404" y="1876858"/>
-              <a:ext cx="397929" cy="0"/>
+              <a:off x="2462654" y="1658071"/>
+              <a:ext cx="446077" cy="0"/>
             </a:xfrm>
             <a:custGeom>
               <a:avLst/>
               <a:pathLst>
-                <a:path w="397929" h="0">
+                <a:path w="446077" h="0">
                   <a:moveTo>
-                    <a:pt x="397929" y="0"/>
+                    <a:pt x="446077" y="0"/>
                   </a:moveTo>
                   <a:lnTo>
                     <a:pt x="0" y="0"/>
@@ -2833,15 +2833,15 @@
           </p:nvSpPr>
           <p:spPr>
             <a:xfrm>
-              <a:off x="2510404" y="1860123"/>
-              <a:ext cx="0" cy="33469"/>
+              <a:off x="2462654" y="1638117"/>
+              <a:ext cx="0" cy="39909"/>
             </a:xfrm>
             <a:custGeom>
               <a:avLst/>
               <a:pathLst>
-                <a:path w="0" h="33469">
+                <a:path w="0" h="39909">
                   <a:moveTo>
-                    <a:pt x="0" y="33469"/>
+                    <a:pt x="0" y="39909"/>
                   </a:moveTo>
                   <a:lnTo>
                     <a:pt x="0" y="0"/>
@@ -2873,15 +2873,15 @@
           </p:nvSpPr>
           <p:spPr>
             <a:xfrm>
-              <a:off x="2643668" y="2027473"/>
-              <a:ext cx="0" cy="33469"/>
+              <a:off x="2612043" y="1837663"/>
+              <a:ext cx="0" cy="39909"/>
             </a:xfrm>
             <a:custGeom>
               <a:avLst/>
               <a:pathLst>
-                <a:path w="0" h="33469">
+                <a:path w="0" h="39909">
                   <a:moveTo>
-                    <a:pt x="0" y="33469"/>
+                    <a:pt x="0" y="39909"/>
                   </a:moveTo>
                   <a:lnTo>
                     <a:pt x="0" y="0"/>
@@ -2913,15 +2913,15 @@
           </p:nvSpPr>
           <p:spPr>
             <a:xfrm>
-              <a:off x="1932894" y="2044208"/>
-              <a:ext cx="710774" cy="0"/>
+              <a:off x="1815266" y="1857618"/>
+              <a:ext cx="796776" cy="0"/>
             </a:xfrm>
             <a:custGeom>
               <a:avLst/>
               <a:pathLst>
-                <a:path w="710774" h="0">
+                <a:path w="796776" h="0">
                   <a:moveTo>
-                    <a:pt x="710774" y="0"/>
+                    <a:pt x="796776" y="0"/>
                   </a:moveTo>
                   <a:lnTo>
                     <a:pt x="0" y="0"/>
@@ -2953,15 +2953,15 @@
           </p:nvSpPr>
           <p:spPr>
             <a:xfrm>
-              <a:off x="1932894" y="2027473"/>
-              <a:ext cx="0" cy="33469"/>
+              <a:off x="1815266" y="1837663"/>
+              <a:ext cx="0" cy="39909"/>
             </a:xfrm>
             <a:custGeom>
               <a:avLst/>
               <a:pathLst>
-                <a:path w="0" h="33469">
+                <a:path w="0" h="39909">
                   <a:moveTo>
-                    <a:pt x="0" y="33469"/>
+                    <a:pt x="0" y="39909"/>
                   </a:moveTo>
                   <a:lnTo>
                     <a:pt x="0" y="0"/>
@@ -2993,15 +2993,15 @@
           </p:nvSpPr>
           <p:spPr>
             <a:xfrm>
-              <a:off x="3560572" y="2194823"/>
-              <a:ext cx="0" cy="33469"/>
+              <a:off x="3639890" y="2037210"/>
+              <a:ext cx="0" cy="39909"/>
             </a:xfrm>
             <a:custGeom>
               <a:avLst/>
               <a:pathLst>
-                <a:path w="0" h="33469">
+                <a:path w="0" h="39909">
                   <a:moveTo>
-                    <a:pt x="0" y="33469"/>
+                    <a:pt x="0" y="39909"/>
                   </a:moveTo>
                   <a:lnTo>
                     <a:pt x="0" y="0"/>
@@ -3033,15 +3033,15 @@
           </p:nvSpPr>
           <p:spPr>
             <a:xfrm>
-              <a:off x="2689067" y="2211558"/>
-              <a:ext cx="871504" cy="0"/>
+              <a:off x="2662935" y="2057164"/>
+              <a:ext cx="976954" cy="0"/>
             </a:xfrm>
             <a:custGeom>
               <a:avLst/>
               <a:pathLst>
-                <a:path w="871504" h="0">
+                <a:path w="976954" h="0">
                   <a:moveTo>
-                    <a:pt x="871504" y="0"/>
+                    <a:pt x="976954" y="0"/>
                   </a:moveTo>
                   <a:lnTo>
                     <a:pt x="0" y="0"/>
@@ -3073,15 +3073,15 @@
           </p:nvSpPr>
           <p:spPr>
             <a:xfrm>
-              <a:off x="2689067" y="2194823"/>
-              <a:ext cx="0" cy="33469"/>
+              <a:off x="2662935" y="2037210"/>
+              <a:ext cx="0" cy="39909"/>
             </a:xfrm>
             <a:custGeom>
               <a:avLst/>
               <a:pathLst>
-                <a:path w="0" h="33469">
+                <a:path w="0" h="39909">
                   <a:moveTo>
-                    <a:pt x="0" y="33469"/>
+                    <a:pt x="0" y="39909"/>
                   </a:moveTo>
                   <a:lnTo>
                     <a:pt x="0" y="0"/>
@@ -3113,15 +3113,15 @@
           </p:nvSpPr>
           <p:spPr>
             <a:xfrm>
-              <a:off x="3125959" y="2362172"/>
-              <a:ext cx="0" cy="33469"/>
+              <a:off x="3152690" y="2236756"/>
+              <a:ext cx="0" cy="39909"/>
             </a:xfrm>
             <a:custGeom>
               <a:avLst/>
               <a:pathLst>
-                <a:path w="0" h="33469">
+                <a:path w="0" h="39909">
                   <a:moveTo>
-                    <a:pt x="0" y="33469"/>
+                    <a:pt x="0" y="39909"/>
                   </a:moveTo>
                   <a:lnTo>
                     <a:pt x="0" y="0"/>
@@ -3153,15 +3153,15 @@
           </p:nvSpPr>
           <p:spPr>
             <a:xfrm>
-              <a:off x="2875849" y="2378907"/>
-              <a:ext cx="250110" cy="0"/>
+              <a:off x="2872317" y="2256711"/>
+              <a:ext cx="280372" cy="0"/>
             </a:xfrm>
             <a:custGeom>
               <a:avLst/>
               <a:pathLst>
-                <a:path w="250110" h="0">
+                <a:path w="280372" h="0">
                   <a:moveTo>
-                    <a:pt x="250110" y="0"/>
+                    <a:pt x="280372" y="0"/>
                   </a:moveTo>
                   <a:lnTo>
                     <a:pt x="0" y="0"/>
@@ -3193,15 +3193,15 @@
           </p:nvSpPr>
           <p:spPr>
             <a:xfrm>
-              <a:off x="2875849" y="2362172"/>
-              <a:ext cx="0" cy="33469"/>
+              <a:off x="2872317" y="2236756"/>
+              <a:ext cx="0" cy="39909"/>
             </a:xfrm>
             <a:custGeom>
               <a:avLst/>
               <a:pathLst>
-                <a:path w="0" h="33469">
+                <a:path w="0" h="39909">
                   <a:moveTo>
-                    <a:pt x="0" y="33469"/>
+                    <a:pt x="0" y="39909"/>
                   </a:moveTo>
                   <a:lnTo>
                     <a:pt x="0" y="0"/>
@@ -3233,15 +3233,15 @@
           </p:nvSpPr>
           <p:spPr>
             <a:xfrm>
-              <a:off x="3877185" y="2529522"/>
-              <a:ext cx="0" cy="33469"/>
+              <a:off x="3994812" y="2436302"/>
+              <a:ext cx="0" cy="39909"/>
             </a:xfrm>
             <a:custGeom>
               <a:avLst/>
               <a:pathLst>
-                <a:path w="0" h="33469">
+                <a:path w="0" h="39909">
                   <a:moveTo>
-                    <a:pt x="0" y="33469"/>
+                    <a:pt x="0" y="39909"/>
                   </a:moveTo>
                   <a:lnTo>
                     <a:pt x="0" y="0"/>
@@ -3273,15 +3273,15 @@
           </p:nvSpPr>
           <p:spPr>
             <a:xfrm>
-              <a:off x="3234537" y="2546257"/>
-              <a:ext cx="642647" cy="0"/>
+              <a:off x="3274406" y="2456257"/>
+              <a:ext cx="720406" cy="0"/>
             </a:xfrm>
             <a:custGeom>
               <a:avLst/>
               <a:pathLst>
-                <a:path w="642647" h="0">
+                <a:path w="720406" h="0">
                   <a:moveTo>
-                    <a:pt x="642647" y="0"/>
+                    <a:pt x="720406" y="0"/>
                   </a:moveTo>
                   <a:lnTo>
                     <a:pt x="0" y="0"/>
@@ -3313,15 +3313,15 @@
           </p:nvSpPr>
           <p:spPr>
             <a:xfrm>
-              <a:off x="3234537" y="2529522"/>
-              <a:ext cx="0" cy="33469"/>
+              <a:off x="3274406" y="2436302"/>
+              <a:ext cx="0" cy="39909"/>
             </a:xfrm>
             <a:custGeom>
               <a:avLst/>
               <a:pathLst>
-                <a:path w="0" h="33469">
+                <a:path w="0" h="39909">
                   <a:moveTo>
-                    <a:pt x="0" y="33469"/>
+                    <a:pt x="0" y="39909"/>
                   </a:moveTo>
                   <a:lnTo>
                     <a:pt x="0" y="0"/>
@@ -3353,15 +3353,15 @@
           </p:nvSpPr>
           <p:spPr>
             <a:xfrm>
-              <a:off x="3016061" y="2696872"/>
-              <a:ext cx="0" cy="33469"/>
+              <a:off x="3029494" y="2635849"/>
+              <a:ext cx="0" cy="39909"/>
             </a:xfrm>
             <a:custGeom>
               <a:avLst/>
               <a:pathLst>
-                <a:path w="0" h="33469">
+                <a:path w="0" h="39909">
                   <a:moveTo>
-                    <a:pt x="0" y="33469"/>
+                    <a:pt x="0" y="39909"/>
                   </a:moveTo>
                   <a:lnTo>
                     <a:pt x="0" y="0"/>
@@ -3393,15 +3393,15 @@
           </p:nvSpPr>
           <p:spPr>
             <a:xfrm>
-              <a:off x="2615540" y="2713607"/>
-              <a:ext cx="400521" cy="0"/>
+              <a:off x="2580511" y="2655803"/>
+              <a:ext cx="448983" cy="0"/>
             </a:xfrm>
             <a:custGeom>
               <a:avLst/>
               <a:pathLst>
-                <a:path w="400521" h="0">
+                <a:path w="448983" h="0">
                   <a:moveTo>
-                    <a:pt x="400521" y="0"/>
+                    <a:pt x="448983" y="0"/>
                   </a:moveTo>
                   <a:lnTo>
                     <a:pt x="0" y="0"/>
@@ -3433,15 +3433,15 @@
           </p:nvSpPr>
           <p:spPr>
             <a:xfrm>
-              <a:off x="2615540" y="2696872"/>
-              <a:ext cx="0" cy="33469"/>
+              <a:off x="2580511" y="2635849"/>
+              <a:ext cx="0" cy="39909"/>
             </a:xfrm>
             <a:custGeom>
               <a:avLst/>
               <a:pathLst>
-                <a:path w="0" h="33469">
+                <a:path w="0" h="39909">
                   <a:moveTo>
-                    <a:pt x="0" y="33469"/>
+                    <a:pt x="0" y="39909"/>
                   </a:moveTo>
                   <a:lnTo>
                     <a:pt x="0" y="0"/>
@@ -3473,15 +3473,15 @@
           </p:nvSpPr>
           <p:spPr>
             <a:xfrm>
-              <a:off x="2874936" y="2864221"/>
-              <a:ext cx="0" cy="33469"/>
+              <a:off x="2871293" y="2835395"/>
+              <a:ext cx="0" cy="39909"/>
             </a:xfrm>
             <a:custGeom>
               <a:avLst/>
               <a:pathLst>
-                <a:path w="0" h="33469">
+                <a:path w="0" h="39909">
                   <a:moveTo>
-                    <a:pt x="0" y="33469"/>
+                    <a:pt x="0" y="39909"/>
                   </a:moveTo>
                   <a:lnTo>
                     <a:pt x="0" y="0"/>
@@ -3513,15 +3513,15 @@
           </p:nvSpPr>
           <p:spPr>
             <a:xfrm>
-              <a:off x="2456154" y="2880956"/>
-              <a:ext cx="418782" cy="0"/>
+              <a:off x="2401840" y="2855350"/>
+              <a:ext cx="469453" cy="0"/>
             </a:xfrm>
             <a:custGeom>
               <a:avLst/>
               <a:pathLst>
-                <a:path w="418782" h="0">
+                <a:path w="469453" h="0">
                   <a:moveTo>
-                    <a:pt x="418782" y="0"/>
+                    <a:pt x="469453" y="0"/>
                   </a:moveTo>
                   <a:lnTo>
                     <a:pt x="0" y="0"/>
@@ -3553,15 +3553,15 @@
           </p:nvSpPr>
           <p:spPr>
             <a:xfrm>
-              <a:off x="2456154" y="2864221"/>
-              <a:ext cx="0" cy="33469"/>
+              <a:off x="2401840" y="2835395"/>
+              <a:ext cx="0" cy="39909"/>
             </a:xfrm>
             <a:custGeom>
               <a:avLst/>
               <a:pathLst>
-                <a:path w="0" h="33469">
+                <a:path w="0" h="39909">
                   <a:moveTo>
-                    <a:pt x="0" y="33469"/>
+                    <a:pt x="0" y="39909"/>
                   </a:moveTo>
                   <a:lnTo>
                     <a:pt x="0" y="0"/>
@@ -3593,15 +3593,15 @@
           </p:nvSpPr>
           <p:spPr>
             <a:xfrm>
-              <a:off x="3516903" y="3031571"/>
-              <a:ext cx="0" cy="33469"/>
+              <a:off x="3590937" y="3034941"/>
+              <a:ext cx="0" cy="39909"/>
             </a:xfrm>
             <a:custGeom>
               <a:avLst/>
               <a:pathLst>
-                <a:path w="0" h="33469">
+                <a:path w="0" h="39909">
                   <a:moveTo>
-                    <a:pt x="0" y="33469"/>
+                    <a:pt x="0" y="39909"/>
                   </a:moveTo>
                   <a:lnTo>
                     <a:pt x="0" y="0"/>
@@ -3633,15 +3633,15 @@
           </p:nvSpPr>
           <p:spPr>
             <a:xfrm>
-              <a:off x="3121453" y="3048306"/>
-              <a:ext cx="395450" cy="0"/>
+              <a:off x="3147638" y="3054896"/>
+              <a:ext cx="443298" cy="0"/>
             </a:xfrm>
             <a:custGeom>
               <a:avLst/>
               <a:pathLst>
-                <a:path w="395450" h="0">
+                <a:path w="443298" h="0">
                   <a:moveTo>
-                    <a:pt x="395450" y="0"/>
+                    <a:pt x="443298" y="0"/>
                   </a:moveTo>
                   <a:lnTo>
                     <a:pt x="0" y="0"/>
@@ -3673,15 +3673,15 @@
           </p:nvSpPr>
           <p:spPr>
             <a:xfrm>
-              <a:off x="3121453" y="3031571"/>
-              <a:ext cx="0" cy="33469"/>
+              <a:off x="3147638" y="3034941"/>
+              <a:ext cx="0" cy="39909"/>
             </a:xfrm>
             <a:custGeom>
               <a:avLst/>
               <a:pathLst>
-                <a:path w="0" h="33469">
+                <a:path w="0" h="39909">
                   <a:moveTo>
-                    <a:pt x="0" y="33469"/>
+                    <a:pt x="0" y="39909"/>
                   </a:moveTo>
                   <a:lnTo>
                     <a:pt x="0" y="0"/>
@@ -3713,15 +3713,15 @@
           </p:nvSpPr>
           <p:spPr>
             <a:xfrm>
-              <a:off x="3419268" y="3198921"/>
-              <a:ext cx="0" cy="33469"/>
+              <a:off x="3481488" y="3234488"/>
+              <a:ext cx="0" cy="39909"/>
             </a:xfrm>
             <a:custGeom>
               <a:avLst/>
               <a:pathLst>
-                <a:path w="0" h="33469">
+                <a:path w="0" h="39909">
                   <a:moveTo>
-                    <a:pt x="0" y="33469"/>
+                    <a:pt x="0" y="39909"/>
                   </a:moveTo>
                   <a:lnTo>
                     <a:pt x="0" y="0"/>
@@ -3753,15 +3753,15 @@
           </p:nvSpPr>
           <p:spPr>
             <a:xfrm>
-              <a:off x="2383261" y="3215656"/>
-              <a:ext cx="1036006" cy="0"/>
+              <a:off x="2320128" y="3254442"/>
+              <a:ext cx="1161360" cy="0"/>
             </a:xfrm>
             <a:custGeom>
               <a:avLst/>
               <a:pathLst>
-                <a:path w="1036006" h="0">
+                <a:path w="1161360" h="0">
                   <a:moveTo>
-                    <a:pt x="1036006" y="0"/>
+                    <a:pt x="1161360" y="0"/>
                   </a:moveTo>
                   <a:lnTo>
                     <a:pt x="0" y="0"/>
@@ -3793,15 +3793,15 @@
           </p:nvSpPr>
           <p:spPr>
             <a:xfrm>
-              <a:off x="2383261" y="3198921"/>
-              <a:ext cx="0" cy="33469"/>
+              <a:off x="2320128" y="3234488"/>
+              <a:ext cx="0" cy="39909"/>
             </a:xfrm>
             <a:custGeom>
               <a:avLst/>
               <a:pathLst>
-                <a:path w="0" h="33469">
+                <a:path w="0" h="39909">
                   <a:moveTo>
-                    <a:pt x="0" y="33469"/>
+                    <a:pt x="0" y="39909"/>
                   </a:moveTo>
                   <a:lnTo>
                     <a:pt x="0" y="0"/>
@@ -3833,15 +3833,15 @@
           </p:nvSpPr>
           <p:spPr>
             <a:xfrm>
-              <a:off x="3194836" y="3366270"/>
-              <a:ext cx="0" cy="33469"/>
+              <a:off x="3229900" y="3434034"/>
+              <a:ext cx="0" cy="39909"/>
             </a:xfrm>
             <a:custGeom>
               <a:avLst/>
               <a:pathLst>
-                <a:path w="0" h="33469">
+                <a:path w="0" h="39909">
                   <a:moveTo>
-                    <a:pt x="0" y="33469"/>
+                    <a:pt x="0" y="39909"/>
                   </a:moveTo>
                   <a:lnTo>
                     <a:pt x="0" y="0"/>
@@ -3873,15 +3873,15 @@
           </p:nvSpPr>
           <p:spPr>
             <a:xfrm>
-              <a:off x="2204799" y="3383005"/>
-              <a:ext cx="990036" cy="0"/>
+              <a:off x="2120072" y="3453989"/>
+              <a:ext cx="1109828" cy="0"/>
             </a:xfrm>
             <a:custGeom>
               <a:avLst/>
               <a:pathLst>
-                <a:path w="990036" h="0">
+                <a:path w="1109828" h="0">
                   <a:moveTo>
-                    <a:pt x="990036" y="0"/>
+                    <a:pt x="1109828" y="0"/>
                   </a:moveTo>
                   <a:lnTo>
                     <a:pt x="0" y="0"/>
@@ -3913,15 +3913,15 @@
           </p:nvSpPr>
           <p:spPr>
             <a:xfrm>
-              <a:off x="2204799" y="3366270"/>
-              <a:ext cx="0" cy="33469"/>
+              <a:off x="2120072" y="3434034"/>
+              <a:ext cx="0" cy="39909"/>
             </a:xfrm>
             <a:custGeom>
               <a:avLst/>
               <a:pathLst>
-                <a:path w="0" h="33469">
+                <a:path w="0" h="39909">
                   <a:moveTo>
-                    <a:pt x="0" y="33469"/>
+                    <a:pt x="0" y="39909"/>
                   </a:moveTo>
                   <a:lnTo>
                     <a:pt x="0" y="0"/>
@@ -3953,15 +3953,15 @@
           </p:nvSpPr>
           <p:spPr>
             <a:xfrm>
-              <a:off x="3354637" y="3533620"/>
-              <a:ext cx="0" cy="33469"/>
+              <a:off x="3409038" y="3633580"/>
+              <a:ext cx="0" cy="39909"/>
             </a:xfrm>
             <a:custGeom>
               <a:avLst/>
               <a:pathLst>
-                <a:path w="0" h="33469">
+                <a:path w="0" h="39909">
                   <a:moveTo>
-                    <a:pt x="0" y="33469"/>
+                    <a:pt x="0" y="39909"/>
                   </a:moveTo>
                   <a:lnTo>
                     <a:pt x="0" y="0"/>
@@ -3993,15 +3993,15 @@
           </p:nvSpPr>
           <p:spPr>
             <a:xfrm>
-              <a:off x="2284434" y="3550355"/>
-              <a:ext cx="1070203" cy="0"/>
+              <a:off x="2209342" y="3653535"/>
+              <a:ext cx="1199695" cy="0"/>
             </a:xfrm>
             <a:custGeom>
               <a:avLst/>
               <a:pathLst>
-                <a:path w="1070203" h="0">
+                <a:path w="1199695" h="0">
                   <a:moveTo>
-                    <a:pt x="1070203" y="0"/>
+                    <a:pt x="1199695" y="0"/>
                   </a:moveTo>
                   <a:lnTo>
                     <a:pt x="0" y="0"/>
@@ -4033,15 +4033,15 @@
           </p:nvSpPr>
           <p:spPr>
             <a:xfrm>
-              <a:off x="2284434" y="3533620"/>
-              <a:ext cx="0" cy="33469"/>
+              <a:off x="2209342" y="3633580"/>
+              <a:ext cx="0" cy="39909"/>
             </a:xfrm>
             <a:custGeom>
               <a:avLst/>
               <a:pathLst>
-                <a:path w="0" h="33469">
+                <a:path w="0" h="39909">
                   <a:moveTo>
-                    <a:pt x="0" y="33469"/>
+                    <a:pt x="0" y="39909"/>
                   </a:moveTo>
                   <a:lnTo>
                     <a:pt x="0" y="0"/>
@@ -4073,15 +4073,15 @@
           </p:nvSpPr>
           <p:spPr>
             <a:xfrm>
-              <a:off x="2744200" y="3700970"/>
-              <a:ext cx="0" cy="33469"/>
+              <a:off x="2724739" y="3833127"/>
+              <a:ext cx="0" cy="39909"/>
             </a:xfrm>
             <a:custGeom>
               <a:avLst/>
               <a:pathLst>
-                <a:path w="0" h="33469">
+                <a:path w="0" h="39909">
                   <a:moveTo>
-                    <a:pt x="0" y="33469"/>
+                    <a:pt x="0" y="39909"/>
                   </a:moveTo>
                   <a:lnTo>
                     <a:pt x="0" y="0"/>
@@ -4113,15 +4113,15 @@
           </p:nvSpPr>
           <p:spPr>
             <a:xfrm>
-              <a:off x="2342280" y="3717705"/>
-              <a:ext cx="401920" cy="0"/>
+              <a:off x="2274188" y="3853081"/>
+              <a:ext cx="450551" cy="0"/>
             </a:xfrm>
             <a:custGeom>
               <a:avLst/>
               <a:pathLst>
-                <a:path w="401920" h="0">
+                <a:path w="450551" h="0">
                   <a:moveTo>
-                    <a:pt x="401920" y="0"/>
+                    <a:pt x="450551" y="0"/>
                   </a:moveTo>
                   <a:lnTo>
                     <a:pt x="0" y="0"/>
@@ -4153,15 +4153,15 @@
           </p:nvSpPr>
           <p:spPr>
             <a:xfrm>
-              <a:off x="2342280" y="3700970"/>
-              <a:ext cx="0" cy="33469"/>
+              <a:off x="2274188" y="3833127"/>
+              <a:ext cx="0" cy="39909"/>
             </a:xfrm>
             <a:custGeom>
               <a:avLst/>
               <a:pathLst>
-                <a:path w="0" h="33469">
+                <a:path w="0" h="39909">
                   <a:moveTo>
-                    <a:pt x="0" y="33469"/>
+                    <a:pt x="0" y="39909"/>
                   </a:moveTo>
                   <a:lnTo>
                     <a:pt x="0" y="0"/>
@@ -4193,7 +4193,7 @@
           </p:nvSpPr>
           <p:spPr>
             <a:xfrm>
-              <a:off x="2657747" y="1323357"/>
+              <a:off x="2634051" y="1007981"/>
               <a:ext cx="102903" cy="102903"/>
             </a:xfrm>
             <a:prstGeom prst="ellipse">
@@ -4228,7 +4228,7 @@
           </p:nvSpPr>
           <p:spPr>
             <a:xfrm>
-              <a:off x="3362194" y="1490707"/>
+              <a:off x="3423734" y="1207527"/>
               <a:ext cx="102903" cy="102903"/>
             </a:xfrm>
             <a:prstGeom prst="ellipse">
@@ -4263,7 +4263,7 @@
           </p:nvSpPr>
           <p:spPr>
             <a:xfrm>
-              <a:off x="3432595" y="1658057"/>
+              <a:off x="3502654" y="1407073"/>
               <a:ext cx="102903" cy="102903"/>
             </a:xfrm>
             <a:prstGeom prst="ellipse">
@@ -4298,7 +4298,7 @@
           </p:nvSpPr>
           <p:spPr>
             <a:xfrm>
-              <a:off x="2657917" y="1825406"/>
+              <a:off x="2634241" y="1606620"/>
               <a:ext cx="102903" cy="102903"/>
             </a:xfrm>
             <a:prstGeom prst="ellipse">
@@ -4333,7 +4333,7 @@
           </p:nvSpPr>
           <p:spPr>
             <a:xfrm>
-              <a:off x="2236829" y="1992756"/>
+              <a:off x="2162203" y="1806166"/>
               <a:ext cx="102903" cy="102903"/>
             </a:xfrm>
             <a:prstGeom prst="ellipse">
@@ -4368,7 +4368,7 @@
           </p:nvSpPr>
           <p:spPr>
             <a:xfrm>
-              <a:off x="3073368" y="2160106"/>
+              <a:off x="3099960" y="2005712"/>
               <a:ext cx="102903" cy="102903"/>
             </a:xfrm>
             <a:prstGeom prst="ellipse">
@@ -4403,7 +4403,7 @@
           </p:nvSpPr>
           <p:spPr>
             <a:xfrm>
-              <a:off x="2949452" y="2327455"/>
+              <a:off x="2961051" y="2205259"/>
               <a:ext cx="102903" cy="102903"/>
             </a:xfrm>
             <a:prstGeom prst="ellipse">
@@ -4438,7 +4438,7 @@
           </p:nvSpPr>
           <p:spPr>
             <a:xfrm>
-              <a:off x="3504409" y="2494805"/>
+              <a:off x="3583157" y="2404805"/>
               <a:ext cx="102903" cy="102903"/>
             </a:xfrm>
             <a:prstGeom prst="ellipse">
@@ -4473,7 +4473,7 @@
           </p:nvSpPr>
           <p:spPr>
             <a:xfrm>
-              <a:off x="2764348" y="2662155"/>
+              <a:off x="2753551" y="2604351"/>
               <a:ext cx="102903" cy="102903"/>
             </a:xfrm>
             <a:prstGeom prst="ellipse">
@@ -4508,7 +4508,7 @@
           </p:nvSpPr>
           <p:spPr>
             <a:xfrm>
-              <a:off x="2614093" y="2829504"/>
+              <a:off x="2585115" y="2803898"/>
               <a:ext cx="102903" cy="102903"/>
             </a:xfrm>
             <a:prstGeom prst="ellipse">
@@ -4543,7 +4543,7 @@
           </p:nvSpPr>
           <p:spPr>
             <a:xfrm>
-              <a:off x="3267726" y="2996854"/>
+              <a:off x="3317836" y="3003444"/>
               <a:ext cx="102903" cy="102903"/>
             </a:xfrm>
             <a:prstGeom prst="ellipse">
@@ -4578,7 +4578,7 @@
           </p:nvSpPr>
           <p:spPr>
             <a:xfrm>
-              <a:off x="2849813" y="3164204"/>
+              <a:off x="2849356" y="3202990"/>
               <a:ext cx="102903" cy="102903"/>
             </a:xfrm>
             <a:prstGeom prst="ellipse">
@@ -4613,7 +4613,7 @@
           </p:nvSpPr>
           <p:spPr>
             <a:xfrm>
-              <a:off x="2648366" y="3331553"/>
+              <a:off x="2623534" y="3402537"/>
               <a:ext cx="102903" cy="102903"/>
             </a:xfrm>
             <a:prstGeom prst="ellipse">
@@ -4648,7 +4648,7 @@
           </p:nvSpPr>
           <p:spPr>
             <a:xfrm>
-              <a:off x="2768084" y="3498903"/>
+              <a:off x="2757738" y="3602083"/>
               <a:ext cx="102903" cy="102903"/>
             </a:xfrm>
             <a:prstGeom prst="ellipse">
@@ -4683,7 +4683,7 @@
           </p:nvSpPr>
           <p:spPr>
             <a:xfrm>
-              <a:off x="2491788" y="3666253"/>
+              <a:off x="2448011" y="3801630"/>
               <a:ext cx="102903" cy="102903"/>
             </a:xfrm>
             <a:prstGeom prst="ellipse">
@@ -4718,8 +4718,8 @@
           </p:nvSpPr>
           <p:spPr>
             <a:xfrm>
-              <a:off x="1835679" y="1274399"/>
-              <a:ext cx="2138720" cy="2543714"/>
+              <a:off x="1706289" y="939705"/>
+              <a:ext cx="2397500" cy="3033104"/>
             </a:xfrm>
             <a:prstGeom prst="rect">
               <a:avLst/>
@@ -4739,15 +4739,15 @@
           </p:nvSpPr>
           <p:spPr>
             <a:xfrm>
-              <a:off x="1835679" y="1274399"/>
-              <a:ext cx="0" cy="2543714"/>
+              <a:off x="1706289" y="939705"/>
+              <a:ext cx="0" cy="3033104"/>
             </a:xfrm>
             <a:custGeom>
               <a:avLst/>
               <a:pathLst>
-                <a:path w="0" h="2543714">
+                <a:path w="0" h="3033104">
                   <a:moveTo>
-                    <a:pt x="0" y="2543714"/>
+                    <a:pt x="0" y="3033104"/>
                   </a:moveTo>
                   <a:lnTo>
                     <a:pt x="0" y="0"/>
@@ -4779,7 +4779,7 @@
           </p:nvSpPr>
           <p:spPr>
             <a:xfrm>
-              <a:off x="1253627" y="3681266"/>
+              <a:off x="1124237" y="3816643"/>
               <a:ext cx="530809" cy="72877"/>
             </a:xfrm>
             <a:prstGeom prst="rect">
@@ -4825,7 +4825,7 @@
           </p:nvSpPr>
           <p:spPr>
             <a:xfrm>
-              <a:off x="1253627" y="3513916"/>
+              <a:off x="1124237" y="3617096"/>
               <a:ext cx="530809" cy="72877"/>
             </a:xfrm>
             <a:prstGeom prst="rect">
@@ -4871,7 +4871,7 @@
           </p:nvSpPr>
           <p:spPr>
             <a:xfrm>
-              <a:off x="1575587" y="3346566"/>
+              <a:off x="1446197" y="3417550"/>
               <a:ext cx="208848" cy="72877"/>
             </a:xfrm>
             <a:prstGeom prst="rect">
@@ -4917,7 +4917,7 @@
           </p:nvSpPr>
           <p:spPr>
             <a:xfrm>
-              <a:off x="1575679" y="3179217"/>
+              <a:off x="1446289" y="3218003"/>
               <a:ext cx="208757" cy="72877"/>
             </a:xfrm>
             <a:prstGeom prst="rect">
@@ -4963,7 +4963,7 @@
           </p:nvSpPr>
           <p:spPr>
             <a:xfrm>
-              <a:off x="1637766" y="3011867"/>
+              <a:off x="1508377" y="3018457"/>
               <a:ext cx="146669" cy="72877"/>
             </a:xfrm>
             <a:prstGeom prst="rect">
@@ -5009,7 +5009,7 @@
           </p:nvSpPr>
           <p:spPr>
             <a:xfrm>
-              <a:off x="1586834" y="2844517"/>
+              <a:off x="1457445" y="2818911"/>
               <a:ext cx="197601" cy="72877"/>
             </a:xfrm>
             <a:prstGeom prst="rect">
@@ -5055,7 +5055,7 @@
           </p:nvSpPr>
           <p:spPr>
             <a:xfrm>
-              <a:off x="1242197" y="2677168"/>
+              <a:off x="1112807" y="2619364"/>
               <a:ext cx="542239" cy="72877"/>
             </a:xfrm>
             <a:prstGeom prst="rect">
@@ -5101,7 +5101,7 @@
           </p:nvSpPr>
           <p:spPr>
             <a:xfrm>
-              <a:off x="1242197" y="2509818"/>
+              <a:off x="1112807" y="2419818"/>
               <a:ext cx="542239" cy="72877"/>
             </a:xfrm>
             <a:prstGeom prst="rect">
@@ -5147,7 +5147,7 @@
           </p:nvSpPr>
           <p:spPr>
             <a:xfrm>
-              <a:off x="1490731" y="2342468"/>
+              <a:off x="1361341" y="2220272"/>
               <a:ext cx="293705" cy="72877"/>
             </a:xfrm>
             <a:prstGeom prst="rect">
@@ -5193,7 +5193,7 @@
           </p:nvSpPr>
           <p:spPr>
             <a:xfrm>
-              <a:off x="1632006" y="2175119"/>
+              <a:off x="1502616" y="2020725"/>
               <a:ext cx="152430" cy="72877"/>
             </a:xfrm>
             <a:prstGeom prst="rect">
@@ -5239,7 +5239,7 @@
           </p:nvSpPr>
           <p:spPr>
             <a:xfrm>
-              <a:off x="1575587" y="2007769"/>
+              <a:off x="1446197" y="1821179"/>
               <a:ext cx="208848" cy="72877"/>
             </a:xfrm>
             <a:prstGeom prst="rect">
@@ -5285,7 +5285,7 @@
           </p:nvSpPr>
           <p:spPr>
             <a:xfrm>
-              <a:off x="1496583" y="1840419"/>
+              <a:off x="1367193" y="1621633"/>
               <a:ext cx="287853" cy="72877"/>
             </a:xfrm>
             <a:prstGeom prst="rect">
@@ -5331,7 +5331,7 @@
           </p:nvSpPr>
           <p:spPr>
             <a:xfrm>
-              <a:off x="1592412" y="1673070"/>
+              <a:off x="1463022" y="1422086"/>
               <a:ext cx="192024" cy="72877"/>
             </a:xfrm>
             <a:prstGeom prst="rect">
@@ -5377,7 +5377,7 @@
           </p:nvSpPr>
           <p:spPr>
             <a:xfrm>
-              <a:off x="1575496" y="1505720"/>
+              <a:off x="1446106" y="1222540"/>
               <a:ext cx="208940" cy="72877"/>
             </a:xfrm>
             <a:prstGeom prst="rect">
@@ -5423,7 +5423,7 @@
           </p:nvSpPr>
           <p:spPr>
             <a:xfrm>
-              <a:off x="1586834" y="1338370"/>
+              <a:off x="1457445" y="1022994"/>
               <a:ext cx="197601" cy="72877"/>
             </a:xfrm>
             <a:prstGeom prst="rect">
@@ -5469,7 +5469,7 @@
           </p:nvSpPr>
           <p:spPr>
             <a:xfrm>
-              <a:off x="1807211" y="3717705"/>
+              <a:off x="1677821" y="3853081"/>
               <a:ext cx="28468" cy="0"/>
             </a:xfrm>
             <a:custGeom>
@@ -5509,7 +5509,7 @@
           </p:nvSpPr>
           <p:spPr>
             <a:xfrm>
-              <a:off x="1807211" y="3550355"/>
+              <a:off x="1677821" y="3653535"/>
               <a:ext cx="28468" cy="0"/>
             </a:xfrm>
             <a:custGeom>
@@ -5549,7 +5549,7 @@
           </p:nvSpPr>
           <p:spPr>
             <a:xfrm>
-              <a:off x="1807211" y="3383005"/>
+              <a:off x="1677821" y="3453989"/>
               <a:ext cx="28468" cy="0"/>
             </a:xfrm>
             <a:custGeom>
@@ -5589,7 +5589,7 @@
           </p:nvSpPr>
           <p:spPr>
             <a:xfrm>
-              <a:off x="1807211" y="3215656"/>
+              <a:off x="1677821" y="3254442"/>
               <a:ext cx="28468" cy="0"/>
             </a:xfrm>
             <a:custGeom>
@@ -5629,7 +5629,7 @@
           </p:nvSpPr>
           <p:spPr>
             <a:xfrm>
-              <a:off x="1807211" y="3048306"/>
+              <a:off x="1677821" y="3054896"/>
               <a:ext cx="28468" cy="0"/>
             </a:xfrm>
             <a:custGeom>
@@ -5669,7 +5669,7 @@
           </p:nvSpPr>
           <p:spPr>
             <a:xfrm>
-              <a:off x="1807211" y="2880956"/>
+              <a:off x="1677821" y="2855350"/>
               <a:ext cx="28468" cy="0"/>
             </a:xfrm>
             <a:custGeom>
@@ -5709,7 +5709,7 @@
           </p:nvSpPr>
           <p:spPr>
             <a:xfrm>
-              <a:off x="1807211" y="2713607"/>
+              <a:off x="1677821" y="2655803"/>
               <a:ext cx="28468" cy="0"/>
             </a:xfrm>
             <a:custGeom>
@@ -5749,7 +5749,7 @@
           </p:nvSpPr>
           <p:spPr>
             <a:xfrm>
-              <a:off x="1807211" y="2546257"/>
+              <a:off x="1677821" y="2456257"/>
               <a:ext cx="28468" cy="0"/>
             </a:xfrm>
             <a:custGeom>
@@ -5789,7 +5789,7 @@
           </p:nvSpPr>
           <p:spPr>
             <a:xfrm>
-              <a:off x="1807211" y="2378907"/>
+              <a:off x="1677821" y="2256711"/>
               <a:ext cx="28468" cy="0"/>
             </a:xfrm>
             <a:custGeom>
@@ -5829,7 +5829,7 @@
           </p:nvSpPr>
           <p:spPr>
             <a:xfrm>
-              <a:off x="1807211" y="2211558"/>
+              <a:off x="1677821" y="2057164"/>
               <a:ext cx="28468" cy="0"/>
             </a:xfrm>
             <a:custGeom>
@@ -5869,7 +5869,7 @@
           </p:nvSpPr>
           <p:spPr>
             <a:xfrm>
-              <a:off x="1807211" y="2044208"/>
+              <a:off x="1677821" y="1857618"/>
               <a:ext cx="28468" cy="0"/>
             </a:xfrm>
             <a:custGeom>
@@ -5909,7 +5909,7 @@
           </p:nvSpPr>
           <p:spPr>
             <a:xfrm>
-              <a:off x="1807211" y="1876858"/>
+              <a:off x="1677821" y="1658071"/>
               <a:ext cx="28468" cy="0"/>
             </a:xfrm>
             <a:custGeom>
@@ -5949,7 +5949,7 @@
           </p:nvSpPr>
           <p:spPr>
             <a:xfrm>
-              <a:off x="1807211" y="1709509"/>
+              <a:off x="1677821" y="1458525"/>
               <a:ext cx="28468" cy="0"/>
             </a:xfrm>
             <a:custGeom>
@@ -5989,7 +5989,7 @@
           </p:nvSpPr>
           <p:spPr>
             <a:xfrm>
-              <a:off x="1807211" y="1542159"/>
+              <a:off x="1677821" y="1258979"/>
               <a:ext cx="28468" cy="0"/>
             </a:xfrm>
             <a:custGeom>
@@ -6029,7 +6029,7 @@
           </p:nvSpPr>
           <p:spPr>
             <a:xfrm>
-              <a:off x="1807211" y="1374809"/>
+              <a:off x="1677821" y="1059432"/>
               <a:ext cx="28468" cy="0"/>
             </a:xfrm>
             <a:custGeom>
@@ -6069,18 +6069,18 @@
           </p:nvSpPr>
           <p:spPr>
             <a:xfrm>
-              <a:off x="1835679" y="3818114"/>
-              <a:ext cx="2138720" cy="0"/>
+              <a:off x="1706289" y="3972809"/>
+              <a:ext cx="2397500" cy="0"/>
             </a:xfrm>
             <a:custGeom>
               <a:avLst/>
               <a:pathLst>
-                <a:path w="2138720" h="0">
+                <a:path w="2397500" h="0">
                   <a:moveTo>
                     <a:pt x="0" y="0"/>
                   </a:moveTo>
                   <a:lnTo>
-                    <a:pt x="2138720" y="0"/>
+                    <a:pt x="2397500" y="0"/>
                   </a:lnTo>
                 </a:path>
               </a:pathLst>
@@ -6109,7 +6109,7 @@
           </p:nvSpPr>
           <p:spPr>
             <a:xfrm>
-              <a:off x="1953555" y="3818114"/>
+              <a:off x="1838428" y="3972809"/>
               <a:ext cx="0" cy="28468"/>
             </a:xfrm>
             <a:custGeom>
@@ -6149,7 +6149,7 @@
           </p:nvSpPr>
           <p:spPr>
             <a:xfrm>
-              <a:off x="2440352" y="3818114"/>
+              <a:off x="2384126" y="3972809"/>
               <a:ext cx="0" cy="28468"/>
             </a:xfrm>
             <a:custGeom>
@@ -6189,7 +6189,7 @@
           </p:nvSpPr>
           <p:spPr>
             <a:xfrm>
-              <a:off x="2927150" y="3818114"/>
+              <a:off x="2929825" y="3972809"/>
               <a:ext cx="0" cy="28468"/>
             </a:xfrm>
             <a:custGeom>
@@ -6229,7 +6229,7 @@
           </p:nvSpPr>
           <p:spPr>
             <a:xfrm>
-              <a:off x="3413947" y="3818114"/>
+              <a:off x="3475523" y="3972809"/>
               <a:ext cx="0" cy="28468"/>
             </a:xfrm>
             <a:custGeom>
@@ -6269,7 +6269,7 @@
           </p:nvSpPr>
           <p:spPr>
             <a:xfrm>
-              <a:off x="3900744" y="3818114"/>
+              <a:off x="4021222" y="3972809"/>
               <a:ext cx="0" cy="28468"/>
             </a:xfrm>
             <a:custGeom>
@@ -6309,7 +6309,7 @@
           </p:nvSpPr>
           <p:spPr>
             <a:xfrm>
-              <a:off x="1837746" y="3869357"/>
+              <a:off x="1722619" y="4024052"/>
               <a:ext cx="231617" cy="72877"/>
             </a:xfrm>
             <a:prstGeom prst="rect">
@@ -6355,7 +6355,7 @@
           </p:nvSpPr>
           <p:spPr>
             <a:xfrm>
-              <a:off x="2324543" y="3869357"/>
+              <a:off x="2268317" y="4024052"/>
               <a:ext cx="231617" cy="72877"/>
             </a:xfrm>
             <a:prstGeom prst="rect">
@@ -6401,7 +6401,7 @@
           </p:nvSpPr>
           <p:spPr>
             <a:xfrm>
-              <a:off x="2828257" y="3869357"/>
+              <a:off x="2830932" y="4024052"/>
               <a:ext cx="197784" cy="72877"/>
             </a:xfrm>
             <a:prstGeom prst="rect">
@@ -6447,7 +6447,7 @@
           </p:nvSpPr>
           <p:spPr>
             <a:xfrm>
-              <a:off x="3315055" y="3869357"/>
+              <a:off x="3376631" y="4024052"/>
               <a:ext cx="197784" cy="72877"/>
             </a:xfrm>
             <a:prstGeom prst="rect">
@@ -6493,7 +6493,7 @@
           </p:nvSpPr>
           <p:spPr>
             <a:xfrm>
-              <a:off x="3801852" y="3869357"/>
+              <a:off x="3922330" y="4024052"/>
               <a:ext cx="197784" cy="72877"/>
             </a:xfrm>
             <a:prstGeom prst="rect">
@@ -6539,7 +6539,7 @@
           </p:nvSpPr>
           <p:spPr>
             <a:xfrm>
-              <a:off x="1927683" y="4026994"/>
+              <a:off x="1927683" y="4181688"/>
               <a:ext cx="1954712" cy="91165"/>
             </a:xfrm>
             <a:prstGeom prst="rect">
@@ -6585,7 +6585,7 @@
           </p:nvSpPr>
           <p:spPr>
             <a:xfrm rot="-5400000">
-              <a:off x="984809" y="2500674"/>
+              <a:off x="855419" y="2410674"/>
               <a:ext cx="254020" cy="91165"/>
             </a:xfrm>
             <a:prstGeom prst="rect">
@@ -6631,7 +6631,7 @@
           </p:nvSpPr>
           <p:spPr>
             <a:xfrm>
-              <a:off x="1799262" y="4226400"/>
+              <a:off x="1799262" y="4381094"/>
               <a:ext cx="2211555" cy="107999"/>
             </a:xfrm>
             <a:prstGeom prst="rect">
@@ -6657,7 +6657,7 @@
           </p:nvSpPr>
           <p:spPr>
             <a:xfrm>
-              <a:off x="1799262" y="4239389"/>
+              <a:off x="1799262" y="4394084"/>
               <a:ext cx="692200" cy="82021"/>
             </a:xfrm>
             <a:prstGeom prst="rect">
@@ -6703,7 +6703,7 @@
           </p:nvSpPr>
           <p:spPr>
             <a:xfrm>
-              <a:off x="2548399" y="4226400"/>
+              <a:off x="2548399" y="4381094"/>
               <a:ext cx="107999" cy="107999"/>
             </a:xfrm>
             <a:prstGeom prst="rect">
@@ -6729,7 +6729,7 @@
           </p:nvSpPr>
           <p:spPr>
             <a:xfrm>
-              <a:off x="2559199" y="4280400"/>
+              <a:off x="2559199" y="4435094"/>
               <a:ext cx="86400" cy="0"/>
             </a:xfrm>
             <a:custGeom>
@@ -6769,7 +6769,7 @@
           </p:nvSpPr>
           <p:spPr>
             <a:xfrm>
-              <a:off x="2550947" y="4228948"/>
+              <a:off x="2550947" y="4383643"/>
               <a:ext cx="102903" cy="102903"/>
             </a:xfrm>
             <a:prstGeom prst="ellipse">
@@ -6799,7 +6799,7 @@
           </p:nvSpPr>
           <p:spPr>
             <a:xfrm>
-              <a:off x="3313151" y="4226400"/>
+              <a:off x="3313151" y="4381094"/>
               <a:ext cx="107999" cy="107999"/>
             </a:xfrm>
             <a:prstGeom prst="rect">
@@ -6825,7 +6825,7 @@
           </p:nvSpPr>
           <p:spPr>
             <a:xfrm>
-              <a:off x="3323951" y="4280400"/>
+              <a:off x="3323951" y="4435094"/>
               <a:ext cx="86399" cy="0"/>
             </a:xfrm>
             <a:custGeom>
@@ -6865,7 +6865,7 @@
           </p:nvSpPr>
           <p:spPr>
             <a:xfrm>
-              <a:off x="3315699" y="4228948"/>
+              <a:off x="3315699" y="4383643"/>
               <a:ext cx="102903" cy="102903"/>
             </a:xfrm>
             <a:prstGeom prst="ellipse">
@@ -6895,7 +6895,7 @@
           </p:nvSpPr>
           <p:spPr>
             <a:xfrm>
-              <a:off x="2713335" y="4247618"/>
+              <a:off x="2713335" y="4402313"/>
               <a:ext cx="542879" cy="65562"/>
             </a:xfrm>
             <a:prstGeom prst="rect">
@@ -6941,7 +6941,7 @@
           </p:nvSpPr>
           <p:spPr>
             <a:xfrm>
-              <a:off x="3478088" y="4247618"/>
+              <a:off x="3478088" y="4402313"/>
               <a:ext cx="532729" cy="65562"/>
             </a:xfrm>
             <a:prstGeom prst="rect">

</xml_diff>